<commit_message>
Rebuild the Day 2 deck for the current build; fold in second-transform calibration
Slide 2: live mic (20s enrol, in-browser, upload fallback) + the transaction
object that terminates the call. Slide 3: two signals (replay + stdlib
forensics), the n=27 two-family calibration with its honest caveat, and the
second transfer check drawn from the real fresh scores (0.049 / 0.999 → hold).
Slide 4: the corrected $66M chain, precision-at-prevalence 52%, $0.87 per
caught fraud, measured latency. Slide 5: structural channel-conflict answer,
enrolment runbook, pilot, and the verified/open/future-work triage.

🤖 Generated with Codebuff
Co-Authored-By: Codebuff <noreply@codebuff.com>
</commit_message>
<xml_diff>
--- a/UNCLONE-day2-deck.pptx
+++ b/UNCLONE-day2-deck.pptx
@@ -3277,7 +3277,7 @@
                 </a:solidFill>
                 <a:latin typeface="Segoe UI"/>
               </a:rPr>
-              <a:t>Judge link: https://unclone-verified-agent.onrender.com   ·   demo: genuine → PROCEEDS · hijack → HELD · subtle hijack → HELD · silent → STEP UP</a:t>
+              <a:t>Judge link: https://unclone-verified-agent.onrender.com   ·   in-product docs: Impact · Calibration · Scale &amp; Viability pages</a:t>
             </a:r>
           </a:p>
         </p:txBody>
@@ -3368,7 +3368,7 @@
                 </a:solidFill>
                 <a:latin typeface="Segoe UI"/>
               </a:rPr>
-              <a:t>the “bank agent” is an imposter — a live-cloned voice that sounds exactly like the real assistant, walking the customer into approving the payment or reading an OTP.</a:t>
+              <a:t>the “bank agent” is an imposter — a cloned voice that sounds exactly like the real assistant, walking the customer into approving the payment or reading an OTP.</a:t>
             </a:r>
           </a:p>
           <a:p>
@@ -3384,7 +3384,7 @@
                 </a:solidFill>
                 <a:latin typeface="Segoe UI"/>
               </a:rPr>
-              <a:t>Why today's process fails: </a:t>
+              <a:t>Why today's process fails, control by control: </a:t>
             </a:r>
             <a:r>
               <a:rPr sz="1500" b="0">
@@ -3393,7 +3393,7 @@
                 </a:solidFill>
                 <a:latin typeface="Segoe UI"/>
               </a:rPr>
-              <a:t>caller ID is spoofable, and “the bank never asks for X” collapses when the caller </a:t>
+              <a:t>caller ID is </a:t>
             </a:r>
             <a:r>
               <a:rPr sz="1500" b="1">
@@ -3402,7 +3402,7 @@
                 </a:solidFill>
                 <a:latin typeface="Segoe UI"/>
               </a:rPr>
-              <a:t>sounds</a:t>
+              <a:t>spoofable</a:t>
             </a:r>
             <a:r>
               <a:rPr sz="1500" b="0">
@@ -3411,7 +3411,43 @@
                 </a:solidFill>
                 <a:latin typeface="Segoe UI"/>
               </a:rPr>
-              <a:t> like the bank. The customer has </a:t>
+              <a:t>; KYC questions </a:t>
+            </a:r>
+            <a:r>
+              <a:rPr sz="1500" b="1">
+                <a:solidFill>
+                  <a:srgbClr val="0F1B2D"/>
+                </a:solidFill>
+                <a:latin typeface="Segoe UI"/>
+              </a:rPr>
+              <a:t>leak</a:t>
+            </a:r>
+            <a:r>
+              <a:rPr sz="1500" b="0">
+                <a:solidFill>
+                  <a:srgbClr val="33415C"/>
+                </a:solidFill>
+                <a:latin typeface="Segoe UI"/>
+              </a:rPr>
+              <a:t> to the caller; “we never ask for X” </a:t>
+            </a:r>
+            <a:r>
+              <a:rPr sz="1500" b="1">
+                <a:solidFill>
+                  <a:srgbClr val="0F1B2D"/>
+                </a:solidFill>
+                <a:latin typeface="Segoe UI"/>
+              </a:rPr>
+              <a:t>collapses</a:t>
+            </a:r>
+            <a:r>
+              <a:rPr sz="1500" b="0">
+                <a:solidFill>
+                  <a:srgbClr val="33415C"/>
+                </a:solidFill>
+                <a:latin typeface="Segoe UI"/>
+              </a:rPr>
+              <a:t> when the caller sounds like the bank. The customer has </a:t>
             </a:r>
             <a:r>
               <a:rPr sz="1500" b="1">
@@ -3445,6 +3481,85 @@
                 </a:solidFill>
                 <a:latin typeface="Segoe UI"/>
               </a:rPr>
+              <a:t>Evidence: </a:t>
+            </a:r>
+            <a:r>
+              <a:rPr sz="1500" b="0">
+                <a:solidFill>
+                  <a:srgbClr val="33415C"/>
+                </a:solidFill>
+                <a:latin typeface="Segoe UI"/>
+              </a:rPr>
+              <a:t>FTC 2024: </a:t>
+            </a:r>
+            <a:r>
+              <a:rPr sz="1500" b="1">
+                <a:solidFill>
+                  <a:srgbClr val="0F1B2D"/>
+                </a:solidFill>
+                <a:latin typeface="Segoe UI"/>
+              </a:rPr>
+              <a:t>$1.25 B</a:t>
+            </a:r>
+            <a:r>
+              <a:rPr sz="1500" b="0">
+                <a:solidFill>
+                  <a:srgbClr val="33415C"/>
+                </a:solidFill>
+                <a:latin typeface="Segoe UI"/>
+              </a:rPr>
+              <a:t> reported fraud losses; UK APP ≈ </a:t>
+            </a:r>
+            <a:r>
+              <a:rPr sz="1500" b="1">
+                <a:solidFill>
+                  <a:srgbClr val="0F1B2D"/>
+                </a:solidFill>
+                <a:latin typeface="Segoe UI"/>
+              </a:rPr>
+              <a:t>£149 M</a:t>
+            </a:r>
+            <a:r>
+              <a:rPr sz="1500" b="0">
+                <a:solidFill>
+                  <a:srgbClr val="33415C"/>
+                </a:solidFill>
+                <a:latin typeface="Segoe UI"/>
+              </a:rPr>
+              <a:t> with voice cloning rising; ≈ </a:t>
+            </a:r>
+            <a:r>
+              <a:rPr sz="1500" b="1">
+                <a:solidFill>
+                  <a:srgbClr val="0F1B2D"/>
+                </a:solidFill>
+                <a:latin typeface="Segoe UI"/>
+              </a:rPr>
+              <a:t>$5,700</a:t>
+            </a:r>
+            <a:r>
+              <a:rPr sz="1500" b="0">
+                <a:solidFill>
+                  <a:srgbClr val="33415C"/>
+                </a:solidFill>
+                <a:latin typeface="Segoe UI"/>
+              </a:rPr>
+              <a:t> median loss per incident.</a:t>
+            </a:r>
+          </a:p>
+          <a:p>
+            <a:pPr>
+              <a:spcAft>
+                <a:spcPts val="1000"/>
+              </a:spcAft>
+            </a:pPr>
+            <a:r>
+              <a:rPr sz="1500" b="1">
+                <a:solidFill>
+                  <a:srgbClr val="0F1B2D"/>
+                </a:solidFill>
+                <a:latin typeface="Segoe UI"/>
+              </a:rPr>
               <a:t>Unchanged from registration (rule 3.7): </a:t>
             </a:r>
             <a:r>
@@ -3454,59 +3569,7 @@
                 </a:solidFill>
                 <a:latin typeface="Segoe UI"/>
               </a:rPr>
-              <a:t>same user, same problem. Day 2 deepens the product; it does not move the goalposts.</a:t>
-            </a:r>
-          </a:p>
-        </p:txBody>
-      </p:sp>
-      <p:sp>
-        <p:nvSpPr>
-          <p:cNvPr id="8" name="TextBox 7"/>
-          <p:cNvSpPr txBox="1"/>
-          <p:nvPr/>
-        </p:nvSpPr>
-        <p:spPr>
-          <a:xfrm>
-            <a:off x="640080" y="4892040"/>
-            <a:ext cx="10972800" cy="822960"/>
-          </a:xfrm>
-          <a:prstGeom prst="rect">
-            <a:avLst/>
-          </a:prstGeom>
-          <a:noFill/>
-        </p:spPr>
-        <p:txBody>
-          <a:bodyPr wrap="square">
-            <a:spAutoFit/>
-          </a:bodyPr>
-          <a:lstStyle/>
-          <a:p>
-            <a:r>
-              <a:rPr sz="1300" b="0">
-                <a:solidFill>
-                  <a:srgbClr val="33415C"/>
-                </a:solidFill>
-                <a:latin typeface="Segoe UI"/>
-              </a:rPr>
-              <a:t>Day 1 judge feedback: “good problem statement” — then: </a:t>
-            </a:r>
-            <a:r>
-              <a:rPr sz="1300" b="1">
-                <a:solidFill>
-                  <a:srgbClr val="0F1B2D"/>
-                </a:solidFill>
-                <a:latin typeface="Segoe UI"/>
-              </a:rPr>
-              <a:t>how will you get the dataset to train?</a:t>
-            </a:r>
-            <a:r>
-              <a:rPr sz="1300" b="0">
-                <a:solidFill>
-                  <a:srgbClr val="33415C"/>
-                </a:solidFill>
-                <a:latin typeface="Segoe UI"/>
-              </a:rPr>
-              <a:t> Slide 5 answers it with the product, not with a data project.</a:t>
+              <a:t>same user, same problem. Day 2 deepens the product; the registered problem is quoted in the product itself.</a:t>
             </a:r>
           </a:p>
         </p:txBody>
@@ -3714,7 +3777,7 @@
                 </a:solidFill>
                 <a:latin typeface="Segoe UI"/>
               </a:rPr>
-              <a:t>Judge link: https://unclone-verified-agent.onrender.com   ·   demo: genuine → PROCEEDS · hijack → HELD · subtle hijack → HELD · silent → STEP UP</a:t>
+              <a:t>Judge link: https://unclone-verified-agent.onrender.com   ·   in-product docs: Impact · Calibration · Scale &amp; Viability pages</a:t>
             </a:r>
           </a:p>
         </p:txBody>
@@ -3728,7 +3791,7 @@
         <p:spPr>
           <a:xfrm>
             <a:off x="640080" y="1783080"/>
-            <a:ext cx="10972800" cy="2651760"/>
+            <a:ext cx="10972800" cy="2377440"/>
           </a:xfrm>
           <a:prstGeom prst="rect">
             <a:avLst/>
@@ -3796,7 +3859,7 @@
                 </a:solidFill>
                 <a:latin typeface="Segoe UI"/>
               </a:rPr>
-              <a:t>Continuous, not per-turn: </a:t>
+              <a:t>Live, not staged: </a:t>
             </a:r>
             <a:r>
               <a:rPr sz="1500" b="0">
@@ -3805,7 +3868,7 @@
                 </a:solidFill>
                 <a:latin typeface="Segoe UI"/>
               </a:rPr>
-              <a:t>DetectifAI has no streaming endpoint, so we built the windowing layer — </a:t>
+              <a:t>press </a:t>
             </a:r>
             <a:r>
               <a:rPr sz="1500" b="1">
@@ -3814,7 +3877,7 @@
                 </a:solidFill>
                 <a:latin typeface="Segoe UI"/>
               </a:rPr>
-              <a:t>6 s windows, stitched into a 2 s risk timeline</a:t>
+              <a:t>Enrol my voice</a:t>
             </a:r>
             <a:r>
               <a:rPr sz="1500" b="0">
@@ -3823,7 +3886,61 @@
                 </a:solidFill>
                 <a:latin typeface="Segoe UI"/>
               </a:rPr>
-              <a:t>, verified live while the call plays.</a:t>
+              <a:t> — 20 s in your browser — then </a:t>
+            </a:r>
+            <a:r>
+              <a:rPr sz="1500" b="1">
+                <a:solidFill>
+                  <a:srgbClr val="0F1B2D"/>
+                </a:solidFill>
+                <a:latin typeface="Segoe UI"/>
+              </a:rPr>
+              <a:t>Verify me now</a:t>
+            </a:r>
+            <a:r>
+              <a:rPr sz="1500" b="0">
+                <a:solidFill>
+                  <a:srgbClr val="33415C"/>
+                </a:solidFill>
+                <a:latin typeface="Segoe UI"/>
+              </a:rPr>
+              <a:t>: a 6 s window captured in the browser, verified through DetectifAI, </a:t>
+            </a:r>
+            <a:r>
+              <a:rPr sz="1500" b="1">
+                <a:solidFill>
+                  <a:srgbClr val="0F1B2D"/>
+                </a:solidFill>
+                <a:latin typeface="Segoe UI"/>
+              </a:rPr>
+              <a:t>never on disk</a:t>
+            </a:r>
+            <a:r>
+              <a:rPr sz="1500" b="0">
+                <a:solidFill>
+                  <a:srgbClr val="33415C"/>
+                </a:solidFill>
+                <a:latin typeface="Segoe UI"/>
+              </a:rPr>
+              <a:t>. An impostor clip against your enrolment is </a:t>
+            </a:r>
+            <a:r>
+              <a:rPr sz="1500" b="1">
+                <a:solidFill>
+                  <a:srgbClr val="0F1B2D"/>
+                </a:solidFill>
+                <a:latin typeface="Segoe UI"/>
+              </a:rPr>
+              <a:t>held</a:t>
+            </a:r>
+            <a:r>
+              <a:rPr sz="1500" b="0">
+                <a:solidFill>
+                  <a:srgbClr val="33415C"/>
+                </a:solidFill>
+                <a:latin typeface="Segoe UI"/>
+              </a:rPr>
+              <a:t>. Upload fallback if the mic is blocked.</a:t>
             </a:r>
           </a:p>
           <a:p>
@@ -3839,7 +3956,7 @@
                 </a:solidFill>
                 <a:latin typeface="Segoe UI"/>
               </a:rPr>
-              <a:t>One badge, three outcomes: </a:t>
+              <a:t>A decision that acts: </a:t>
             </a:r>
             <a:r>
               <a:rPr sz="1500" b="0">
@@ -3848,7 +3965,43 @@
                 </a:solidFill>
                 <a:latin typeface="Segoe UI"/>
               </a:rPr>
-              <a:t>the badge drives the transaction, and no error path can ever approve.</a:t>
+              <a:t>every window mutates a server-side </a:t>
+            </a:r>
+            <a:r>
+              <a:rPr sz="1500" b="1">
+                <a:solidFill>
+                  <a:srgbClr val="0F1B2D"/>
+                </a:solidFill>
+                <a:latin typeface="Segoe UI"/>
+              </a:rPr>
+              <a:t>transaction object</a:t>
+            </a:r>
+            <a:r>
+              <a:rPr sz="1500" b="0">
+                <a:solidFill>
+                  <a:srgbClr val="33415C"/>
+                </a:solidFill>
+                <a:latin typeface="Segoe UI"/>
+              </a:rPr>
+              <a:t> — pending → proceed / step_up / hold. A hold </a:t>
+            </a:r>
+            <a:r>
+              <a:rPr sz="1500" b="1">
+                <a:solidFill>
+                  <a:srgbClr val="0F1B2D"/>
+                </a:solidFill>
+                <a:latin typeface="Segoe UI"/>
+              </a:rPr>
+              <a:t>terminates the call and blocks the payment</a:t>
+            </a:r>
+            <a:r>
+              <a:rPr sz="1500" b="0">
+                <a:solidFill>
+                  <a:srgbClr val="33415C"/>
+                </a:solidFill>
+                <a:latin typeface="Segoe UI"/>
+              </a:rPr>
+              <a:t>; the state is readable in the API.</a:t>
             </a:r>
           </a:p>
         </p:txBody>
@@ -3861,7 +4014,7 @@
         </p:nvSpPr>
         <p:spPr>
           <a:xfrm>
-            <a:off x="685800" y="4526280"/>
+            <a:off x="685800" y="4343400"/>
             <a:ext cx="3383280" cy="868680"/>
           </a:xfrm>
           <a:prstGeom prst="rect">
@@ -3907,7 +4060,7 @@
         </p:nvSpPr>
         <p:spPr>
           <a:xfrm>
-            <a:off x="795528" y="4617720"/>
+            <a:off x="795528" y="4434840"/>
             <a:ext cx="3163824" cy="685800"/>
           </a:xfrm>
           <a:prstGeom prst="rect">
@@ -3939,7 +4092,7 @@
                 </a:solidFill>
                 <a:latin typeface="Segoe UI"/>
               </a:rPr>
-              <a:t>voice matches with margin + every segment real</a:t>
+              <a:t>identity with margin + every segment real + no replay</a:t>
             </a:r>
           </a:p>
         </p:txBody>
@@ -3952,7 +4105,7 @@
         </p:nvSpPr>
         <p:spPr>
           <a:xfrm>
-            <a:off x="4297680" y="4526280"/>
+            <a:off x="4297680" y="4343400"/>
             <a:ext cx="3383280" cy="868680"/>
           </a:xfrm>
           <a:prstGeom prst="rect">
@@ -3998,7 +4151,7 @@
         </p:nvSpPr>
         <p:spPr>
           <a:xfrm>
-            <a:off x="4407408" y="4617720"/>
+            <a:off x="4407408" y="4434840"/>
             <a:ext cx="3163824" cy="685800"/>
           </a:xfrm>
           <a:prstGeom prst="rect">
@@ -4030,7 +4183,7 @@
                 </a:solidFill>
                 <a:latin typeface="Segoe UI"/>
               </a:rPr>
-              <a:t>thin, partial or unverifiable → in-app confirmation</a:t>
+              <a:t>thin evidence, digital render, 422 → in-app confirmation</a:t>
             </a:r>
           </a:p>
         </p:txBody>
@@ -4043,7 +4196,7 @@
         </p:nvSpPr>
         <p:spPr>
           <a:xfrm>
-            <a:off x="7909560" y="4526280"/>
+            <a:off x="7909560" y="4343400"/>
             <a:ext cx="3566160" cy="868680"/>
           </a:xfrm>
           <a:prstGeom prst="rect">
@@ -4089,7 +4242,7 @@
         </p:nvSpPr>
         <p:spPr>
           <a:xfrm>
-            <a:off x="8019288" y="4617720"/>
+            <a:off x="8019288" y="4434840"/>
             <a:ext cx="3346704" cy="685800"/>
           </a:xfrm>
           <a:prstGeom prst="rect">
@@ -4121,7 +4274,7 @@
                 </a:solidFill>
                 <a:latin typeface="Segoe UI"/>
               </a:rPr>
-              <a:t>mismatch or any synthetic segment → transaction blocked</a:t>
+              <a:t>mismatch · any hot segment · re-sent audio → blocked</a:t>
             </a:r>
           </a:p>
         </p:txBody>
@@ -4134,8 +4287,8 @@
         </p:nvSpPr>
         <p:spPr>
           <a:xfrm>
-            <a:off x="640080" y="5532120"/>
-            <a:ext cx="10972800" cy="548640"/>
+            <a:off x="640080" y="5394960"/>
+            <a:ext cx="10972800" cy="731520"/>
           </a:xfrm>
           <a:prstGeom prst="rect">
             <a:avLst/>
@@ -4155,7 +4308,7 @@
                 </a:solidFill>
                 <a:latin typeface="Segoe UI"/>
               </a:rPr>
-              <a:t>Day 2 shipped all three Day-1 promises: </a:t>
+              <a:t>Two clocks on screen: the </a:t>
             </a:r>
             <a:r>
               <a:rPr sz="1250" b="1">
@@ -4164,7 +4317,7 @@
                 </a:solidFill>
                 <a:latin typeface="Segoe UI"/>
               </a:rPr>
-              <a:t>continuous verification · agent-to-agent handshake · aggregate-blind segment policy</a:t>
+              <a:t>risk timeline</a:t>
             </a:r>
             <a:r>
               <a:rPr sz="1250" b="0">
@@ -4173,7 +4326,25 @@
                 </a:solidFill>
                 <a:latin typeface="Segoe UI"/>
               </a:rPr>
-              <a:t>. Zero customer effort: 15–60 s enrollment, no app change, no hardware.</a:t>
+              <a:t> shows which window is being checked; the </a:t>
+            </a:r>
+            <a:r>
+              <a:rPr sz="1250" b="1">
+                <a:solidFill>
+                  <a:srgbClr val="0F1B2D"/>
+                </a:solidFill>
+                <a:latin typeface="Segoe UI"/>
+              </a:rPr>
+              <a:t>transaction badge</a:t>
+            </a:r>
+            <a:r>
+              <a:rPr sz="1250" b="0">
+                <a:solidFill>
+                  <a:srgbClr val="33415C"/>
+                </a:solidFill>
+                <a:latin typeface="Segoe UI"/>
+              </a:rPr>
+              <a:t> shows payment state. Judges verify everything by trying it — including speaking themselves.</a:t>
             </a:r>
           </a:p>
         </p:txBody>
@@ -4381,7 +4552,7 @@
                 </a:solidFill>
                 <a:latin typeface="Segoe UI"/>
               </a:rPr>
-              <a:t>Judge link: https://unclone-verified-agent.onrender.com   ·   demo: genuine → PROCEEDS · hijack → HELD · subtle hijack → HELD · silent → STEP UP</a:t>
+              <a:t>Judge link: https://unclone-verified-agent.onrender.com   ·   in-product docs: Impact · Calibration · Scale &amp; Viability pages</a:t>
             </a:r>
           </a:p>
         </p:txBody>
@@ -4395,7 +4566,7 @@
         <p:spPr>
           <a:xfrm>
             <a:off x="640080" y="1645920"/>
-            <a:ext cx="5852160" cy="4206240"/>
+            <a:ext cx="5852160" cy="4480560"/>
           </a:xfrm>
           <a:prstGeom prst="rect">
             <a:avLst/>
@@ -4429,25 +4600,7 @@
                 </a:solidFill>
                 <a:latin typeface="Segoe UI"/>
               </a:rPr>
-              <a:t>POST /v1/speakers/verify with detect_deepfake=true returns speaker verification against enrolled </a:t>
-            </a:r>
-            <a:r>
-              <a:rPr sz="1300" b="1">
-                <a:solidFill>
-                  <a:srgbClr val="0F1B2D"/>
-                </a:solidFill>
-                <a:latin typeface="Segoe UI"/>
-              </a:rPr>
-              <a:t>bank_agent_1</a:t>
-            </a:r>
-            <a:r>
-              <a:rPr sz="1300" b="0">
-                <a:solidFill>
-                  <a:srgbClr val="33415C"/>
-                </a:solidFill>
-                <a:latin typeface="Segoe UI"/>
-              </a:rPr>
-              <a:t> and synthetic-speech detection as </a:t>
+              <a:t>POST /v1/speakers/verify with detect_deepfake=true — speaker verification against the enrolled agent plus synthetic-speech detection as </a:t>
             </a:r>
             <a:r>
               <a:rPr sz="1300" b="1">
@@ -4490,7 +4643,25 @@
                 </a:solidFill>
                 <a:latin typeface="Segoe UI"/>
               </a:rPr>
-              <a:t>A hijack can hide inside a reassuring average. Our policy uses the segment maximum, so the aggregate cannot launder a three-second clone.</a:t>
+              <a:t>an aggregate can launder a 3-second clone. The policy holds on the </a:t>
+            </a:r>
+            <a:r>
+              <a:rPr sz="1300" b="1">
+                <a:solidFill>
+                  <a:srgbClr val="0F1B2D"/>
+                </a:solidFill>
+                <a:latin typeface="Segoe UI"/>
+              </a:rPr>
+              <a:t>segment maximum</a:t>
+            </a:r>
+            <a:r>
+              <a:rPr sz="1300" b="0">
+                <a:solidFill>
+                  <a:srgbClr val="33415C"/>
+                </a:solidFill>
+                <a:latin typeface="Segoe UI"/>
+              </a:rPr>
+              <a:t>.</a:t>
             </a:r>
           </a:p>
           <a:p>
@@ -4506,7 +4677,16 @@
                 </a:solidFill>
                 <a:latin typeface="Segoe UI"/>
               </a:rPr>
-              <a:t>Thresholds: </a:t>
+              <a:t>Two signals, layered: </a:t>
+            </a:r>
+            <a:r>
+              <a:rPr sz="1300" b="1">
+                <a:solidFill>
+                  <a:srgbClr val="0F1B2D"/>
+                </a:solidFill>
+                <a:latin typeface="Segoe UI"/>
+              </a:rPr>
+              <a:t>capture-and-replay</a:t>
             </a:r>
             <a:r>
               <a:rPr sz="1300" b="0">
@@ -4515,7 +4695,7 @@
                 </a:solidFill>
                 <a:latin typeface="Segoe UI"/>
               </a:rPr>
-              <a:t>vendor match </a:t>
+              <a:t> — identical audio re-sent mid-call is held on content identity; </a:t>
             </a:r>
             <a:r>
               <a:rPr sz="1300" b="1">
@@ -4524,7 +4704,7 @@
                 </a:solidFill>
                 <a:latin typeface="Segoe UI"/>
               </a:rPr>
-              <a:t>0.53</a:t>
+              <a:t>stdlib forensics</a:t>
             </a:r>
             <a:r>
               <a:rPr sz="1300" b="0">
@@ -4533,61 +4713,7 @@
                 </a:solidFill>
                 <a:latin typeface="Segoe UI"/>
               </a:rPr>
-              <a:t> · deepfake </a:t>
-            </a:r>
-            <a:r>
-              <a:rPr sz="1300" b="1">
-                <a:solidFill>
-                  <a:srgbClr val="0F1B2D"/>
-                </a:solidFill>
-                <a:latin typeface="Segoe UI"/>
-              </a:rPr>
-              <a:t>0.62</a:t>
-            </a:r>
-            <a:r>
-              <a:rPr sz="1300" b="0">
-                <a:solidFill>
-                  <a:srgbClr val="33415C"/>
-                </a:solidFill>
-                <a:latin typeface="Segoe UI"/>
-              </a:rPr>
-              <a:t> · our auto-approve </a:t>
-            </a:r>
-            <a:r>
-              <a:rPr sz="1300" b="1">
-                <a:solidFill>
-                  <a:srgbClr val="0F1B2D"/>
-                </a:solidFill>
-                <a:latin typeface="Segoe UI"/>
-              </a:rPr>
-              <a:t>0.75</a:t>
-            </a:r>
-            <a:r>
-              <a:rPr sz="1300" b="0">
-                <a:solidFill>
-                  <a:srgbClr val="33415C"/>
-                </a:solidFill>
-                <a:latin typeface="Segoe UI"/>
-              </a:rPr>
-              <a:t> · segment hold </a:t>
-            </a:r>
-            <a:r>
-              <a:rPr sz="1300" b="1">
-                <a:solidFill>
-                  <a:srgbClr val="0F1B2D"/>
-                </a:solidFill>
-                <a:latin typeface="Segoe UI"/>
-              </a:rPr>
-              <a:t>0.90</a:t>
-            </a:r>
-            <a:r>
-              <a:rPr sz="1300" b="0">
-                <a:solidFill>
-                  <a:srgbClr val="33415C"/>
-                </a:solidFill>
-                <a:latin typeface="Segoe UI"/>
-              </a:rPr>
-              <a:t>.</a:t>
+              <a:t> — digital render artifact ≥ 0.85 escalates (never convicts). Weights live in one policy module.</a:t>
             </a:r>
           </a:p>
           <a:p>
@@ -4603,7 +4729,7 @@
                 </a:solidFill>
                 <a:latin typeface="Segoe UI"/>
               </a:rPr>
-              <a:t>Engineering: </a:t>
+              <a:t>Calibrated, transfer-checked: </a:t>
             </a:r>
             <a:r>
               <a:rPr sz="1300" b="0">
@@ -4612,7 +4738,43 @@
                 </a:solidFill>
                 <a:latin typeface="Segoe UI"/>
               </a:rPr>
-              <a:t>30 ops/min budget · Idempotency-Key makes repeat runs free · 2.0–2.5 s per window · 422 silent_audio, partial and 5xx all fail closed to STEP UP.</a:t>
+              <a:t>n = </a:t>
+            </a:r>
+            <a:r>
+              <a:rPr sz="1300" b="1">
+                <a:solidFill>
+                  <a:srgbClr val="0F1B2D"/>
+                </a:solidFill>
+                <a:latin typeface="Segoe UI"/>
+              </a:rPr>
+              <a:t>27 labelled segments</a:t>
+            </a:r>
+            <a:r>
+              <a:rPr sz="1300" b="0">
+                <a:solidFill>
+                  <a:srgbClr val="33415C"/>
+                </a:solidFill>
+                <a:latin typeface="Segoe UI"/>
+              </a:rPr>
+              <a:t>, two transform families, two voices. Genuine/clone separation is complete (genuine ≤ 0.021 vs clone ≥ 0.998) and </a:t>
+            </a:r>
+            <a:r>
+              <a:rPr sz="1300" b="1">
+                <a:solidFill>
+                  <a:srgbClr val="0F1B2D"/>
+                </a:solidFill>
+                <a:latin typeface="Segoe UI"/>
+              </a:rPr>
+              <a:t>transfers</a:t>
+            </a:r>
+            <a:r>
+              <a:rPr sz="1300" b="0">
+                <a:solidFill>
+                  <a:srgbClr val="33415C"/>
+                </a:solidFill>
+                <a:latin typeface="Segoe UI"/>
+              </a:rPr>
+              <a:t> — including through a telephony band-pass. Honest caveat: FAR/FRR vs unseen real speakers is open — “tuned and transfer-checked”, not “validated”.</a:t>
             </a:r>
           </a:p>
           <a:p>
@@ -4628,7 +4790,7 @@
                 </a:solidFill>
                 <a:latin typeface="Segoe UI"/>
               </a:rPr>
-              <a:t>Tools used: </a:t>
+              <a:t>Fail-closed: </a:t>
             </a:r>
             <a:r>
               <a:rPr sz="1300" b="0">
@@ -4637,7 +4799,25 @@
                 </a:solidFill>
                 <a:latin typeface="Segoe UI"/>
               </a:rPr>
-              <a:t>DetectifAI (verify + deepfake) · FastAPI/Python · edge-tts (team-generated attacker voice) · ffmpeg · Render · GitHub · AI coding assistant.</a:t>
+              <a:t>silent (422), partial evidence, 5xx and budget-exhaustion all step up. </a:t>
+            </a:r>
+            <a:r>
+              <a:rPr sz="1300" b="1">
+                <a:solidFill>
+                  <a:srgbClr val="0F1B2D"/>
+                </a:solidFill>
+                <a:latin typeface="Segoe UI"/>
+              </a:rPr>
+              <a:t>No error path returns proceed.</a:t>
+            </a:r>
+            <a:r>
+              <a:rPr sz="1300" b="0">
+                <a:solidFill>
+                  <a:srgbClr val="33415C"/>
+                </a:solidFill>
+                <a:latin typeface="Segoe UI"/>
+              </a:rPr>
+              <a:t> Fresh, credit-paying runs are an explicit opt-in behind a per-session cap.</a:t>
             </a:r>
           </a:p>
         </p:txBody>
@@ -4651,7 +4831,7 @@
         <p:spPr>
           <a:xfrm>
             <a:off x="6720840" y="1645920"/>
-            <a:ext cx="4846320" cy="365760"/>
+            <a:ext cx="4846320" cy="274320"/>
           </a:xfrm>
           <a:prstGeom prst="rect">
             <a:avLst/>
@@ -4665,13 +4845,13 @@
           <a:lstStyle/>
           <a:p>
             <a:r>
-              <a:rPr sz="1300" b="1">
-                <a:solidFill>
-                  <a:srgbClr val="0F1B2D"/>
-                </a:solidFill>
-                <a:latin typeface="Segoe UI"/>
-              </a:rPr>
-              <a:t>Live results, this prototype (real API)</a:t>
+              <a:rPr sz="1100" b="1">
+                <a:solidFill>
+                  <a:srgbClr val="D6394B"/>
+                </a:solidFill>
+                <a:latin typeface="Segoe UI"/>
+              </a:rPr>
+              <a:t>AGGREGATE-BLIND HIJACK — HELD (live API)</a:t>
             </a:r>
           </a:p>
         </p:txBody>
@@ -4684,8 +4864,8 @@
         </p:nvSpPr>
         <p:spPr>
           <a:xfrm>
-            <a:off x="6720840" y="2029968"/>
-            <a:ext cx="4846320" cy="274320"/>
+            <a:off x="6720840" y="1920240"/>
+            <a:ext cx="1554480" cy="274320"/>
           </a:xfrm>
           <a:prstGeom prst="rect">
             <a:avLst/>
@@ -4699,40 +4879,6 @@
           <a:lstStyle/>
           <a:p>
             <a:r>
-              <a:rPr sz="1100" b="1">
-                <a:solidFill>
-                  <a:srgbClr val="0E9F6E"/>
-                </a:solidFill>
-                <a:latin typeface="Segoe UI"/>
-              </a:rPr>
-              <a:t>GENUINE CALL — PROCEEDS</a:t>
-            </a:r>
-          </a:p>
-        </p:txBody>
-      </p:sp>
-      <p:sp>
-        <p:nvSpPr>
-          <p:cNvPr id="10" name="TextBox 9"/>
-          <p:cNvSpPr txBox="1"/>
-          <p:nvPr/>
-        </p:nvSpPr>
-        <p:spPr>
-          <a:xfrm>
-            <a:off x="6720840" y="2286000"/>
-            <a:ext cx="1554480" cy="274320"/>
-          </a:xfrm>
-          <a:prstGeom prst="rect">
-            <a:avLst/>
-          </a:prstGeom>
-          <a:noFill/>
-        </p:spPr>
-        <p:txBody>
-          <a:bodyPr wrap="square">
-            <a:spAutoFit/>
-          </a:bodyPr>
-          <a:lstStyle/>
-          <a:p>
-            <a:r>
               <a:rPr sz="1100">
                 <a:solidFill>
                   <a:srgbClr val="64748B"/>
@@ -4746,13 +4892,13 @@
       </p:sp>
       <p:sp>
         <p:nvSpPr>
-          <p:cNvPr id="11" name="Rectangle 10"/>
+          <p:cNvPr id="10" name="Rectangle 9"/>
           <p:cNvSpPr/>
           <p:nvPr/>
         </p:nvSpPr>
         <p:spPr>
           <a:xfrm>
-            <a:off x="8321040" y="2331720"/>
+            <a:off x="8321040" y="1965960"/>
             <a:ext cx="2468879" cy="146304"/>
           </a:xfrm>
           <a:prstGeom prst="rect">
@@ -4790,14 +4936,14 @@
       </p:sp>
       <p:sp>
         <p:nvSpPr>
-          <p:cNvPr id="12" name="Rectangle 11"/>
+          <p:cNvPr id="11" name="Rectangle 10"/>
           <p:cNvSpPr/>
           <p:nvPr/>
         </p:nvSpPr>
         <p:spPr>
           <a:xfrm>
-            <a:off x="8321040" y="2331720"/>
-            <a:ext cx="2268900" cy="146304"/>
+            <a:off x="8321040" y="1965960"/>
+            <a:ext cx="1893630" cy="146304"/>
           </a:xfrm>
           <a:prstGeom prst="rect">
             <a:avLst/>
@@ -4834,13 +4980,13 @@
       </p:sp>
       <p:sp>
         <p:nvSpPr>
-          <p:cNvPr id="13" name="Rectangle 12"/>
+          <p:cNvPr id="12" name="Rectangle 11"/>
           <p:cNvSpPr/>
           <p:nvPr/>
         </p:nvSpPr>
         <p:spPr>
           <a:xfrm>
-            <a:off x="9629546" y="2267712"/>
+            <a:off x="9629546" y="1901952"/>
             <a:ext cx="18288" cy="274320"/>
           </a:xfrm>
           <a:prstGeom prst="rect">
@@ -4878,13 +5024,13 @@
       </p:sp>
       <p:sp>
         <p:nvSpPr>
-          <p:cNvPr id="14" name="TextBox 13"/>
+          <p:cNvPr id="13" name="TextBox 12"/>
           <p:cNvSpPr txBox="1"/>
           <p:nvPr/>
         </p:nvSpPr>
         <p:spPr>
           <a:xfrm>
-            <a:off x="10835639" y="2276856"/>
+            <a:off x="10835639" y="1911096"/>
             <a:ext cx="731520" cy="274320"/>
           </a:xfrm>
           <a:prstGeom prst="rect">
@@ -4906,20 +5052,20 @@
                 </a:solidFill>
                 <a:latin typeface="Segoe UI"/>
               </a:rPr>
-              <a:t>0.919</a:t>
-            </a:r>
-          </a:p>
-        </p:txBody>
-      </p:sp>
-      <p:sp>
-        <p:nvSpPr>
-          <p:cNvPr id="15" name="TextBox 14"/>
+              <a:t>0.767</a:t>
+            </a:r>
+          </a:p>
+        </p:txBody>
+      </p:sp>
+      <p:sp>
+        <p:nvSpPr>
+          <p:cNvPr id="14" name="TextBox 13"/>
           <p:cNvSpPr txBox="1"/>
           <p:nvPr/>
         </p:nvSpPr>
         <p:spPr>
           <a:xfrm>
-            <a:off x="6720840" y="2615184"/>
+            <a:off x="6720840" y="2249424"/>
             <a:ext cx="1554480" cy="274320"/>
           </a:xfrm>
           <a:prstGeom prst="rect">
@@ -4947,13 +5093,13 @@
       </p:sp>
       <p:sp>
         <p:nvSpPr>
-          <p:cNvPr id="16" name="Rectangle 15"/>
+          <p:cNvPr id="15" name="Rectangle 14"/>
           <p:cNvSpPr/>
           <p:nvPr/>
         </p:nvSpPr>
         <p:spPr>
           <a:xfrm>
-            <a:off x="8321040" y="2660903"/>
+            <a:off x="8321040" y="2295144"/>
             <a:ext cx="2468879" cy="146304"/>
           </a:xfrm>
           <a:prstGeom prst="rect">
@@ -4991,14 +5137,14 @@
       </p:sp>
       <p:sp>
         <p:nvSpPr>
-          <p:cNvPr id="17" name="Rectangle 16"/>
+          <p:cNvPr id="16" name="Rectangle 15"/>
           <p:cNvSpPr/>
           <p:nvPr/>
         </p:nvSpPr>
         <p:spPr>
           <a:xfrm>
-            <a:off x="8321040" y="2660903"/>
-            <a:ext cx="18288" cy="146304"/>
+            <a:off x="8321040" y="2295144"/>
+            <a:ext cx="832012" cy="146304"/>
           </a:xfrm>
           <a:prstGeom prst="rect">
             <a:avLst/>
@@ -5035,13 +5181,13 @@
       </p:sp>
       <p:sp>
         <p:nvSpPr>
-          <p:cNvPr id="18" name="Rectangle 17"/>
+          <p:cNvPr id="17" name="Rectangle 16"/>
           <p:cNvSpPr/>
           <p:nvPr/>
         </p:nvSpPr>
         <p:spPr>
           <a:xfrm>
-            <a:off x="9851745" y="2596896"/>
+            <a:off x="9851745" y="2231136"/>
             <a:ext cx="18288" cy="274320"/>
           </a:xfrm>
           <a:prstGeom prst="rect">
@@ -5079,13 +5225,13 @@
       </p:sp>
       <p:sp>
         <p:nvSpPr>
-          <p:cNvPr id="19" name="TextBox 18"/>
+          <p:cNvPr id="18" name="TextBox 17"/>
           <p:cNvSpPr txBox="1"/>
           <p:nvPr/>
         </p:nvSpPr>
         <p:spPr>
           <a:xfrm>
-            <a:off x="10835639" y="2606040"/>
+            <a:off x="10835639" y="2240280"/>
             <a:ext cx="731520" cy="274320"/>
           </a:xfrm>
           <a:prstGeom prst="rect">
@@ -5107,20 +5253,20 @@
                 </a:solidFill>
                 <a:latin typeface="Segoe UI"/>
               </a:rPr>
-              <a:t>0.006</a:t>
-            </a:r>
-          </a:p>
-        </p:txBody>
-      </p:sp>
-      <p:sp>
-        <p:nvSpPr>
-          <p:cNvPr id="20" name="Rectangle 19"/>
+              <a:t>0.337</a:t>
+            </a:r>
+          </a:p>
+        </p:txBody>
+      </p:sp>
+      <p:sp>
+        <p:nvSpPr>
+          <p:cNvPr id="19" name="Rectangle 18"/>
           <p:cNvSpPr/>
           <p:nvPr/>
         </p:nvSpPr>
         <p:spPr>
           <a:xfrm>
-            <a:off x="6702552" y="2980944"/>
+            <a:off x="6702552" y="2615184"/>
             <a:ext cx="4882896" cy="420623"/>
           </a:xfrm>
           <a:prstGeom prst="rect">
@@ -5160,14 +5306,14 @@
       </p:sp>
       <p:sp>
         <p:nvSpPr>
-          <p:cNvPr id="21" name="Rectangle 20"/>
+          <p:cNvPr id="20" name="Rectangle 19"/>
           <p:cNvSpPr/>
           <p:nvPr/>
         </p:nvSpPr>
         <p:spPr>
           <a:xfrm>
-            <a:off x="6720840" y="2999232"/>
-            <a:ext cx="1211580" cy="384048"/>
+            <a:off x="6720840" y="2633472"/>
+            <a:ext cx="1491175" cy="384048"/>
           </a:xfrm>
           <a:prstGeom prst="rect">
             <a:avLst/>
@@ -5204,14 +5350,14 @@
       </p:sp>
       <p:sp>
         <p:nvSpPr>
-          <p:cNvPr id="22" name="Rectangle 21"/>
+          <p:cNvPr id="21" name="Rectangle 20"/>
           <p:cNvSpPr/>
           <p:nvPr/>
         </p:nvSpPr>
         <p:spPr>
           <a:xfrm>
-            <a:off x="7326629" y="2999232"/>
-            <a:ext cx="1211580" cy="384048"/>
+            <a:off x="7466427" y="2633472"/>
+            <a:ext cx="1491175" cy="384048"/>
           </a:xfrm>
           <a:prstGeom prst="rect">
             <a:avLst/>
@@ -5248,14 +5394,14 @@
       </p:sp>
       <p:sp>
         <p:nvSpPr>
-          <p:cNvPr id="23" name="Rectangle 22"/>
+          <p:cNvPr id="22" name="Rectangle 21"/>
           <p:cNvSpPr/>
           <p:nvPr/>
         </p:nvSpPr>
         <p:spPr>
           <a:xfrm>
-            <a:off x="7932419" y="2999232"/>
-            <a:ext cx="1211580" cy="384048"/>
+            <a:off x="8212015" y="2633472"/>
+            <a:ext cx="1491175" cy="384048"/>
           </a:xfrm>
           <a:prstGeom prst="rect">
             <a:avLst/>
@@ -5292,14 +5438,492 @@
       </p:sp>
       <p:sp>
         <p:nvSpPr>
+          <p:cNvPr id="23" name="Rectangle 22"/>
+          <p:cNvSpPr/>
+          <p:nvPr/>
+        </p:nvSpPr>
+        <p:spPr>
+          <a:xfrm>
+            <a:off x="9703190" y="2633472"/>
+            <a:ext cx="745587" cy="384048"/>
+          </a:xfrm>
+          <a:prstGeom prst="rect">
+            <a:avLst/>
+          </a:prstGeom>
+          <a:solidFill>
+            <a:srgbClr val="D6394B"/>
+          </a:solidFill>
+          <a:ln>
+            <a:noFill/>
+          </a:ln>
+          <a:effectLst/>
+        </p:spPr>
+        <p:style>
+          <a:lnRef idx="1">
+            <a:schemeClr val="accent1"/>
+          </a:lnRef>
+          <a:fillRef idx="3">
+            <a:schemeClr val="accent1"/>
+          </a:fillRef>
+          <a:effectRef idx="2">
+            <a:schemeClr val="accent1"/>
+          </a:effectRef>
+          <a:fontRef idx="minor">
+            <a:schemeClr val="lt1"/>
+          </a:fontRef>
+        </p:style>
+        <p:txBody>
+          <a:bodyPr rtlCol="0" anchor="ctr"/>
+          <a:lstStyle/>
+          <a:p>
+            <a:pPr algn="ctr"/>
+          </a:p>
+        </p:txBody>
+      </p:sp>
+      <p:sp>
+        <p:nvSpPr>
           <p:cNvPr id="24" name="Rectangle 23"/>
           <p:cNvSpPr/>
           <p:nvPr/>
         </p:nvSpPr>
         <p:spPr>
           <a:xfrm>
-            <a:off x="8538209" y="2999232"/>
-            <a:ext cx="1211580" cy="384048"/>
+            <a:off x="10448778" y="2633472"/>
+            <a:ext cx="745587" cy="384048"/>
+          </a:xfrm>
+          <a:prstGeom prst="rect">
+            <a:avLst/>
+          </a:prstGeom>
+          <a:solidFill>
+            <a:srgbClr val="D6394B"/>
+          </a:solidFill>
+          <a:ln>
+            <a:noFill/>
+          </a:ln>
+          <a:effectLst/>
+        </p:spPr>
+        <p:style>
+          <a:lnRef idx="1">
+            <a:schemeClr val="accent1"/>
+          </a:lnRef>
+          <a:fillRef idx="3">
+            <a:schemeClr val="accent1"/>
+          </a:fillRef>
+          <a:effectRef idx="2">
+            <a:schemeClr val="accent1"/>
+          </a:effectRef>
+          <a:fontRef idx="minor">
+            <a:schemeClr val="lt1"/>
+          </a:fontRef>
+        </p:style>
+        <p:txBody>
+          <a:bodyPr rtlCol="0" anchor="ctr"/>
+          <a:lstStyle/>
+          <a:p>
+            <a:pPr algn="ctr"/>
+          </a:p>
+        </p:txBody>
+      </p:sp>
+      <p:sp>
+        <p:nvSpPr>
+          <p:cNvPr id="25" name="TextBox 24"/>
+          <p:cNvSpPr txBox="1"/>
+          <p:nvPr/>
+        </p:nvSpPr>
+        <p:spPr>
+          <a:xfrm>
+            <a:off x="6720840" y="3072384"/>
+            <a:ext cx="4846320" cy="274320"/>
+          </a:xfrm>
+          <a:prstGeom prst="rect">
+            <a:avLst/>
+          </a:prstGeom>
+          <a:noFill/>
+        </p:spPr>
+        <p:txBody>
+          <a:bodyPr wrap="square">
+            <a:spAutoFit/>
+          </a:bodyPr>
+          <a:lstStyle/>
+          <a:p>
+            <a:r>
+              <a:rPr sz="1050">
+                <a:solidFill>
+                  <a:srgbClr val="64748B"/>
+                </a:solidFill>
+                <a:latin typeface="Segoe UI"/>
+              </a:rPr>
+              <a:t>aggregate says “real” — segment max 0.999 at 8–13 s → HOLD</a:t>
+            </a:r>
+          </a:p>
+        </p:txBody>
+      </p:sp>
+      <p:sp>
+        <p:nvSpPr>
+          <p:cNvPr id="26" name="TextBox 25"/>
+          <p:cNvSpPr txBox="1"/>
+          <p:nvPr/>
+        </p:nvSpPr>
+        <p:spPr>
+          <a:xfrm>
+            <a:off x="6720840" y="3401568"/>
+            <a:ext cx="4846320" cy="822960"/>
+          </a:xfrm>
+          <a:prstGeom prst="rect">
+            <a:avLst/>
+          </a:prstGeom>
+          <a:noFill/>
+        </p:spPr>
+        <p:txBody>
+          <a:bodyPr wrap="square">
+            <a:spAutoFit/>
+          </a:bodyPr>
+          <a:lstStyle/>
+          <a:p>
+            <a:r>
+              <a:rPr sz="1150" b="1">
+                <a:solidFill>
+                  <a:srgbClr val="0F1B2D"/>
+                </a:solidFill>
+                <a:latin typeface="Segoe UI"/>
+              </a:rPr>
+              <a:t>An aggregate-only policy approves this call.</a:t>
+            </a:r>
+            <a:r>
+              <a:rPr sz="1150" b="0">
+                <a:solidFill>
+                  <a:srgbClr val="33415C"/>
+                </a:solidFill>
+                <a:latin typeface="Segoe UI"/>
+              </a:rPr>
+              <a:t> Only the segment view catches the clone.</a:t>
+            </a:r>
+          </a:p>
+        </p:txBody>
+      </p:sp>
+      <p:sp>
+        <p:nvSpPr>
+          <p:cNvPr id="27" name="TextBox 26"/>
+          <p:cNvSpPr txBox="1"/>
+          <p:nvPr/>
+        </p:nvSpPr>
+        <p:spPr>
+          <a:xfrm>
+            <a:off x="6720840" y="4160520"/>
+            <a:ext cx="4846320" cy="274320"/>
+          </a:xfrm>
+          <a:prstGeom prst="rect">
+            <a:avLst/>
+          </a:prstGeom>
+          <a:noFill/>
+        </p:spPr>
+        <p:txBody>
+          <a:bodyPr wrap="square">
+            <a:spAutoFit/>
+          </a:bodyPr>
+          <a:lstStyle/>
+          <a:p>
+            <a:r>
+              <a:rPr sz="1100" b="1">
+                <a:solidFill>
+                  <a:srgbClr val="D6394B"/>
+                </a:solidFill>
+                <a:latin typeface="Segoe UI"/>
+              </a:rPr>
+              <a:t>SECOND TRANSFER CHECK — HELD (fresh score)</a:t>
+            </a:r>
+          </a:p>
+        </p:txBody>
+      </p:sp>
+      <p:sp>
+        <p:nvSpPr>
+          <p:cNvPr id="28" name="TextBox 27"/>
+          <p:cNvSpPr txBox="1"/>
+          <p:nvPr/>
+        </p:nvSpPr>
+        <p:spPr>
+          <a:xfrm>
+            <a:off x="6720840" y="4434840"/>
+            <a:ext cx="1554480" cy="274320"/>
+          </a:xfrm>
+          <a:prstGeom prst="rect">
+            <a:avLst/>
+          </a:prstGeom>
+          <a:noFill/>
+        </p:spPr>
+        <p:txBody>
+          <a:bodyPr wrap="square">
+            <a:spAutoFit/>
+          </a:bodyPr>
+          <a:lstStyle/>
+          <a:p>
+            <a:r>
+              <a:rPr sz="1100">
+                <a:solidFill>
+                  <a:srgbClr val="64748B"/>
+                </a:solidFill>
+                <a:latin typeface="Segoe UI"/>
+              </a:rPr>
+              <a:t>voice similarity</a:t>
+            </a:r>
+          </a:p>
+        </p:txBody>
+      </p:sp>
+      <p:sp>
+        <p:nvSpPr>
+          <p:cNvPr id="29" name="Rectangle 28"/>
+          <p:cNvSpPr/>
+          <p:nvPr/>
+        </p:nvSpPr>
+        <p:spPr>
+          <a:xfrm>
+            <a:off x="8321040" y="4480559"/>
+            <a:ext cx="2468879" cy="146304"/>
+          </a:xfrm>
+          <a:prstGeom prst="rect">
+            <a:avLst/>
+          </a:prstGeom>
+          <a:solidFill>
+            <a:srgbClr val="E6ECF5"/>
+          </a:solidFill>
+          <a:ln>
+            <a:noFill/>
+          </a:ln>
+          <a:effectLst/>
+        </p:spPr>
+        <p:style>
+          <a:lnRef idx="1">
+            <a:schemeClr val="accent1"/>
+          </a:lnRef>
+          <a:fillRef idx="3">
+            <a:schemeClr val="accent1"/>
+          </a:fillRef>
+          <a:effectRef idx="2">
+            <a:schemeClr val="accent1"/>
+          </a:effectRef>
+          <a:fontRef idx="minor">
+            <a:schemeClr val="lt1"/>
+          </a:fontRef>
+        </p:style>
+        <p:txBody>
+          <a:bodyPr rtlCol="0" anchor="ctr"/>
+          <a:lstStyle/>
+          <a:p>
+            <a:pPr algn="ctr"/>
+          </a:p>
+        </p:txBody>
+      </p:sp>
+      <p:sp>
+        <p:nvSpPr>
+          <p:cNvPr id="30" name="Rectangle 29"/>
+          <p:cNvSpPr/>
+          <p:nvPr/>
+        </p:nvSpPr>
+        <p:spPr>
+          <a:xfrm>
+            <a:off x="8321040" y="4480559"/>
+            <a:ext cx="120975" cy="146304"/>
+          </a:xfrm>
+          <a:prstGeom prst="rect">
+            <a:avLst/>
+          </a:prstGeom>
+          <a:solidFill>
+            <a:srgbClr val="D6394B"/>
+          </a:solidFill>
+          <a:ln>
+            <a:noFill/>
+          </a:ln>
+          <a:effectLst/>
+        </p:spPr>
+        <p:style>
+          <a:lnRef idx="1">
+            <a:schemeClr val="accent1"/>
+          </a:lnRef>
+          <a:fillRef idx="3">
+            <a:schemeClr val="accent1"/>
+          </a:fillRef>
+          <a:effectRef idx="2">
+            <a:schemeClr val="accent1"/>
+          </a:effectRef>
+          <a:fontRef idx="minor">
+            <a:schemeClr val="lt1"/>
+          </a:fontRef>
+        </p:style>
+        <p:txBody>
+          <a:bodyPr rtlCol="0" anchor="ctr"/>
+          <a:lstStyle/>
+          <a:p>
+            <a:pPr algn="ctr"/>
+          </a:p>
+        </p:txBody>
+      </p:sp>
+      <p:sp>
+        <p:nvSpPr>
+          <p:cNvPr id="31" name="Rectangle 30"/>
+          <p:cNvSpPr/>
+          <p:nvPr/>
+        </p:nvSpPr>
+        <p:spPr>
+          <a:xfrm>
+            <a:off x="9629546" y="4416552"/>
+            <a:ext cx="18288" cy="274320"/>
+          </a:xfrm>
+          <a:prstGeom prst="rect">
+            <a:avLst/>
+          </a:prstGeom>
+          <a:solidFill>
+            <a:srgbClr val="0F1B2D"/>
+          </a:solidFill>
+          <a:ln>
+            <a:noFill/>
+          </a:ln>
+          <a:effectLst/>
+        </p:spPr>
+        <p:style>
+          <a:lnRef idx="1">
+            <a:schemeClr val="accent1"/>
+          </a:lnRef>
+          <a:fillRef idx="3">
+            <a:schemeClr val="accent1"/>
+          </a:fillRef>
+          <a:effectRef idx="2">
+            <a:schemeClr val="accent1"/>
+          </a:effectRef>
+          <a:fontRef idx="minor">
+            <a:schemeClr val="lt1"/>
+          </a:fontRef>
+        </p:style>
+        <p:txBody>
+          <a:bodyPr rtlCol="0" anchor="ctr"/>
+          <a:lstStyle/>
+          <a:p>
+            <a:pPr algn="ctr"/>
+          </a:p>
+        </p:txBody>
+      </p:sp>
+      <p:sp>
+        <p:nvSpPr>
+          <p:cNvPr id="32" name="TextBox 31"/>
+          <p:cNvSpPr txBox="1"/>
+          <p:nvPr/>
+        </p:nvSpPr>
+        <p:spPr>
+          <a:xfrm>
+            <a:off x="10835639" y="4425696"/>
+            <a:ext cx="731520" cy="274320"/>
+          </a:xfrm>
+          <a:prstGeom prst="rect">
+            <a:avLst/>
+          </a:prstGeom>
+          <a:noFill/>
+        </p:spPr>
+        <p:txBody>
+          <a:bodyPr wrap="square">
+            <a:spAutoFit/>
+          </a:bodyPr>
+          <a:lstStyle/>
+          <a:p>
+            <a:pPr algn="r"/>
+            <a:r>
+              <a:rPr sz="1150" b="1">
+                <a:solidFill>
+                  <a:srgbClr val="D6394B"/>
+                </a:solidFill>
+                <a:latin typeface="Segoe UI"/>
+              </a:rPr>
+              <a:t>0.049</a:t>
+            </a:r>
+          </a:p>
+        </p:txBody>
+      </p:sp>
+      <p:sp>
+        <p:nvSpPr>
+          <p:cNvPr id="33" name="TextBox 32"/>
+          <p:cNvSpPr txBox="1"/>
+          <p:nvPr/>
+        </p:nvSpPr>
+        <p:spPr>
+          <a:xfrm>
+            <a:off x="6720840" y="4764024"/>
+            <a:ext cx="1554480" cy="274320"/>
+          </a:xfrm>
+          <a:prstGeom prst="rect">
+            <a:avLst/>
+          </a:prstGeom>
+          <a:noFill/>
+        </p:spPr>
+        <p:txBody>
+          <a:bodyPr wrap="square">
+            <a:spAutoFit/>
+          </a:bodyPr>
+          <a:lstStyle/>
+          <a:p>
+            <a:r>
+              <a:rPr sz="1100">
+                <a:solidFill>
+                  <a:srgbClr val="64748B"/>
+                </a:solidFill>
+                <a:latin typeface="Segoe UI"/>
+              </a:rPr>
+              <a:t>AI-gen score</a:t>
+            </a:r>
+          </a:p>
+        </p:txBody>
+      </p:sp>
+      <p:sp>
+        <p:nvSpPr>
+          <p:cNvPr id="34" name="Rectangle 33"/>
+          <p:cNvSpPr/>
+          <p:nvPr/>
+        </p:nvSpPr>
+        <p:spPr>
+          <a:xfrm>
+            <a:off x="8321040" y="4809744"/>
+            <a:ext cx="2468879" cy="146304"/>
+          </a:xfrm>
+          <a:prstGeom prst="rect">
+            <a:avLst/>
+          </a:prstGeom>
+          <a:solidFill>
+            <a:srgbClr val="E6ECF5"/>
+          </a:solidFill>
+          <a:ln>
+            <a:noFill/>
+          </a:ln>
+          <a:effectLst/>
+        </p:spPr>
+        <p:style>
+          <a:lnRef idx="1">
+            <a:schemeClr val="accent1"/>
+          </a:lnRef>
+          <a:fillRef idx="3">
+            <a:schemeClr val="accent1"/>
+          </a:fillRef>
+          <a:effectRef idx="2">
+            <a:schemeClr val="accent1"/>
+          </a:effectRef>
+          <a:fontRef idx="minor">
+            <a:schemeClr val="lt1"/>
+          </a:fontRef>
+        </p:style>
+        <p:txBody>
+          <a:bodyPr rtlCol="0" anchor="ctr"/>
+          <a:lstStyle/>
+          <a:p>
+            <a:pPr algn="ctr"/>
+          </a:p>
+        </p:txBody>
+      </p:sp>
+      <p:sp>
+        <p:nvSpPr>
+          <p:cNvPr id="35" name="Rectangle 34"/>
+          <p:cNvSpPr/>
+          <p:nvPr/>
+        </p:nvSpPr>
+        <p:spPr>
+          <a:xfrm>
+            <a:off x="8321040" y="4809744"/>
+            <a:ext cx="2466411" cy="146304"/>
           </a:xfrm>
           <a:prstGeom prst="rect">
             <a:avLst/>
@@ -5336,335 +5960,13 @@
       </p:sp>
       <p:sp>
         <p:nvSpPr>
-          <p:cNvPr id="25" name="Rectangle 24"/>
+          <p:cNvPr id="36" name="Rectangle 35"/>
           <p:cNvSpPr/>
           <p:nvPr/>
         </p:nvSpPr>
         <p:spPr>
           <a:xfrm>
-            <a:off x="9144000" y="2999232"/>
-            <a:ext cx="1211580" cy="384048"/>
-          </a:xfrm>
-          <a:prstGeom prst="rect">
-            <a:avLst/>
-          </a:prstGeom>
-          <a:solidFill>
-            <a:srgbClr val="0E9F6E"/>
-          </a:solidFill>
-          <a:ln>
-            <a:noFill/>
-          </a:ln>
-          <a:effectLst/>
-        </p:spPr>
-        <p:style>
-          <a:lnRef idx="1">
-            <a:schemeClr val="accent1"/>
-          </a:lnRef>
-          <a:fillRef idx="3">
-            <a:schemeClr val="accent1"/>
-          </a:fillRef>
-          <a:effectRef idx="2">
-            <a:schemeClr val="accent1"/>
-          </a:effectRef>
-          <a:fontRef idx="minor">
-            <a:schemeClr val="lt1"/>
-          </a:fontRef>
-        </p:style>
-        <p:txBody>
-          <a:bodyPr rtlCol="0" anchor="ctr"/>
-          <a:lstStyle/>
-          <a:p>
-            <a:pPr algn="ctr"/>
-          </a:p>
-        </p:txBody>
-      </p:sp>
-      <p:sp>
-        <p:nvSpPr>
-          <p:cNvPr id="26" name="Rectangle 25"/>
-          <p:cNvSpPr/>
-          <p:nvPr/>
-        </p:nvSpPr>
-        <p:spPr>
-          <a:xfrm>
-            <a:off x="9749790" y="2999232"/>
-            <a:ext cx="1211580" cy="384048"/>
-          </a:xfrm>
-          <a:prstGeom prst="rect">
-            <a:avLst/>
-          </a:prstGeom>
-          <a:solidFill>
-            <a:srgbClr val="0E9F6E"/>
-          </a:solidFill>
-          <a:ln>
-            <a:noFill/>
-          </a:ln>
-          <a:effectLst/>
-        </p:spPr>
-        <p:style>
-          <a:lnRef idx="1">
-            <a:schemeClr val="accent1"/>
-          </a:lnRef>
-          <a:fillRef idx="3">
-            <a:schemeClr val="accent1"/>
-          </a:fillRef>
-          <a:effectRef idx="2">
-            <a:schemeClr val="accent1"/>
-          </a:effectRef>
-          <a:fontRef idx="minor">
-            <a:schemeClr val="lt1"/>
-          </a:fontRef>
-        </p:style>
-        <p:txBody>
-          <a:bodyPr rtlCol="0" anchor="ctr"/>
-          <a:lstStyle/>
-          <a:p>
-            <a:pPr algn="ctr"/>
-          </a:p>
-        </p:txBody>
-      </p:sp>
-      <p:sp>
-        <p:nvSpPr>
-          <p:cNvPr id="27" name="Rectangle 26"/>
-          <p:cNvSpPr/>
-          <p:nvPr/>
-        </p:nvSpPr>
-        <p:spPr>
-          <a:xfrm>
-            <a:off x="10355580" y="2999232"/>
-            <a:ext cx="1211580" cy="384048"/>
-          </a:xfrm>
-          <a:prstGeom prst="rect">
-            <a:avLst/>
-          </a:prstGeom>
-          <a:solidFill>
-            <a:srgbClr val="0E9F6E"/>
-          </a:solidFill>
-          <a:ln>
-            <a:noFill/>
-          </a:ln>
-          <a:effectLst/>
-        </p:spPr>
-        <p:style>
-          <a:lnRef idx="1">
-            <a:schemeClr val="accent1"/>
-          </a:lnRef>
-          <a:fillRef idx="3">
-            <a:schemeClr val="accent1"/>
-          </a:fillRef>
-          <a:effectRef idx="2">
-            <a:schemeClr val="accent1"/>
-          </a:effectRef>
-          <a:fontRef idx="minor">
-            <a:schemeClr val="lt1"/>
-          </a:fontRef>
-        </p:style>
-        <p:txBody>
-          <a:bodyPr rtlCol="0" anchor="ctr"/>
-          <a:lstStyle/>
-          <a:p>
-            <a:pPr algn="ctr"/>
-          </a:p>
-        </p:txBody>
-      </p:sp>
-      <p:sp>
-        <p:nvSpPr>
-          <p:cNvPr id="28" name="TextBox 27"/>
-          <p:cNvSpPr txBox="1"/>
-          <p:nvPr/>
-        </p:nvSpPr>
-        <p:spPr>
-          <a:xfrm>
-            <a:off x="6720840" y="3438144"/>
-            <a:ext cx="4846320" cy="274320"/>
-          </a:xfrm>
-          <a:prstGeom prst="rect">
-            <a:avLst/>
-          </a:prstGeom>
-          <a:noFill/>
-        </p:spPr>
-        <p:txBody>
-          <a:bodyPr wrap="square">
-            <a:spAutoFit/>
-          </a:bodyPr>
-          <a:lstStyle/>
-          <a:p>
-            <a:r>
-              <a:rPr sz="1050">
-                <a:solidFill>
-                  <a:srgbClr val="64748B"/>
-                </a:solidFill>
-                <a:latin typeface="Segoe UI"/>
-              </a:rPr>
-              <a:t>every 4 s window is real · max segment 0.009</a:t>
-            </a:r>
-          </a:p>
-        </p:txBody>
-      </p:sp>
-      <p:sp>
-        <p:nvSpPr>
-          <p:cNvPr id="29" name="TextBox 28"/>
-          <p:cNvSpPr txBox="1"/>
-          <p:nvPr/>
-        </p:nvSpPr>
-        <p:spPr>
-          <a:xfrm>
-            <a:off x="6720840" y="3675887"/>
-            <a:ext cx="4846320" cy="274320"/>
-          </a:xfrm>
-          <a:prstGeom prst="rect">
-            <a:avLst/>
-          </a:prstGeom>
-          <a:noFill/>
-        </p:spPr>
-        <p:txBody>
-          <a:bodyPr wrap="square">
-            <a:spAutoFit/>
-          </a:bodyPr>
-          <a:lstStyle/>
-          <a:p>
-            <a:r>
-              <a:rPr sz="1100" b="1">
-                <a:solidFill>
-                  <a:srgbClr val="D6394B"/>
-                </a:solidFill>
-                <a:latin typeface="Segoe UI"/>
-              </a:rPr>
-              <a:t>AGGREGATE-BLIND HIJACK — HELD</a:t>
-            </a:r>
-          </a:p>
-        </p:txBody>
-      </p:sp>
-      <p:sp>
-        <p:nvSpPr>
-          <p:cNvPr id="30" name="TextBox 29"/>
-          <p:cNvSpPr txBox="1"/>
-          <p:nvPr/>
-        </p:nvSpPr>
-        <p:spPr>
-          <a:xfrm>
-            <a:off x="6720840" y="3931920"/>
-            <a:ext cx="1554480" cy="274320"/>
-          </a:xfrm>
-          <a:prstGeom prst="rect">
-            <a:avLst/>
-          </a:prstGeom>
-          <a:noFill/>
-        </p:spPr>
-        <p:txBody>
-          <a:bodyPr wrap="square">
-            <a:spAutoFit/>
-          </a:bodyPr>
-          <a:lstStyle/>
-          <a:p>
-            <a:r>
-              <a:rPr sz="1100">
-                <a:solidFill>
-                  <a:srgbClr val="64748B"/>
-                </a:solidFill>
-                <a:latin typeface="Segoe UI"/>
-              </a:rPr>
-              <a:t>voice similarity</a:t>
-            </a:r>
-          </a:p>
-        </p:txBody>
-      </p:sp>
-      <p:sp>
-        <p:nvSpPr>
-          <p:cNvPr id="31" name="Rectangle 30"/>
-          <p:cNvSpPr/>
-          <p:nvPr/>
-        </p:nvSpPr>
-        <p:spPr>
-          <a:xfrm>
-            <a:off x="8321040" y="3977639"/>
-            <a:ext cx="2468879" cy="146304"/>
-          </a:xfrm>
-          <a:prstGeom prst="rect">
-            <a:avLst/>
-          </a:prstGeom>
-          <a:solidFill>
-            <a:srgbClr val="E6ECF5"/>
-          </a:solidFill>
-          <a:ln>
-            <a:noFill/>
-          </a:ln>
-          <a:effectLst/>
-        </p:spPr>
-        <p:style>
-          <a:lnRef idx="1">
-            <a:schemeClr val="accent1"/>
-          </a:lnRef>
-          <a:fillRef idx="3">
-            <a:schemeClr val="accent1"/>
-          </a:fillRef>
-          <a:effectRef idx="2">
-            <a:schemeClr val="accent1"/>
-          </a:effectRef>
-          <a:fontRef idx="minor">
-            <a:schemeClr val="lt1"/>
-          </a:fontRef>
-        </p:style>
-        <p:txBody>
-          <a:bodyPr rtlCol="0" anchor="ctr"/>
-          <a:lstStyle/>
-          <a:p>
-            <a:pPr algn="ctr"/>
-          </a:p>
-        </p:txBody>
-      </p:sp>
-      <p:sp>
-        <p:nvSpPr>
-          <p:cNvPr id="32" name="Rectangle 31"/>
-          <p:cNvSpPr/>
-          <p:nvPr/>
-        </p:nvSpPr>
-        <p:spPr>
-          <a:xfrm>
-            <a:off x="8321040" y="3977639"/>
-            <a:ext cx="1893630" cy="146304"/>
-          </a:xfrm>
-          <a:prstGeom prst="rect">
-            <a:avLst/>
-          </a:prstGeom>
-          <a:solidFill>
-            <a:srgbClr val="0E9F6E"/>
-          </a:solidFill>
-          <a:ln>
-            <a:noFill/>
-          </a:ln>
-          <a:effectLst/>
-        </p:spPr>
-        <p:style>
-          <a:lnRef idx="1">
-            <a:schemeClr val="accent1"/>
-          </a:lnRef>
-          <a:fillRef idx="3">
-            <a:schemeClr val="accent1"/>
-          </a:fillRef>
-          <a:effectRef idx="2">
-            <a:schemeClr val="accent1"/>
-          </a:effectRef>
-          <a:fontRef idx="minor">
-            <a:schemeClr val="lt1"/>
-          </a:fontRef>
-        </p:style>
-        <p:txBody>
-          <a:bodyPr rtlCol="0" anchor="ctr"/>
-          <a:lstStyle/>
-          <a:p>
-            <a:pPr algn="ctr"/>
-          </a:p>
-        </p:txBody>
-      </p:sp>
-      <p:sp>
-        <p:nvSpPr>
-          <p:cNvPr id="33" name="Rectangle 32"/>
-          <p:cNvSpPr/>
-          <p:nvPr/>
-        </p:nvSpPr>
-        <p:spPr>
-          <a:xfrm>
-            <a:off x="9629546" y="3913632"/>
+            <a:off x="9851745" y="4745736"/>
             <a:ext cx="18288" cy="274320"/>
           </a:xfrm>
           <a:prstGeom prst="rect">
@@ -5702,13 +6004,13 @@
       </p:sp>
       <p:sp>
         <p:nvSpPr>
-          <p:cNvPr id="34" name="TextBox 33"/>
+          <p:cNvPr id="37" name="TextBox 36"/>
           <p:cNvSpPr txBox="1"/>
           <p:nvPr/>
         </p:nvSpPr>
         <p:spPr>
           <a:xfrm>
-            <a:off x="10835639" y="3922776"/>
+            <a:off x="10835639" y="4754880"/>
             <a:ext cx="731520" cy="274320"/>
           </a:xfrm>
           <a:prstGeom prst="rect">
@@ -5730,130 +6032,8 @@
                 </a:solidFill>
                 <a:latin typeface="Segoe UI"/>
               </a:rPr>
-              <a:t>0.767</a:t>
-            </a:r>
-          </a:p>
-        </p:txBody>
-      </p:sp>
-      <p:sp>
-        <p:nvSpPr>
-          <p:cNvPr id="35" name="TextBox 34"/>
-          <p:cNvSpPr txBox="1"/>
-          <p:nvPr/>
-        </p:nvSpPr>
-        <p:spPr>
-          <a:xfrm>
-            <a:off x="6720840" y="4261104"/>
-            <a:ext cx="1554480" cy="274320"/>
-          </a:xfrm>
-          <a:prstGeom prst="rect">
-            <a:avLst/>
-          </a:prstGeom>
-          <a:noFill/>
-        </p:spPr>
-        <p:txBody>
-          <a:bodyPr wrap="square">
-            <a:spAutoFit/>
-          </a:bodyPr>
-          <a:lstStyle/>
-          <a:p>
-            <a:r>
-              <a:rPr sz="1100">
-                <a:solidFill>
-                  <a:srgbClr val="64748B"/>
-                </a:solidFill>
-                <a:latin typeface="Segoe UI"/>
-              </a:rPr>
-              <a:t>AI-gen score</a:t>
-            </a:r>
-          </a:p>
-        </p:txBody>
-      </p:sp>
-      <p:sp>
-        <p:nvSpPr>
-          <p:cNvPr id="36" name="Rectangle 35"/>
-          <p:cNvSpPr/>
-          <p:nvPr/>
-        </p:nvSpPr>
-        <p:spPr>
-          <a:xfrm>
-            <a:off x="8321040" y="4306824"/>
-            <a:ext cx="2468879" cy="146304"/>
-          </a:xfrm>
-          <a:prstGeom prst="rect">
-            <a:avLst/>
-          </a:prstGeom>
-          <a:solidFill>
-            <a:srgbClr val="E6ECF5"/>
-          </a:solidFill>
-          <a:ln>
-            <a:noFill/>
-          </a:ln>
-          <a:effectLst/>
-        </p:spPr>
-        <p:style>
-          <a:lnRef idx="1">
-            <a:schemeClr val="accent1"/>
-          </a:lnRef>
-          <a:fillRef idx="3">
-            <a:schemeClr val="accent1"/>
-          </a:fillRef>
-          <a:effectRef idx="2">
-            <a:schemeClr val="accent1"/>
-          </a:effectRef>
-          <a:fontRef idx="minor">
-            <a:schemeClr val="lt1"/>
-          </a:fontRef>
-        </p:style>
-        <p:txBody>
-          <a:bodyPr rtlCol="0" anchor="ctr"/>
-          <a:lstStyle/>
-          <a:p>
-            <a:pPr algn="ctr"/>
-          </a:p>
-        </p:txBody>
-      </p:sp>
-      <p:sp>
-        <p:nvSpPr>
-          <p:cNvPr id="37" name="Rectangle 36"/>
-          <p:cNvSpPr/>
-          <p:nvPr/>
-        </p:nvSpPr>
-        <p:spPr>
-          <a:xfrm>
-            <a:off x="8321040" y="4306824"/>
-            <a:ext cx="832012" cy="146304"/>
-          </a:xfrm>
-          <a:prstGeom prst="rect">
-            <a:avLst/>
-          </a:prstGeom>
-          <a:solidFill>
-            <a:srgbClr val="0E9F6E"/>
-          </a:solidFill>
-          <a:ln>
-            <a:noFill/>
-          </a:ln>
-          <a:effectLst/>
-        </p:spPr>
-        <p:style>
-          <a:lnRef idx="1">
-            <a:schemeClr val="accent1"/>
-          </a:lnRef>
-          <a:fillRef idx="3">
-            <a:schemeClr val="accent1"/>
-          </a:fillRef>
-          <a:effectRef idx="2">
-            <a:schemeClr val="accent1"/>
-          </a:effectRef>
-          <a:fontRef idx="minor">
-            <a:schemeClr val="lt1"/>
-          </a:fontRef>
-        </p:style>
-        <p:txBody>
-          <a:bodyPr rtlCol="0" anchor="ctr"/>
-          <a:lstStyle/>
-          <a:p>
-            <a:pPr algn="ctr"/>
+              <a:t>0.999</a:t>
+            </a:r>
           </a:p>
         </p:txBody>
       </p:sp>
@@ -5865,86 +6045,7 @@
         </p:nvSpPr>
         <p:spPr>
           <a:xfrm>
-            <a:off x="9851745" y="4242816"/>
-            <a:ext cx="18288" cy="274320"/>
-          </a:xfrm>
-          <a:prstGeom prst="rect">
-            <a:avLst/>
-          </a:prstGeom>
-          <a:solidFill>
-            <a:srgbClr val="0F1B2D"/>
-          </a:solidFill>
-          <a:ln>
-            <a:noFill/>
-          </a:ln>
-          <a:effectLst/>
-        </p:spPr>
-        <p:style>
-          <a:lnRef idx="1">
-            <a:schemeClr val="accent1"/>
-          </a:lnRef>
-          <a:fillRef idx="3">
-            <a:schemeClr val="accent1"/>
-          </a:fillRef>
-          <a:effectRef idx="2">
-            <a:schemeClr val="accent1"/>
-          </a:effectRef>
-          <a:fontRef idx="minor">
-            <a:schemeClr val="lt1"/>
-          </a:fontRef>
-        </p:style>
-        <p:txBody>
-          <a:bodyPr rtlCol="0" anchor="ctr"/>
-          <a:lstStyle/>
-          <a:p>
-            <a:pPr algn="ctr"/>
-          </a:p>
-        </p:txBody>
-      </p:sp>
-      <p:sp>
-        <p:nvSpPr>
-          <p:cNvPr id="39" name="TextBox 38"/>
-          <p:cNvSpPr txBox="1"/>
-          <p:nvPr/>
-        </p:nvSpPr>
-        <p:spPr>
-          <a:xfrm>
-            <a:off x="10835639" y="4251960"/>
-            <a:ext cx="731520" cy="274320"/>
-          </a:xfrm>
-          <a:prstGeom prst="rect">
-            <a:avLst/>
-          </a:prstGeom>
-          <a:noFill/>
-        </p:spPr>
-        <p:txBody>
-          <a:bodyPr wrap="square">
-            <a:spAutoFit/>
-          </a:bodyPr>
-          <a:lstStyle/>
-          <a:p>
-            <a:pPr algn="r"/>
-            <a:r>
-              <a:rPr sz="1150" b="1">
-                <a:solidFill>
-                  <a:srgbClr val="0E9F6E"/>
-                </a:solidFill>
-                <a:latin typeface="Segoe UI"/>
-              </a:rPr>
-              <a:t>0.337</a:t>
-            </a:r>
-          </a:p>
-        </p:txBody>
-      </p:sp>
-      <p:sp>
-        <p:nvSpPr>
-          <p:cNvPr id="40" name="Rectangle 39"/>
-          <p:cNvSpPr/>
-          <p:nvPr/>
-        </p:nvSpPr>
-        <p:spPr>
-          <a:xfrm>
-            <a:off x="6702552" y="4626864"/>
+            <a:off x="6702552" y="5129784"/>
             <a:ext cx="4882896" cy="420623"/>
           </a:xfrm>
           <a:prstGeom prst="rect">
@@ -5984,190 +6085,14 @@
       </p:sp>
       <p:sp>
         <p:nvSpPr>
-          <p:cNvPr id="41" name="Rectangle 40"/>
+          <p:cNvPr id="39" name="Rectangle 38"/>
           <p:cNvSpPr/>
           <p:nvPr/>
         </p:nvSpPr>
         <p:spPr>
           <a:xfrm>
-            <a:off x="6720840" y="4645152"/>
-            <a:ext cx="1491175" cy="384048"/>
-          </a:xfrm>
-          <a:prstGeom prst="rect">
-            <a:avLst/>
-          </a:prstGeom>
-          <a:solidFill>
-            <a:srgbClr val="0E9F6E"/>
-          </a:solidFill>
-          <a:ln>
-            <a:noFill/>
-          </a:ln>
-          <a:effectLst/>
-        </p:spPr>
-        <p:style>
-          <a:lnRef idx="1">
-            <a:schemeClr val="accent1"/>
-          </a:lnRef>
-          <a:fillRef idx="3">
-            <a:schemeClr val="accent1"/>
-          </a:fillRef>
-          <a:effectRef idx="2">
-            <a:schemeClr val="accent1"/>
-          </a:effectRef>
-          <a:fontRef idx="minor">
-            <a:schemeClr val="lt1"/>
-          </a:fontRef>
-        </p:style>
-        <p:txBody>
-          <a:bodyPr rtlCol="0" anchor="ctr"/>
-          <a:lstStyle/>
-          <a:p>
-            <a:pPr algn="ctr"/>
-          </a:p>
-        </p:txBody>
-      </p:sp>
-      <p:sp>
-        <p:nvSpPr>
-          <p:cNvPr id="42" name="Rectangle 41"/>
-          <p:cNvSpPr/>
-          <p:nvPr/>
-        </p:nvSpPr>
-        <p:spPr>
-          <a:xfrm>
-            <a:off x="7466427" y="4645152"/>
-            <a:ext cx="1491175" cy="384048"/>
-          </a:xfrm>
-          <a:prstGeom prst="rect">
-            <a:avLst/>
-          </a:prstGeom>
-          <a:solidFill>
-            <a:srgbClr val="0E9F6E"/>
-          </a:solidFill>
-          <a:ln>
-            <a:noFill/>
-          </a:ln>
-          <a:effectLst/>
-        </p:spPr>
-        <p:style>
-          <a:lnRef idx="1">
-            <a:schemeClr val="accent1"/>
-          </a:lnRef>
-          <a:fillRef idx="3">
-            <a:schemeClr val="accent1"/>
-          </a:fillRef>
-          <a:effectRef idx="2">
-            <a:schemeClr val="accent1"/>
-          </a:effectRef>
-          <a:fontRef idx="minor">
-            <a:schemeClr val="lt1"/>
-          </a:fontRef>
-        </p:style>
-        <p:txBody>
-          <a:bodyPr rtlCol="0" anchor="ctr"/>
-          <a:lstStyle/>
-          <a:p>
-            <a:pPr algn="ctr"/>
-          </a:p>
-        </p:txBody>
-      </p:sp>
-      <p:sp>
-        <p:nvSpPr>
-          <p:cNvPr id="43" name="Rectangle 42"/>
-          <p:cNvSpPr/>
-          <p:nvPr/>
-        </p:nvSpPr>
-        <p:spPr>
-          <a:xfrm>
-            <a:off x="8212015" y="4645152"/>
-            <a:ext cx="1491175" cy="384048"/>
-          </a:xfrm>
-          <a:prstGeom prst="rect">
-            <a:avLst/>
-          </a:prstGeom>
-          <a:solidFill>
-            <a:srgbClr val="0E9F6E"/>
-          </a:solidFill>
-          <a:ln>
-            <a:noFill/>
-          </a:ln>
-          <a:effectLst/>
-        </p:spPr>
-        <p:style>
-          <a:lnRef idx="1">
-            <a:schemeClr val="accent1"/>
-          </a:lnRef>
-          <a:fillRef idx="3">
-            <a:schemeClr val="accent1"/>
-          </a:fillRef>
-          <a:effectRef idx="2">
-            <a:schemeClr val="accent1"/>
-          </a:effectRef>
-          <a:fontRef idx="minor">
-            <a:schemeClr val="lt1"/>
-          </a:fontRef>
-        </p:style>
-        <p:txBody>
-          <a:bodyPr rtlCol="0" anchor="ctr"/>
-          <a:lstStyle/>
-          <a:p>
-            <a:pPr algn="ctr"/>
-          </a:p>
-        </p:txBody>
-      </p:sp>
-      <p:sp>
-        <p:nvSpPr>
-          <p:cNvPr id="44" name="Rectangle 43"/>
-          <p:cNvSpPr/>
-          <p:nvPr/>
-        </p:nvSpPr>
-        <p:spPr>
-          <a:xfrm>
-            <a:off x="8957603" y="4645152"/>
-            <a:ext cx="745587" cy="384048"/>
-          </a:xfrm>
-          <a:prstGeom prst="rect">
-            <a:avLst/>
-          </a:prstGeom>
-          <a:solidFill>
-            <a:srgbClr val="0E9F6E"/>
-          </a:solidFill>
-          <a:ln>
-            <a:noFill/>
-          </a:ln>
-          <a:effectLst/>
-        </p:spPr>
-        <p:style>
-          <a:lnRef idx="1">
-            <a:schemeClr val="accent1"/>
-          </a:lnRef>
-          <a:fillRef idx="3">
-            <a:schemeClr val="accent1"/>
-          </a:fillRef>
-          <a:effectRef idx="2">
-            <a:schemeClr val="accent1"/>
-          </a:effectRef>
-          <a:fontRef idx="minor">
-            <a:schemeClr val="lt1"/>
-          </a:fontRef>
-        </p:style>
-        <p:txBody>
-          <a:bodyPr rtlCol="0" anchor="ctr"/>
-          <a:lstStyle/>
-          <a:p>
-            <a:pPr algn="ctr"/>
-          </a:p>
-        </p:txBody>
-      </p:sp>
-      <p:sp>
-        <p:nvSpPr>
-          <p:cNvPr id="45" name="Rectangle 44"/>
-          <p:cNvSpPr/>
-          <p:nvPr/>
-        </p:nvSpPr>
-        <p:spPr>
-          <a:xfrm>
-            <a:off x="9703190" y="4645152"/>
-            <a:ext cx="745587" cy="384048"/>
+            <a:off x="6720840" y="5148072"/>
+            <a:ext cx="1938528" cy="384048"/>
           </a:xfrm>
           <a:prstGeom prst="rect">
             <a:avLst/>
@@ -6204,14 +6129,14 @@
       </p:sp>
       <p:sp>
         <p:nvSpPr>
-          <p:cNvPr id="46" name="Rectangle 45"/>
+          <p:cNvPr id="40" name="Rectangle 39"/>
           <p:cNvSpPr/>
           <p:nvPr/>
         </p:nvSpPr>
         <p:spPr>
           <a:xfrm>
-            <a:off x="10448778" y="4645152"/>
-            <a:ext cx="745587" cy="384048"/>
+            <a:off x="8659367" y="5148072"/>
+            <a:ext cx="484632" cy="384048"/>
           </a:xfrm>
           <a:prstGeom prst="rect">
             <a:avLst/>
@@ -6248,57 +6173,13 @@
       </p:sp>
       <p:sp>
         <p:nvSpPr>
-          <p:cNvPr id="47" name="Rectangle 46"/>
-          <p:cNvSpPr/>
-          <p:nvPr/>
-        </p:nvSpPr>
-        <p:spPr>
-          <a:xfrm>
-            <a:off x="11194366" y="4645152"/>
-            <a:ext cx="372793" cy="384048"/>
-          </a:xfrm>
-          <a:prstGeom prst="rect">
-            <a:avLst/>
-          </a:prstGeom>
-          <a:solidFill>
-            <a:srgbClr val="D6394B"/>
-          </a:solidFill>
-          <a:ln>
-            <a:noFill/>
-          </a:ln>
-          <a:effectLst/>
-        </p:spPr>
-        <p:style>
-          <a:lnRef idx="1">
-            <a:schemeClr val="accent1"/>
-          </a:lnRef>
-          <a:fillRef idx="3">
-            <a:schemeClr val="accent1"/>
-          </a:fillRef>
-          <a:effectRef idx="2">
-            <a:schemeClr val="accent1"/>
-          </a:effectRef>
-          <a:fontRef idx="minor">
-            <a:schemeClr val="lt1"/>
-          </a:fontRef>
-        </p:style>
-        <p:txBody>
-          <a:bodyPr rtlCol="0" anchor="ctr"/>
-          <a:lstStyle/>
-          <a:p>
-            <a:pPr algn="ctr"/>
-          </a:p>
-        </p:txBody>
-      </p:sp>
-      <p:sp>
-        <p:nvSpPr>
-          <p:cNvPr id="48" name="TextBox 47"/>
+          <p:cNvPr id="41" name="TextBox 40"/>
           <p:cNvSpPr txBox="1"/>
           <p:nvPr/>
         </p:nvSpPr>
         <p:spPr>
           <a:xfrm>
-            <a:off x="6720840" y="5084064"/>
+            <a:off x="6720840" y="5586983"/>
             <a:ext cx="4846320" cy="274320"/>
           </a:xfrm>
           <a:prstGeom prst="rect">
@@ -6319,21 +6200,21 @@
                 </a:solidFill>
                 <a:latin typeface="Segoe UI"/>
               </a:rPr>
-              <a:t>aggregate says “real” (0.337) — segment max 0.999 at 8–13 s → HOLD</a:t>
-            </a:r>
-          </a:p>
-        </p:txBody>
-      </p:sp>
-      <p:sp>
-        <p:nvSpPr>
-          <p:cNvPr id="49" name="TextBox 48"/>
+              <a:t>engine-2 pitch-converted TTS: segs 0.999 / 0.9993 → HOLD</a:t>
+            </a:r>
+          </a:p>
+        </p:txBody>
+      </p:sp>
+      <p:sp>
+        <p:nvSpPr>
+          <p:cNvPr id="42" name="TextBox 41"/>
           <p:cNvSpPr txBox="1"/>
           <p:nvPr/>
         </p:nvSpPr>
         <p:spPr>
           <a:xfrm>
-            <a:off x="6720840" y="5449824"/>
-            <a:ext cx="4846320" cy="822960"/>
+            <a:off x="6720840" y="5870448"/>
+            <a:ext cx="4846320" cy="457200"/>
           </a:xfrm>
           <a:prstGeom prst="rect">
             <a:avLst/>
@@ -6347,22 +6228,31 @@
           <a:lstStyle/>
           <a:p>
             <a:r>
-              <a:rPr sz="1150" b="1">
+              <a:rPr sz="1100" b="0">
+                <a:solidFill>
+                  <a:srgbClr val="33415C"/>
+                </a:solidFill>
+                <a:latin typeface="Segoe UI"/>
+              </a:rPr>
+              <a:t>Telephony-band variant of the same attack: still </a:t>
+            </a:r>
+            <a:r>
+              <a:rPr sz="1100" b="1">
                 <a:solidFill>
                   <a:srgbClr val="0F1B2D"/>
                 </a:solidFill>
                 <a:latin typeface="Segoe UI"/>
               </a:rPr>
-              <a:t>An aggregate-only policy approves this call.</a:t>
-            </a:r>
-            <a:r>
-              <a:rPr sz="1150" b="0">
+              <a:t>0.998</a:t>
+            </a:r>
+            <a:r>
+              <a:rPr sz="1100" b="0">
                 <a:solidFill>
                   <a:srgbClr val="33415C"/>
                 </a:solidFill>
                 <a:latin typeface="Segoe UI"/>
               </a:rPr>
-              <a:t> Voice identity passed and the whole-call score said real; only the segment view caught the clone.</a:t>
+              <a:t> — band-limiting helps detection.</a:t>
             </a:r>
           </a:p>
         </p:txBody>
@@ -6570,7 +6460,7 @@
                 </a:solidFill>
                 <a:latin typeface="Segoe UI"/>
               </a:rPr>
-              <a:t>Judge link: https://unclone-verified-agent.onrender.com   ·   demo: genuine → PROCEEDS · hijack → HELD · subtle hijack → HELD · silent → STEP UP</a:t>
+              <a:t>Judge link: https://unclone-verified-agent.onrender.com   ·   in-product docs: Impact · Calibration · Scale &amp; Viability pages</a:t>
             </a:r>
           </a:p>
         </p:txBody>
@@ -6584,7 +6474,7 @@
         <p:spPr>
           <a:xfrm>
             <a:off x="640080" y="1783080"/>
-            <a:ext cx="6766560" cy="4206240"/>
+            <a:ext cx="6766560" cy="4480560"/>
           </a:xfrm>
           <a:prstGeom prst="rect">
             <a:avLst/>
@@ -6603,22 +6493,40 @@
               </a:spcAft>
             </a:pPr>
             <a:r>
-              <a:rPr sz="1500" b="1">
+              <a:rPr sz="1400" b="1">
                 <a:solidFill>
                   <a:srgbClr val="0F1B2D"/>
                 </a:solidFill>
                 <a:latin typeface="Segoe UI"/>
               </a:rPr>
-              <a:t>Who it protects: </a:t>
-            </a:r>
-            <a:r>
-              <a:rPr sz="1500" b="0">
+              <a:t>The model, five visible inputs: </a:t>
+            </a:r>
+            <a:r>
+              <a:rPr sz="1400" b="0">
                 <a:solidFill>
                   <a:srgbClr val="33415C"/>
                 </a:solidFill>
                 <a:latin typeface="Segoe UI"/>
               </a:rPr>
-              <a:t>every customer on an outbound bank, NBFC or insurer confirmation call — the exact moment this fraud class targets.</a:t>
+              <a:t>1.56 M flagged calls/yr [A] × 1.33 % incidence [FTC/UK-APP] × $5,700 avg loss [FTC] × 80 % detection [calibration] × 70 % step-up conversion [A] ≈ </a:t>
+            </a:r>
+            <a:r>
+              <a:rPr sz="1400" b="1">
+                <a:solidFill>
+                  <a:srgbClr val="0F1B2D"/>
+                </a:solidFill>
+                <a:latin typeface="Segoe UI"/>
+              </a:rPr>
+              <a:t>$66 M / yr prevented per mid-size bank</a:t>
+            </a:r>
+            <a:r>
+              <a:rPr sz="1400" b="0">
+                <a:solidFill>
+                  <a:srgbClr val="33415C"/>
+                </a:solidFill>
+                <a:latin typeface="Segoe UI"/>
+              </a:rPr>
+              <a:t>.</a:t>
             </a:r>
           </a:p>
           <a:p>
@@ -6628,40 +6536,76 @@
               </a:spcAft>
             </a:pPr>
             <a:r>
-              <a:rPr sz="1500" b="1">
+              <a:rPr sz="1400" b="1">
                 <a:solidFill>
                   <a:srgbClr val="0F1B2D"/>
                 </a:solidFill>
                 <a:latin typeface="Segoe UI"/>
               </a:rPr>
-              <a:t>What changes: </a:t>
-            </a:r>
-            <a:r>
-              <a:rPr sz="1500" b="0">
+              <a:t>The number the deck was missing — precision at prevalence: </a:t>
+            </a:r>
+            <a:r>
+              <a:rPr sz="1400" b="0">
                 <a:solidFill>
                   <a:srgbClr val="33415C"/>
                 </a:solidFill>
                 <a:latin typeface="Segoe UI"/>
               </a:rPr>
-              <a:t>the imposter call ends </a:t>
-            </a:r>
-            <a:r>
-              <a:rPr sz="1500" b="1">
+              <a:t>screening flagged traffic gives ~</a:t>
+            </a:r>
+            <a:r>
+              <a:rPr sz="1400" b="1">
                 <a:solidFill>
                   <a:srgbClr val="0F1B2D"/>
                 </a:solidFill>
                 <a:latin typeface="Segoe UI"/>
               </a:rPr>
-              <a:t>before</a:t>
-            </a:r>
-            <a:r>
-              <a:rPr sz="1500" b="0">
+              <a:t>52 %</a:t>
+            </a:r>
+            <a:r>
+              <a:rPr sz="1400" b="0">
                 <a:solidFill>
                   <a:srgbClr val="33415C"/>
                 </a:solidFill>
                 <a:latin typeface="Segoe UI"/>
               </a:rPr>
-              <a:t> the customer speaks a single secret; the genuine call gets a visible trust signal instead of anxiety.</a:t>
+              <a:t> precision at 80 % recall / 1 % FPR, ≈ </a:t>
+            </a:r>
+            <a:r>
+              <a:rPr sz="1400" b="1">
+                <a:solidFill>
+                  <a:srgbClr val="0F1B2D"/>
+                </a:solidFill>
+                <a:latin typeface="Segoe UI"/>
+              </a:rPr>
+              <a:t>10 false alarms per 1,000</a:t>
+            </a:r>
+            <a:r>
+              <a:rPr sz="1400" b="0">
+                <a:solidFill>
+                  <a:srgbClr val="33415C"/>
+                </a:solidFill>
+                <a:latin typeface="Segoe UI"/>
+              </a:rPr>
+              <a:t> genuine flagged calls — one false step-up per real catch. The same rates on the full inbound firehose give ~7 %: </a:t>
+            </a:r>
+            <a:r>
+              <a:rPr sz="1400" b="1">
+                <a:solidFill>
+                  <a:srgbClr val="0F1B2D"/>
+                </a:solidFill>
+                <a:latin typeface="Segoe UI"/>
+              </a:rPr>
+              <a:t>screen flagged traffic, not the firehose</a:t>
+            </a:r>
+            <a:r>
+              <a:rPr sz="1400" b="0">
+                <a:solidFill>
+                  <a:srgbClr val="33415C"/>
+                </a:solidFill>
+                <a:latin typeface="Segoe UI"/>
+              </a:rPr>
+              <a:t> is the design thesis.</a:t>
             </a:r>
           </a:p>
           <a:p>
@@ -6671,22 +6615,31 @@
               </a:spcAft>
             </a:pPr>
             <a:r>
-              <a:rPr sz="1500" b="1">
+              <a:rPr sz="1400" b="1">
                 <a:solidFill>
                   <a:srgbClr val="0F1B2D"/>
                 </a:solidFill>
                 <a:latin typeface="Segoe UI"/>
               </a:rPr>
-              <a:t>Measured on the working prototype: </a:t>
-            </a:r>
-            <a:r>
-              <a:rPr sz="1500" b="0">
+              <a:t>Latency, measured: </a:t>
+            </a:r>
+            <a:r>
+              <a:rPr sz="1400" b="1">
+                <a:solidFill>
+                  <a:srgbClr val="0F1B2D"/>
+                </a:solidFill>
+                <a:latin typeface="Segoe UI"/>
+              </a:rPr>
+              <a:t>p50 0.6–2.6 s</a:t>
+            </a:r>
+            <a:r>
+              <a:rPr sz="1400" b="0">
                 <a:solidFill>
                   <a:srgbClr val="33415C"/>
                 </a:solidFill>
                 <a:latin typeface="Segoe UI"/>
               </a:rPr>
-              <a:t>2.0–2.5 s per window · all four outcomes demonstrated live · 15–60 s enrollment · ~100 credits per combined check.</a:t>
+              <a:t> per window on the deployed build; the intervention point is the payment authorisation — inside the window. L3 telephony (blocking mid-conversation) is declared future work.</a:t>
             </a:r>
           </a:p>
           <a:p>
@@ -6696,40 +6649,22 @@
               </a:spcAft>
             </a:pPr>
             <a:r>
-              <a:rPr sz="1500" b="1">
+              <a:rPr sz="1400" b="1">
                 <a:solidFill>
                   <a:srgbClr val="0F1B2D"/>
                 </a:solidFill>
                 <a:latin typeface="Segoe UI"/>
               </a:rPr>
-              <a:t>False-alarm posture: </a:t>
-            </a:r>
-            <a:r>
-              <a:rPr sz="1500" b="0">
+              <a:t>Customer cost bounded: </a:t>
+            </a:r>
+            <a:r>
+              <a:rPr sz="1400" b="0">
                 <a:solidFill>
                   <a:srgbClr val="33415C"/>
                 </a:solidFill>
                 <a:latin typeface="Segoe UI"/>
               </a:rPr>
-              <a:t>thin evidence </a:t>
-            </a:r>
-            <a:r>
-              <a:rPr sz="1500" b="1">
-                <a:solidFill>
-                  <a:srgbClr val="0F1B2D"/>
-                </a:solidFill>
-                <a:latin typeface="Segoe UI"/>
-              </a:rPr>
-              <a:t>steps up</a:t>
-            </a:r>
-            <a:r>
-              <a:rPr sz="1500" b="0">
-                <a:solidFill>
-                  <a:srgbClr val="33415C"/>
-                </a:solidFill>
-                <a:latin typeface="Segoe UI"/>
-              </a:rPr>
-              <a:t> to in-app confirmation — the customer is never locked out, and fraud is never auto-approved.</a:t>
+              <a:t>a false hold ends the call — the customer uses the app. Inconvenience, never lockout.</a:t>
             </a:r>
           </a:p>
         </p:txBody>
@@ -6742,8 +6677,8 @@
         </p:nvSpPr>
         <p:spPr>
           <a:xfrm>
-            <a:off x="7726679" y="2331720"/>
-            <a:ext cx="3840480" cy="1600200"/>
+            <a:off x="7726679" y="2011680"/>
+            <a:ext cx="3840480" cy="1828800"/>
           </a:xfrm>
           <a:prstGeom prst="rect">
             <a:avLst/>
@@ -6788,8 +6723,8 @@
         </p:nvSpPr>
         <p:spPr>
           <a:xfrm>
-            <a:off x="7909560" y="2487168"/>
-            <a:ext cx="3474720" cy="1371600"/>
+            <a:off x="7909560" y="2176272"/>
+            <a:ext cx="3474720" cy="1554480"/>
           </a:xfrm>
           <a:prstGeom prst="rect">
             <a:avLst/>
@@ -6803,13 +6738,13 @@
           <a:lstStyle/>
           <a:p>
             <a:r>
-              <a:rPr sz="4400" b="1">
+              <a:rPr sz="4600" b="1">
                 <a:solidFill>
                   <a:srgbClr val="0E9F6E"/>
                 </a:solidFill>
                 <a:latin typeface="Segoe UI"/>
               </a:rPr>
-              <a:t>~10,000</a:t>
+              <a:t>$0.87</a:t>
             </a:r>
           </a:p>
           <a:p>
@@ -6820,25 +6755,7 @@
                 </a:solidFill>
                 <a:latin typeface="Segoe UI"/>
               </a:rPr>
-              <a:t>checks funded by </a:t>
-            </a:r>
-            <a:r>
-              <a:rPr sz="1250" b="1">
-                <a:solidFill>
-                  <a:srgbClr val="0F1B2D"/>
-                </a:solidFill>
-                <a:latin typeface="Segoe UI"/>
-              </a:rPr>
-              <a:t>one prevented scam</a:t>
-            </a:r>
-            <a:r>
-              <a:rPr sz="1250" b="0">
-                <a:solidFill>
-                  <a:srgbClr val="33415C"/>
-                </a:solidFill>
-                <a:latin typeface="Segoe UI"/>
-              </a:rPr>
-              <a:t> — a $3,000 typical impersonation loss against the ~$0.30/call market benchmark.</a:t>
+              <a:t>cost per caught fraud — ≈ $0.45 per analysed flagged call ÷ 52 % precision, against a $5,700 average loss.</a:t>
             </a:r>
           </a:p>
         </p:txBody>
@@ -6890,7 +6807,25 @@
                 </a:solidFill>
                 <a:latin typeface="Segoe UI"/>
               </a:rPr>
-              <a:t> of a bank-branded fraud call — the loss customers blame on the bank, not the attacker.</a:t>
+              <a:t> of a bank-branded fraud call. Full model with every assumption tagged: the </a:t>
+            </a:r>
+            <a:r>
+              <a:rPr sz="1200" b="1">
+                <a:solidFill>
+                  <a:srgbClr val="0F1B2D"/>
+                </a:solidFill>
+                <a:latin typeface="Segoe UI"/>
+              </a:rPr>
+              <a:t>Impact</a:t>
+            </a:r>
+            <a:r>
+              <a:rPr sz="1200" b="0">
+                <a:solidFill>
+                  <a:srgbClr val="33415C"/>
+                </a:solidFill>
+                <a:latin typeface="Segoe UI"/>
+              </a:rPr>
+              <a:t> page in the product.</a:t>
             </a:r>
           </a:p>
         </p:txBody>
@@ -7098,7 +7033,7 @@
                 </a:solidFill>
                 <a:latin typeface="Segoe UI"/>
               </a:rPr>
-              <a:t>Judge link: https://unclone-verified-agent.onrender.com   ·   demo: genuine → PROCEEDS · hijack → HELD · subtle hijack → HELD · silent → STEP UP</a:t>
+              <a:t>Judge link: https://unclone-verified-agent.onrender.com   ·   in-product docs: Impact · Calibration · Scale &amp; Viability pages</a:t>
             </a:r>
           </a:p>
         </p:txBody>
@@ -7137,7 +7072,7 @@
                 </a:solidFill>
                 <a:latin typeface="Segoe UI"/>
               </a:rPr>
-              <a:t>Who pays: </a:t>
+              <a:t>Who pays, and why a user-side verifier wins the channel conflict: </a:t>
             </a:r>
             <a:r>
               <a:rPr sz="1300" b="0">
@@ -7146,7 +7081,43 @@
                 </a:solidFill>
                 <a:latin typeface="Segoe UI"/>
               </a:rPr>
-              <a:t>the bank's fraud / scam-prevention team, with contact-center operations. Distribution through CCaaS platforms (Genesys, Amazon Connect) and BPOs. Wedge: high-risk workflows — account recovery, contact-detail and beneficiary changes, high-value confirmation. Priced per analysed high-risk interaction (~$0.30/call benchmark).</a:t>
+              <a:t>the bank's fraud-ops + digital-channels team. The conflict (revenue wants the call; risk stops it) is resolved </a:t>
+            </a:r>
+            <a:r>
+              <a:rPr sz="1300" b="1">
+                <a:solidFill>
+                  <a:srgbClr val="0F1B2D"/>
+                </a:solidFill>
+                <a:latin typeface="Segoe UI"/>
+              </a:rPr>
+              <a:t>structurally</a:t>
+            </a:r>
+            <a:r>
+              <a:rPr sz="1300" b="0">
+                <a:solidFill>
+                  <a:srgbClr val="33415C"/>
+                </a:solidFill>
+                <a:latin typeface="Segoe UI"/>
+              </a:rPr>
+              <a:t>: the verifier is the </a:t>
+            </a:r>
+            <a:r>
+              <a:rPr sz="1300" b="1">
+                <a:solidFill>
+                  <a:srgbClr val="0F1B2D"/>
+                </a:solidFill>
+                <a:latin typeface="Segoe UI"/>
+              </a:rPr>
+              <a:t>customer's</a:t>
+            </a:r>
+            <a:r>
+              <a:rPr sz="1300" b="0">
+                <a:solidFill>
+                  <a:srgbClr val="33415C"/>
+                </a:solidFill>
+                <a:latin typeface="Segoe UI"/>
+              </a:rPr>
+              <a:t> control, so it protects the one case the contact centre cannot see — a perfect clone of the agent's own voice — and produces the decision log regulators ask for.</a:t>
             </a:r>
           </a:p>
           <a:p>
@@ -7162,7 +7133,7 @@
                 </a:solidFill>
                 <a:latin typeface="Segoe UI"/>
               </a:rPr>
-              <a:t>Day-1 question — answered: </a:t>
+              <a:t>Distribution: </a:t>
             </a:r>
             <a:r>
               <a:rPr sz="1300" b="0">
@@ -7171,43 +7142,7 @@
                 </a:solidFill>
                 <a:latin typeface="Segoe UI"/>
               </a:rPr>
-              <a:t>“Where do you get the training dataset?” </a:t>
-            </a:r>
-            <a:r>
-              <a:rPr sz="1300" b="1">
-                <a:solidFill>
-                  <a:srgbClr val="0F1B2D"/>
-                </a:solidFill>
-                <a:latin typeface="Segoe UI"/>
-              </a:rPr>
-              <a:t>We don't train.</a:t>
-            </a:r>
-            <a:r>
-              <a:rPr sz="1300" b="0">
-                <a:solidFill>
-                  <a:srgbClr val="33415C"/>
-                </a:solidFill>
-                <a:latin typeface="Segoe UI"/>
-              </a:rPr>
-              <a:t> 15–60 s of the bank's own agent voice is enrolled against pretrained models; the bank already records its agents for compliance. No corpus, no training pipeline, </a:t>
-            </a:r>
-            <a:r>
-              <a:rPr sz="1300" b="1">
-                <a:solidFill>
-                  <a:srgbClr val="0F1B2D"/>
-                </a:solidFill>
-                <a:latin typeface="Segoe UI"/>
-              </a:rPr>
-              <a:t>no cold start</a:t>
-            </a:r>
-            <a:r>
-              <a:rPr sz="1300" b="0">
-                <a:solidFill>
-                  <a:srgbClr val="33415C"/>
-                </a:solidFill>
-                <a:latin typeface="Segoe UI"/>
-              </a:rPr>
-              <a:t> — a paid pilot starts in days.</a:t>
+              <a:t>SDK in the bank's app (where the step-up prompt already lives), then CCaaS. Telephony is the later expansion.</a:t>
             </a:r>
           </a:p>
           <a:p>
@@ -7223,7 +7158,16 @@
                 </a:solidFill>
                 <a:latin typeface="Segoe UI"/>
               </a:rPr>
-              <a:t>Privacy by design: </a:t>
+              <a:t>Day-1 question — answered productised: </a:t>
+            </a:r>
+            <a:r>
+              <a:rPr sz="1300" b="1">
+                <a:solidFill>
+                  <a:srgbClr val="0F1B2D"/>
+                </a:solidFill>
+                <a:latin typeface="Segoe UI"/>
+              </a:rPr>
+              <a:t>we don't train.</a:t>
             </a:r>
             <a:r>
               <a:rPr sz="1300" b="0">
@@ -7232,7 +7176,32 @@
                 </a:solidFill>
                 <a:latin typeface="Segoe UI"/>
               </a:rPr>
-              <a:t>embeddings only, consent / employment basis (DPDP), on-prem option, retention and offboarding policy.</a:t>
+              <a:t> The runbook (Scale page): source = the bank's own compliance recordings of the payment-desk roster; basis = same privacy basis as the recordings; store = vendor template only, we hold ids and scores; delete = one call per offboarding agent, evidenced in the log.</a:t>
+            </a:r>
+          </a:p>
+          <a:p>
+            <a:pPr>
+              <a:spcAft>
+                <a:spcPts val="900"/>
+              </a:spcAft>
+            </a:pPr>
+            <a:r>
+              <a:rPr sz="1300" b="1">
+                <a:solidFill>
+                  <a:srgbClr val="0F1B2D"/>
+                </a:solidFill>
+                <a:latin typeface="Segoe UI"/>
+              </a:rPr>
+              <a:t>Pilot: </a:t>
+            </a:r>
+            <a:r>
+              <a:rPr sz="1300" b="0">
+                <a:solidFill>
+                  <a:srgbClr val="33415C"/>
+                </a:solidFill>
+                <a:latin typeface="Segoe UI"/>
+              </a:rPr>
+              <a:t>above-limit flagged calls · metric = prevented loss with false-step-up ≤ 2 % · 6 weeks · success = ≥1 prevented incident with a full decision log.</a:t>
             </a:r>
           </a:p>
         </p:txBody>
@@ -7246,7 +7215,7 @@
         <p:spPr>
           <a:xfrm>
             <a:off x="6629400" y="1737360"/>
-            <a:ext cx="4937760" cy="4480560"/>
+            <a:ext cx="4937760" cy="365760"/>
           </a:xfrm>
           <a:prstGeom prst="rect">
             <a:avLst/>
@@ -7266,7 +7235,7 @@
                 </a:solidFill>
                 <a:latin typeface="Segoe UI"/>
               </a:rPr>
-              <a:t>Risks, named with mitigations</a:t>
+              <a:t>What is verified vs what remains honest</a:t>
             </a:r>
           </a:p>
         </p:txBody>
@@ -7279,8 +7248,8 @@
         </p:nvSpPr>
         <p:spPr>
           <a:xfrm>
-            <a:off x="6629400" y="2212848"/>
-            <a:ext cx="4937760" cy="548640"/>
+            <a:off x="6629400" y="2194560"/>
+            <a:ext cx="4937760" cy="914400"/>
           </a:xfrm>
           <a:prstGeom prst="rect">
             <a:avLst/>
@@ -7294,13 +7263,13 @@
           <a:lstStyle/>
           <a:p>
             <a:r>
-              <a:rPr sz="1200" b="1">
-                <a:solidFill>
-                  <a:srgbClr val="D6394B"/>
-                </a:solidFill>
-                <a:latin typeface="Segoe UI"/>
-              </a:rPr>
-              <a:t>Latency — </a:t>
+              <a:rPr sz="1250" b="1">
+                <a:solidFill>
+                  <a:srgbClr val="0E9F6E"/>
+                </a:solidFill>
+                <a:latin typeface="Segoe UI"/>
+              </a:rPr>
+              <a:t>Verified live</a:t>
             </a:r>
             <a:r>
               <a:rPr sz="1200" b="0">
@@ -7309,7 +7278,7 @@
                 </a:solidFill>
                 <a:latin typeface="Segoe UI"/>
               </a:rPr>
-              <a:t>2.0–2.5 s window; the decision lands before the transaction step</a:t>
+              <a:t>genuine → PROCEEDS · hijack → HELD (call terminated) · subtle → HELD · silent → STEP UP · replay → HELD · render → STEP UP</a:t>
             </a:r>
           </a:p>
         </p:txBody>
@@ -7322,8 +7291,8 @@
         </p:nvSpPr>
         <p:spPr>
           <a:xfrm>
-            <a:off x="6629400" y="2779776"/>
-            <a:ext cx="4937760" cy="548640"/>
+            <a:off x="6629400" y="3127248"/>
+            <a:ext cx="4937760" cy="914400"/>
           </a:xfrm>
           <a:prstGeom prst="rect">
             <a:avLst/>
@@ -7337,13 +7306,13 @@
           <a:lstStyle/>
           <a:p>
             <a:r>
-              <a:rPr sz="1200" b="1">
-                <a:solidFill>
-                  <a:srgbClr val="D6394B"/>
-                </a:solidFill>
-                <a:latin typeface="Segoe UI"/>
-              </a:rPr>
-              <a:t>False positives — </a:t>
+              <a:rPr sz="1250" b="1">
+                <a:solidFill>
+                  <a:srgbClr val="C88600"/>
+                </a:solidFill>
+                <a:latin typeface="Segoe UI"/>
+              </a:rPr>
+              <a:t>Measurably open</a:t>
             </a:r>
             <a:r>
               <a:rPr sz="1200" b="0">
@@ -7352,7 +7321,7 @@
                 </a:solidFill>
                 <a:latin typeface="Segoe UI"/>
               </a:rPr>
-              <a:t>auto-approve needs margin; otherwise step up — never auto-block</a:t>
+              <a:t>FAR/FRR vs unseen real speakers · second true TTS engine · mic flow rehearsed live</a:t>
             </a:r>
           </a:p>
         </p:txBody>
@@ -7365,8 +7334,8 @@
         </p:nvSpPr>
         <p:spPr>
           <a:xfrm>
-            <a:off x="6629400" y="3346704"/>
-            <a:ext cx="4937760" cy="548640"/>
+            <a:off x="6629400" y="4059935"/>
+            <a:ext cx="4937760" cy="914400"/>
           </a:xfrm>
           <a:prstGeom prst="rect">
             <a:avLst/>
@@ -7380,13 +7349,13 @@
           <a:lstStyle/>
           <a:p>
             <a:r>
-              <a:rPr sz="1200" b="1">
+              <a:rPr sz="1250" b="1">
                 <a:solidFill>
                   <a:srgbClr val="D6394B"/>
                 </a:solidFill>
                 <a:latin typeface="Segoe UI"/>
               </a:rPr>
-              <a:t>Adversarial TTS — </a:t>
+              <a:t>Declared future work</a:t>
             </a:r>
             <a:r>
               <a:rPr sz="1200" b="0">
@@ -7395,7 +7364,7 @@
                 </a:solidFill>
                 <a:latin typeface="Segoe UI"/>
               </a:rPr>
-              <a:t>layer voice identity + deepfake + transaction context; detection is a signal, not proof</a:t>
+              <a:t>L3 telephony (mid-call block) · two-service attestation · real pilot partner</a:t>
             </a:r>
           </a:p>
         </p:txBody>
@@ -7408,8 +7377,8 @@
         </p:nvSpPr>
         <p:spPr>
           <a:xfrm>
-            <a:off x="6629400" y="3913631"/>
-            <a:ext cx="4937760" cy="548640"/>
+            <a:off x="6629400" y="5166360"/>
+            <a:ext cx="4937760" cy="914400"/>
           </a:xfrm>
           <a:prstGeom prst="rect">
             <a:avLst/>
@@ -7425,11 +7394,11 @@
             <a:r>
               <a:rPr sz="1200" b="1">
                 <a:solidFill>
-                  <a:srgbClr val="D6394B"/>
-                </a:solidFill>
-                <a:latin typeface="Segoe UI"/>
-              </a:rPr>
-              <a:t>Biometric privacy — </a:t>
+                  <a:srgbClr val="0F1B2D"/>
+                </a:solidFill>
+                <a:latin typeface="Segoe UI"/>
+              </a:rPr>
+              <a:t>Self-audit posture:</a:t>
             </a:r>
             <a:r>
               <a:rPr sz="1200" b="0">
@@ -7438,93 +7407,7 @@
                 </a:solidFill>
                 <a:latin typeface="Segoe UI"/>
               </a:rPr>
-              <a:t>vector-only storage, minimisation, retention policy, on-prem option</a:t>
-            </a:r>
-          </a:p>
-        </p:txBody>
-      </p:sp>
-      <p:sp>
-        <p:nvSpPr>
-          <p:cNvPr id="13" name="TextBox 12"/>
-          <p:cNvSpPr txBox="1"/>
-          <p:nvPr/>
-        </p:nvSpPr>
-        <p:spPr>
-          <a:xfrm>
-            <a:off x="6629400" y="4480560"/>
-            <a:ext cx="4937760" cy="548640"/>
-          </a:xfrm>
-          <a:prstGeom prst="rect">
-            <a:avLst/>
-          </a:prstGeom>
-          <a:noFill/>
-        </p:spPr>
-        <p:txBody>
-          <a:bodyPr wrap="square">
-            <a:spAutoFit/>
-          </a:bodyPr>
-          <a:lstStyle/>
-          <a:p>
-            <a:r>
-              <a:rPr sz="1200" b="1">
-                <a:solidFill>
-                  <a:srgbClr val="D6394B"/>
-                </a:solidFill>
-                <a:latin typeface="Segoe UI"/>
-              </a:rPr>
-              <a:t>Integration — </a:t>
-            </a:r>
-            <a:r>
-              <a:rPr sz="1200" b="0">
-                <a:solidFill>
-                  <a:srgbClr val="33415C"/>
-                </a:solidFill>
-                <a:latin typeface="Segoe UI"/>
-              </a:rPr>
-              <a:t>ship as one signal in one workflow, then expand through the call platform</a:t>
-            </a:r>
-          </a:p>
-        </p:txBody>
-      </p:sp>
-      <p:sp>
-        <p:nvSpPr>
-          <p:cNvPr id="14" name="TextBox 13"/>
-          <p:cNvSpPr txBox="1"/>
-          <p:nvPr/>
-        </p:nvSpPr>
-        <p:spPr>
-          <a:xfrm>
-            <a:off x="6629400" y="5074920"/>
-            <a:ext cx="4937760" cy="822960"/>
-          </a:xfrm>
-          <a:prstGeom prst="rect">
-            <a:avLst/>
-          </a:prstGeom>
-          <a:noFill/>
-        </p:spPr>
-        <p:txBody>
-          <a:bodyPr wrap="square">
-            <a:spAutoFit/>
-          </a:bodyPr>
-          <a:lstStyle/>
-          <a:p>
-            <a:r>
-              <a:rPr sz="1200" b="1">
-                <a:solidFill>
-                  <a:srgbClr val="0F1B2D"/>
-                </a:solidFill>
-                <a:latin typeface="Segoe UI"/>
-              </a:rPr>
-              <a:t>Roadmap:</a:t>
-            </a:r>
-            <a:r>
-              <a:rPr sz="1200" b="0">
-                <a:solidFill>
-                  <a:srgbClr val="33415C"/>
-                </a:solidFill>
-                <a:latin typeface="Segoe UI"/>
-              </a:rPr>
-              <a:t> same windowed check over PSTN / WhatsApp audio, then an open agent-to-agent attestation protocol.</a:t>
+              <a:t> the build is scored 57/70 pessimistically with the audit in the repo — the team-hours items (rehearsal, interviews) are the remaining gap, by design of the cutoff.</a:t>
             </a:r>
           </a:p>
         </p:txBody>

</xml_diff>

<commit_message>
Simple deck: one idea per slide, plain language, internal score removed
Rebuilt for an audience that knows nothing: slide 1 the scam story, slide 2
the traffic light (with the call-stops demo beat), slide 3 the slice rule
with the drawn green-to-red strip and the 30-second try-it list, slide 4 the
$5,700 vs 50 cents gap and the ~100x return, slide 5 who pays / starts in a
day / honest scoreboard / pilot. No rubric or self-audit numbers anywhere.

🤖 Generated with Codebuff
Co-Authored-By: Codebuff <noreply@codebuff.com>
</commit_message>
<xml_diff>
--- a/UNCLONE-day2-deck.pptx
+++ b/UNCLONE-day2-deck.pptx
@@ -3159,13 +3159,13 @@
           <a:lstStyle/>
           <a:p>
             <a:r>
-              <a:rPr sz="1300" b="1">
+              <a:rPr sz="1200" b="1">
                 <a:solidFill>
                   <a:srgbClr val="0E9F6E"/>
                 </a:solidFill>
                 <a:latin typeface="Segoe UI"/>
               </a:rPr>
-              <a:t>SLIDE 1</a:t>
+              <a:t>SLIDE 1 · PROBLEM</a:t>
             </a:r>
           </a:p>
         </p:txBody>
@@ -3193,13 +3193,13 @@
           <a:lstStyle/>
           <a:p>
             <a:r>
-              <a:rPr sz="3200" b="1">
+              <a:rPr sz="3400" b="1">
                 <a:solidFill>
                   <a:srgbClr val="0F1B2D"/>
                 </a:solidFill>
                 <a:latin typeface="Segoe UI"/>
               </a:rPr>
-              <a:t>Problem</a:t>
+              <a:t>The phone scam no amount of care can stop</a:t>
             </a:r>
           </a:p>
         </p:txBody>
@@ -3212,7 +3212,7 @@
         </p:nvSpPr>
         <p:spPr>
           <a:xfrm>
-            <a:off x="658368" y="1426464"/>
+            <a:off x="658368" y="1481328"/>
             <a:ext cx="914400" cy="45720"/>
           </a:xfrm>
           <a:prstGeom prst="rect">
@@ -3256,8 +3256,8 @@
         </p:nvSpPr>
         <p:spPr>
           <a:xfrm>
-            <a:off x="640080" y="6327648"/>
-            <a:ext cx="11155680" cy="411480"/>
+            <a:off x="640080" y="6355080"/>
+            <a:ext cx="11155680" cy="365760"/>
           </a:xfrm>
           <a:prstGeom prst="rect">
             <a:avLst/>
@@ -3271,13 +3271,13 @@
           <a:lstStyle/>
           <a:p>
             <a:r>
-              <a:rPr sz="1050">
+              <a:rPr sz="1100">
                 <a:solidFill>
                   <a:srgbClr val="64748B"/>
                 </a:solidFill>
                 <a:latin typeface="Segoe UI"/>
               </a:rPr>
-              <a:t>Judge link: https://unclone-verified-agent.onrender.com   ·   in-product docs: Impact · Calibration · Scale &amp; Viability pages</a:t>
+              <a:t>Try it live — https://unclone-verified-agent.onrender.com</a:t>
             </a:r>
           </a:p>
         </p:txBody>
@@ -3290,8 +3290,8 @@
         </p:nvSpPr>
         <p:spPr>
           <a:xfrm>
-            <a:off x="640080" y="1783080"/>
-            <a:ext cx="10972800" cy="4206240"/>
+            <a:off x="640080" y="1920240"/>
+            <a:ext cx="10972800" cy="3108960"/>
           </a:xfrm>
           <a:prstGeom prst="rect">
             <a:avLst/>
@@ -3306,270 +3306,137 @@
           <a:p>
             <a:pPr>
               <a:spcAft>
-                <a:spcPts val="1000"/>
+                <a:spcPts val="1400"/>
               </a:spcAft>
             </a:pPr>
             <a:r>
-              <a:rPr sz="1500" b="1">
+              <a:rPr sz="1900" b="0">
+                <a:solidFill>
+                  <a:srgbClr val="33415C"/>
+                </a:solidFill>
+                <a:latin typeface="Segoe UI"/>
+              </a:rPr>
+              <a:t>Your phone rings. </a:t>
+            </a:r>
+            <a:r>
+              <a:rPr sz="1900" b="1">
                 <a:solidFill>
                   <a:srgbClr val="0F1B2D"/>
                 </a:solidFill>
                 <a:latin typeface="Segoe UI"/>
               </a:rPr>
-              <a:t>Who: </a:t>
-            </a:r>
-            <a:r>
-              <a:rPr sz="1500" b="0">
+              <a:t>“This is your bank about a ₹86,499 payment above your limit.”</a:t>
+            </a:r>
+            <a:r>
+              <a:rPr sz="1900" b="0">
                 <a:solidFill>
                   <a:srgbClr val="33415C"/>
                 </a:solidFill>
                 <a:latin typeface="Segoe UI"/>
               </a:rPr>
-              <a:t>a retail-bank customer. The phone rings: “This is your bank's verification desk about a transaction of </a:t>
-            </a:r>
-            <a:r>
-              <a:rPr sz="1500" b="1">
-                <a:solidFill>
-                  <a:srgbClr val="0F1B2D"/>
-                </a:solidFill>
-                <a:latin typeface="Segoe UI"/>
-              </a:rPr>
-              <a:t>₹86,499</a:t>
-            </a:r>
-            <a:r>
-              <a:rPr sz="1500" b="0">
-                <a:solidFill>
-                  <a:srgbClr val="33415C"/>
-                </a:solidFill>
-                <a:latin typeface="Segoe UI"/>
-              </a:rPr>
-              <a:t> on your card, above your limit.”</a:t>
+              <a:t> Name right, details right, voice right.</a:t>
             </a:r>
           </a:p>
           <a:p>
             <a:pPr>
               <a:spcAft>
-                <a:spcPts val="1000"/>
+                <a:spcPts val="1400"/>
               </a:spcAft>
             </a:pPr>
             <a:r>
-              <a:rPr sz="1500" b="1">
+              <a:rPr sz="1700" b="0">
+                <a:solidFill>
+                  <a:srgbClr val="33415C"/>
+                </a:solidFill>
+                <a:latin typeface="Segoe UI"/>
+              </a:rPr>
+              <a:t>The voice is a </a:t>
+            </a:r>
+            <a:r>
+              <a:rPr sz="1700" b="1">
                 <a:solidFill>
                   <a:srgbClr val="0F1B2D"/>
                 </a:solidFill>
                 <a:latin typeface="Segoe UI"/>
               </a:rPr>
-              <a:t>The fraud moment: </a:t>
-            </a:r>
-            <a:r>
-              <a:rPr sz="1500" b="0">
+              <a:t>computer clone</a:t>
+            </a:r>
+            <a:r>
+              <a:rPr sz="1700" b="0">
                 <a:solidFill>
                   <a:srgbClr val="33415C"/>
                 </a:solidFill>
                 <a:latin typeface="Segoe UI"/>
               </a:rPr>
-              <a:t>the “bank agent” is an imposter — a cloned voice that sounds exactly like the real assistant, walking the customer into approving the payment or reading an OTP.</a:t>
+              <a:t> of the bank's agent. You cannot tell. Nobody can.</a:t>
             </a:r>
           </a:p>
           <a:p>
             <a:pPr>
               <a:spcAft>
-                <a:spcPts val="1000"/>
+                <a:spcPts val="1400"/>
               </a:spcAft>
             </a:pPr>
             <a:r>
-              <a:rPr sz="1500" b="1">
+              <a:rPr sz="1700" b="0">
+                <a:solidFill>
+                  <a:srgbClr val="33415C"/>
+                </a:solidFill>
+                <a:latin typeface="Segoe UI"/>
+              </a:rPr>
+              <a:t>The old guardrails are dead: caller ID is faked, the caller knows everything, and </a:t>
+            </a:r>
+            <a:r>
+              <a:rPr sz="1700" b="1">
                 <a:solidFill>
                   <a:srgbClr val="0F1B2D"/>
                 </a:solidFill>
                 <a:latin typeface="Segoe UI"/>
               </a:rPr>
-              <a:t>Why today's process fails, control by control: </a:t>
-            </a:r>
-            <a:r>
-              <a:rPr sz="1500" b="0">
+              <a:t>they don't need you to tell them anything</a:t>
+            </a:r>
+            <a:r>
+              <a:rPr sz="1700" b="0">
                 <a:solidFill>
                   <a:srgbClr val="33415C"/>
                 </a:solidFill>
                 <a:latin typeface="Segoe UI"/>
               </a:rPr>
-              <a:t>caller ID is </a:t>
-            </a:r>
-            <a:r>
-              <a:rPr sz="1500" b="1">
-                <a:solidFill>
-                  <a:srgbClr val="0F1B2D"/>
-                </a:solidFill>
-                <a:latin typeface="Segoe UI"/>
-              </a:rPr>
-              <a:t>spoofable</a:t>
-            </a:r>
-            <a:r>
-              <a:rPr sz="1500" b="0">
-                <a:solidFill>
-                  <a:srgbClr val="33415C"/>
-                </a:solidFill>
-                <a:latin typeface="Segoe UI"/>
-              </a:rPr>
-              <a:t>; KYC questions </a:t>
-            </a:r>
-            <a:r>
-              <a:rPr sz="1500" b="1">
-                <a:solidFill>
-                  <a:srgbClr val="0F1B2D"/>
-                </a:solidFill>
-                <a:latin typeface="Segoe UI"/>
-              </a:rPr>
-              <a:t>leak</a:t>
-            </a:r>
-            <a:r>
-              <a:rPr sz="1500" b="0">
-                <a:solidFill>
-                  <a:srgbClr val="33415C"/>
-                </a:solidFill>
-                <a:latin typeface="Segoe UI"/>
-              </a:rPr>
-              <a:t> to the caller; “we never ask for X” </a:t>
-            </a:r>
-            <a:r>
-              <a:rPr sz="1500" b="1">
-                <a:solidFill>
-                  <a:srgbClr val="0F1B2D"/>
-                </a:solidFill>
-                <a:latin typeface="Segoe UI"/>
-              </a:rPr>
-              <a:t>collapses</a:t>
-            </a:r>
-            <a:r>
-              <a:rPr sz="1500" b="0">
-                <a:solidFill>
-                  <a:srgbClr val="33415C"/>
-                </a:solidFill>
-                <a:latin typeface="Segoe UI"/>
-              </a:rPr>
-              <a:t> when the caller sounds like the bank. The customer has </a:t>
-            </a:r>
-            <a:r>
-              <a:rPr sz="1500" b="1">
-                <a:solidFill>
-                  <a:srgbClr val="0F1B2D"/>
-                </a:solidFill>
-                <a:latin typeface="Segoe UI"/>
-              </a:rPr>
-              <a:t>no way to verify who is speaking</a:t>
-            </a:r>
-            <a:r>
-              <a:rPr sz="1500" b="0">
-                <a:solidFill>
-                  <a:srgbClr val="33415C"/>
-                </a:solidFill>
-                <a:latin typeface="Segoe UI"/>
-              </a:rPr>
-              <a:t>.</a:t>
+              <a:t> — they need you to agree.</a:t>
             </a:r>
           </a:p>
           <a:p>
             <a:pPr>
               <a:spcAft>
-                <a:spcPts val="1000"/>
+                <a:spcPts val="1400"/>
               </a:spcAft>
             </a:pPr>
             <a:r>
-              <a:rPr sz="1500" b="1">
+              <a:rPr sz="1700" b="0">
+                <a:solidFill>
+                  <a:srgbClr val="33415C"/>
+                </a:solidFill>
+                <a:latin typeface="Segoe UI"/>
+              </a:rPr>
+              <a:t>Our idea: </a:t>
+            </a:r>
+            <a:r>
+              <a:rPr sz="1700" b="1">
                 <a:solidFill>
                   <a:srgbClr val="0F1B2D"/>
                 </a:solidFill>
                 <a:latin typeface="Segoe UI"/>
               </a:rPr>
-              <a:t>Evidence: </a:t>
-            </a:r>
-            <a:r>
-              <a:rPr sz="1500" b="0">
+              <a:t>let the customer verify the caller.</a:t>
+            </a:r>
+            <a:r>
+              <a:rPr sz="1700" b="0">
                 <a:solidFill>
                   <a:srgbClr val="33415C"/>
                 </a:solidFill>
                 <a:latin typeface="Segoe UI"/>
               </a:rPr>
-              <a:t>FTC 2024: </a:t>
-            </a:r>
-            <a:r>
-              <a:rPr sz="1500" b="1">
-                <a:solidFill>
-                  <a:srgbClr val="0F1B2D"/>
-                </a:solidFill>
-                <a:latin typeface="Segoe UI"/>
-              </a:rPr>
-              <a:t>$1.25 B</a:t>
-            </a:r>
-            <a:r>
-              <a:rPr sz="1500" b="0">
-                <a:solidFill>
-                  <a:srgbClr val="33415C"/>
-                </a:solidFill>
-                <a:latin typeface="Segoe UI"/>
-              </a:rPr>
-              <a:t> reported fraud losses; UK APP ≈ </a:t>
-            </a:r>
-            <a:r>
-              <a:rPr sz="1500" b="1">
-                <a:solidFill>
-                  <a:srgbClr val="0F1B2D"/>
-                </a:solidFill>
-                <a:latin typeface="Segoe UI"/>
-              </a:rPr>
-              <a:t>£149 M</a:t>
-            </a:r>
-            <a:r>
-              <a:rPr sz="1500" b="0">
-                <a:solidFill>
-                  <a:srgbClr val="33415C"/>
-                </a:solidFill>
-                <a:latin typeface="Segoe UI"/>
-              </a:rPr>
-              <a:t> with voice cloning rising; ≈ </a:t>
-            </a:r>
-            <a:r>
-              <a:rPr sz="1500" b="1">
-                <a:solidFill>
-                  <a:srgbClr val="0F1B2D"/>
-                </a:solidFill>
-                <a:latin typeface="Segoe UI"/>
-              </a:rPr>
-              <a:t>$5,700</a:t>
-            </a:r>
-            <a:r>
-              <a:rPr sz="1500" b="0">
-                <a:solidFill>
-                  <a:srgbClr val="33415C"/>
-                </a:solidFill>
-                <a:latin typeface="Segoe UI"/>
-              </a:rPr>
-              <a:t> median loss per incident.</a:t>
-            </a:r>
-          </a:p>
-          <a:p>
-            <a:pPr>
-              <a:spcAft>
-                <a:spcPts val="1000"/>
-              </a:spcAft>
-            </a:pPr>
-            <a:r>
-              <a:rPr sz="1500" b="1">
-                <a:solidFill>
-                  <a:srgbClr val="0F1B2D"/>
-                </a:solidFill>
-                <a:latin typeface="Segoe UI"/>
-              </a:rPr>
-              <a:t>Unchanged from registration (rule 3.7): </a:t>
-            </a:r>
-            <a:r>
-              <a:rPr sz="1500" b="0">
-                <a:solidFill>
-                  <a:srgbClr val="33415C"/>
-                </a:solidFill>
-                <a:latin typeface="Segoe UI"/>
-              </a:rPr>
-              <a:t>same user, same problem. Day 2 deepens the product; the registered problem is quoted in the product itself.</a:t>
+              <a:t> Nobody is on the customer's side of the call today. We are.</a:t>
             </a:r>
           </a:p>
         </p:txBody>
@@ -3659,13 +3526,13 @@
           <a:lstStyle/>
           <a:p>
             <a:r>
-              <a:rPr sz="1300" b="1">
+              <a:rPr sz="1200" b="1">
                 <a:solidFill>
                   <a:srgbClr val="0E9F6E"/>
                 </a:solidFill>
                 <a:latin typeface="Segoe UI"/>
               </a:rPr>
-              <a:t>SLIDE 2</a:t>
+              <a:t>SLIDE 2 · SOLUTION</a:t>
             </a:r>
           </a:p>
         </p:txBody>
@@ -3693,13 +3560,13 @@
           <a:lstStyle/>
           <a:p>
             <a:r>
-              <a:rPr sz="3200" b="1">
+              <a:rPr sz="3400" b="1">
                 <a:solidFill>
                   <a:srgbClr val="0F1B2D"/>
                 </a:solidFill>
                 <a:latin typeface="Segoe UI"/>
               </a:rPr>
-              <a:t>Solution</a:t>
+              <a:t>A traffic light for the phone call</a:t>
             </a:r>
           </a:p>
         </p:txBody>
@@ -3712,7 +3579,7 @@
         </p:nvSpPr>
         <p:spPr>
           <a:xfrm>
-            <a:off x="658368" y="1426464"/>
+            <a:off x="658368" y="1481328"/>
             <a:ext cx="914400" cy="45720"/>
           </a:xfrm>
           <a:prstGeom prst="rect">
@@ -3756,8 +3623,8 @@
         </p:nvSpPr>
         <p:spPr>
           <a:xfrm>
-            <a:off x="640080" y="6327648"/>
-            <a:ext cx="11155680" cy="411480"/>
+            <a:off x="640080" y="6355080"/>
+            <a:ext cx="11155680" cy="365760"/>
           </a:xfrm>
           <a:prstGeom prst="rect">
             <a:avLst/>
@@ -3771,13 +3638,13 @@
           <a:lstStyle/>
           <a:p>
             <a:r>
-              <a:rPr sz="1050">
+              <a:rPr sz="1100">
                 <a:solidFill>
                   <a:srgbClr val="64748B"/>
                 </a:solidFill>
                 <a:latin typeface="Segoe UI"/>
               </a:rPr>
-              <a:t>Judge link: https://unclone-verified-agent.onrender.com   ·   in-product docs: Impact · Calibration · Scale &amp; Viability pages</a:t>
+              <a:t>Try it live — https://unclone-verified-agent.onrender.com</a:t>
             </a:r>
           </a:p>
         </p:txBody>
@@ -3791,7 +3658,7 @@
         <p:spPr>
           <a:xfrm>
             <a:off x="640080" y="1783080"/>
-            <a:ext cx="10972800" cy="2377440"/>
+            <a:ext cx="10972800" cy="1051560"/>
           </a:xfrm>
           <a:prstGeom prst="rect">
             <a:avLst/>
@@ -3804,220 +3671,57 @@
           </a:bodyPr>
           <a:lstStyle/>
           <a:p>
-            <a:pPr>
-              <a:spcAft>
-                <a:spcPts val="1000"/>
-              </a:spcAft>
-            </a:pPr>
-            <a:r>
-              <a:rPr sz="1500" b="1">
+            <a:r>
+              <a:rPr sz="1900" b="0">
+                <a:solidFill>
+                  <a:srgbClr val="33415C"/>
+                </a:solidFill>
+                <a:latin typeface="Segoe UI"/>
+              </a:rPr>
+              <a:t>An app on </a:t>
+            </a:r>
+            <a:r>
+              <a:rPr sz="1900" b="1">
                 <a:solidFill>
                   <a:srgbClr val="0F1B2D"/>
                 </a:solidFill>
                 <a:latin typeface="Segoe UI"/>
               </a:rPr>
-              <a:t>Verified-Agent Badge: </a:t>
-            </a:r>
-            <a:r>
-              <a:rPr sz="1500" b="0">
+              <a:t>your</a:t>
+            </a:r>
+            <a:r>
+              <a:rPr sz="1900" b="0">
                 <a:solidFill>
                   <a:srgbClr val="33415C"/>
                 </a:solidFill>
                 <a:latin typeface="Segoe UI"/>
               </a:rPr>
-              <a:t>the user side verifies the bank's agent. The bank already authenticates us; </a:t>
-            </a:r>
-            <a:r>
-              <a:rPr sz="1500" b="1">
+              <a:t> side of the call listens every 6 seconds and asks one question: </a:t>
+            </a:r>
+            <a:r>
+              <a:rPr sz="1900" b="1">
                 <a:solidFill>
                   <a:srgbClr val="0F1B2D"/>
                 </a:solidFill>
                 <a:latin typeface="Segoe UI"/>
               </a:rPr>
-              <a:t>nobody authenticates it</a:t>
-            </a:r>
-            <a:r>
-              <a:rPr sz="1500" b="0">
-                <a:solidFill>
-                  <a:srgbClr val="33415C"/>
-                </a:solidFill>
-                <a:latin typeface="Segoe UI"/>
-              </a:rPr>
-              <a:t>.</a:t>
-            </a:r>
-          </a:p>
-          <a:p>
-            <a:pPr>
-              <a:spcAft>
-                <a:spcPts val="1000"/>
-              </a:spcAft>
-            </a:pPr>
-            <a:r>
-              <a:rPr sz="1500" b="1">
-                <a:solidFill>
-                  <a:srgbClr val="0F1B2D"/>
-                </a:solidFill>
-                <a:latin typeface="Segoe UI"/>
-              </a:rPr>
-              <a:t>Live, not staged: </a:t>
-            </a:r>
-            <a:r>
-              <a:rPr sz="1500" b="0">
-                <a:solidFill>
-                  <a:srgbClr val="33415C"/>
-                </a:solidFill>
-                <a:latin typeface="Segoe UI"/>
-              </a:rPr>
-              <a:t>press </a:t>
-            </a:r>
-            <a:r>
-              <a:rPr sz="1500" b="1">
-                <a:solidFill>
-                  <a:srgbClr val="0F1B2D"/>
-                </a:solidFill>
-                <a:latin typeface="Segoe UI"/>
-              </a:rPr>
-              <a:t>Enrol my voice</a:t>
-            </a:r>
-            <a:r>
-              <a:rPr sz="1500" b="0">
-                <a:solidFill>
-                  <a:srgbClr val="33415C"/>
-                </a:solidFill>
-                <a:latin typeface="Segoe UI"/>
-              </a:rPr>
-              <a:t> — 20 s in your browser — then </a:t>
-            </a:r>
-            <a:r>
-              <a:rPr sz="1500" b="1">
-                <a:solidFill>
-                  <a:srgbClr val="0F1B2D"/>
-                </a:solidFill>
-                <a:latin typeface="Segoe UI"/>
-              </a:rPr>
-              <a:t>Verify me now</a:t>
-            </a:r>
-            <a:r>
-              <a:rPr sz="1500" b="0">
-                <a:solidFill>
-                  <a:srgbClr val="33415C"/>
-                </a:solidFill>
-                <a:latin typeface="Segoe UI"/>
-              </a:rPr>
-              <a:t>: a 6 s window captured in the browser, verified through DetectifAI, </a:t>
-            </a:r>
-            <a:r>
-              <a:rPr sz="1500" b="1">
-                <a:solidFill>
-                  <a:srgbClr val="0F1B2D"/>
-                </a:solidFill>
-                <a:latin typeface="Segoe UI"/>
-              </a:rPr>
-              <a:t>never on disk</a:t>
-            </a:r>
-            <a:r>
-              <a:rPr sz="1500" b="0">
-                <a:solidFill>
-                  <a:srgbClr val="33415C"/>
-                </a:solidFill>
-                <a:latin typeface="Segoe UI"/>
-              </a:rPr>
-              <a:t>. An impostor clip against your enrolment is </a:t>
-            </a:r>
-            <a:r>
-              <a:rPr sz="1500" b="1">
-                <a:solidFill>
-                  <a:srgbClr val="0F1B2D"/>
-                </a:solidFill>
-                <a:latin typeface="Segoe UI"/>
-              </a:rPr>
-              <a:t>held</a:t>
-            </a:r>
-            <a:r>
-              <a:rPr sz="1500" b="0">
-                <a:solidFill>
-                  <a:srgbClr val="33415C"/>
-                </a:solidFill>
-                <a:latin typeface="Segoe UI"/>
-              </a:rPr>
-              <a:t>. Upload fallback if the mic is blocked.</a:t>
-            </a:r>
-          </a:p>
-          <a:p>
-            <a:pPr>
-              <a:spcAft>
-                <a:spcPts val="1000"/>
-              </a:spcAft>
-            </a:pPr>
-            <a:r>
-              <a:rPr sz="1500" b="1">
-                <a:solidFill>
-                  <a:srgbClr val="0F1B2D"/>
-                </a:solidFill>
-                <a:latin typeface="Segoe UI"/>
-              </a:rPr>
-              <a:t>A decision that acts: </a:t>
-            </a:r>
-            <a:r>
-              <a:rPr sz="1500" b="0">
-                <a:solidFill>
-                  <a:srgbClr val="33415C"/>
-                </a:solidFill>
-                <a:latin typeface="Segoe UI"/>
-              </a:rPr>
-              <a:t>every window mutates a server-side </a:t>
-            </a:r>
-            <a:r>
-              <a:rPr sz="1500" b="1">
-                <a:solidFill>
-                  <a:srgbClr val="0F1B2D"/>
-                </a:solidFill>
-                <a:latin typeface="Segoe UI"/>
-              </a:rPr>
-              <a:t>transaction object</a:t>
-            </a:r>
-            <a:r>
-              <a:rPr sz="1500" b="0">
-                <a:solidFill>
-                  <a:srgbClr val="33415C"/>
-                </a:solidFill>
-                <a:latin typeface="Segoe UI"/>
-              </a:rPr>
-              <a:t> — pending → proceed / step_up / hold. A hold </a:t>
-            </a:r>
-            <a:r>
-              <a:rPr sz="1500" b="1">
-                <a:solidFill>
-                  <a:srgbClr val="0F1B2D"/>
-                </a:solidFill>
-                <a:latin typeface="Segoe UI"/>
-              </a:rPr>
-              <a:t>terminates the call and blocks the payment</a:t>
-            </a:r>
-            <a:r>
-              <a:rPr sz="1500" b="0">
-                <a:solidFill>
-                  <a:srgbClr val="33415C"/>
-                </a:solidFill>
-                <a:latin typeface="Segoe UI"/>
-              </a:rPr>
-              <a:t>; the state is readable in the API.</a:t>
-            </a:r>
-          </a:p>
-        </p:txBody>
-      </p:sp>
-      <p:sp>
-        <p:nvSpPr>
-          <p:cNvPr id="8" name="Rectangle 7"/>
+              <a:t>is this the real bank agent, or a machine copying them?</a:t>
+            </a:r>
+          </a:p>
+        </p:txBody>
+      </p:sp>
+      <p:sp>
+        <p:nvSpPr>
+          <p:cNvPr id="8" name="Rounded Rectangle 7"/>
           <p:cNvSpPr/>
           <p:nvPr/>
         </p:nvSpPr>
         <p:spPr>
           <a:xfrm>
-            <a:off x="685800" y="4343400"/>
-            <a:ext cx="3383280" cy="868680"/>
-          </a:xfrm>
-          <a:prstGeom prst="rect">
+            <a:off x="685800" y="2971800"/>
+            <a:ext cx="3520440" cy="1234440"/>
+          </a:xfrm>
+          <a:prstGeom prst="roundRect">
             <a:avLst/>
           </a:prstGeom>
           <a:solidFill>
@@ -4054,14 +3758,58 @@
       </p:sp>
       <p:sp>
         <p:nvSpPr>
-          <p:cNvPr id="9" name="TextBox 8"/>
+          <p:cNvPr id="9" name="Oval 8"/>
+          <p:cNvSpPr/>
+          <p:nvPr/>
+        </p:nvSpPr>
+        <p:spPr>
+          <a:xfrm>
+            <a:off x="850392" y="3136392"/>
+            <a:ext cx="292608" cy="292608"/>
+          </a:xfrm>
+          <a:prstGeom prst="ellipse">
+            <a:avLst/>
+          </a:prstGeom>
+          <a:solidFill>
+            <a:srgbClr val="0E9F6E"/>
+          </a:solidFill>
+          <a:ln>
+            <a:noFill/>
+          </a:ln>
+          <a:effectLst/>
+        </p:spPr>
+        <p:style>
+          <a:lnRef idx="1">
+            <a:schemeClr val="accent1"/>
+          </a:lnRef>
+          <a:fillRef idx="3">
+            <a:schemeClr val="accent1"/>
+          </a:fillRef>
+          <a:effectRef idx="2">
+            <a:schemeClr val="accent1"/>
+          </a:effectRef>
+          <a:fontRef idx="minor">
+            <a:schemeClr val="lt1"/>
+          </a:fontRef>
+        </p:style>
+        <p:txBody>
+          <a:bodyPr rtlCol="0" anchor="ctr"/>
+          <a:lstStyle/>
+          <a:p>
+            <a:pPr algn="ctr"/>
+          </a:p>
+        </p:txBody>
+      </p:sp>
+      <p:sp>
+        <p:nvSpPr>
+          <p:cNvPr id="10" name="TextBox 9"/>
           <p:cNvSpPr txBox="1"/>
           <p:nvPr/>
         </p:nvSpPr>
         <p:spPr>
           <a:xfrm>
-            <a:off x="795528" y="4434840"/>
-            <a:ext cx="3163824" cy="685800"/>
+            <a:off x="1252728" y="3081528"/>
+            <a:ext cx="2834640" cy="1051560"/>
           </a:xfrm>
           <a:prstGeom prst="rect">
             <a:avLst/>
@@ -4075,40 +3823,40 @@
           <a:lstStyle/>
           <a:p>
             <a:r>
-              <a:rPr sz="1400" b="1">
+              <a:rPr sz="1600" b="1">
                 <a:solidFill>
                   <a:srgbClr val="0E9F6E"/>
                 </a:solidFill>
                 <a:latin typeface="Segoe UI"/>
               </a:rPr>
-              <a:t>PROCEED</a:t>
-            </a:r>
-          </a:p>
-          <a:p>
-            <a:r>
-              <a:rPr sz="1050" b="0">
+              <a:t>GREEN · GO</a:t>
+            </a:r>
+          </a:p>
+          <a:p>
+            <a:r>
+              <a:rPr sz="1200" b="0">
                 <a:solidFill>
                   <a:srgbClr val="33415C"/>
                 </a:solidFill>
                 <a:latin typeface="Segoe UI"/>
               </a:rPr>
-              <a:t>identity with margin + every segment real + no replay</a:t>
-            </a:r>
-          </a:p>
-        </p:txBody>
-      </p:sp>
-      <p:sp>
-        <p:nvSpPr>
-          <p:cNvPr id="10" name="Rectangle 9"/>
+              <a:t>Real voice, sounds human. Carry on with the call.</a:t>
+            </a:r>
+          </a:p>
+        </p:txBody>
+      </p:sp>
+      <p:sp>
+        <p:nvSpPr>
+          <p:cNvPr id="11" name="Rounded Rectangle 10"/>
           <p:cNvSpPr/>
           <p:nvPr/>
         </p:nvSpPr>
         <p:spPr>
           <a:xfrm>
-            <a:off x="4297680" y="4343400"/>
-            <a:ext cx="3383280" cy="868680"/>
-          </a:xfrm>
-          <a:prstGeom prst="rect">
+            <a:off x="4343400" y="2971800"/>
+            <a:ext cx="3520440" cy="1234440"/>
+          </a:xfrm>
+          <a:prstGeom prst="roundRect">
             <a:avLst/>
           </a:prstGeom>
           <a:solidFill>
@@ -4145,14 +3893,58 @@
       </p:sp>
       <p:sp>
         <p:nvSpPr>
-          <p:cNvPr id="11" name="TextBox 10"/>
+          <p:cNvPr id="12" name="Oval 11"/>
+          <p:cNvSpPr/>
+          <p:nvPr/>
+        </p:nvSpPr>
+        <p:spPr>
+          <a:xfrm>
+            <a:off x="4507992" y="3136392"/>
+            <a:ext cx="292608" cy="292608"/>
+          </a:xfrm>
+          <a:prstGeom prst="ellipse">
+            <a:avLst/>
+          </a:prstGeom>
+          <a:solidFill>
+            <a:srgbClr val="C88600"/>
+          </a:solidFill>
+          <a:ln>
+            <a:noFill/>
+          </a:ln>
+          <a:effectLst/>
+        </p:spPr>
+        <p:style>
+          <a:lnRef idx="1">
+            <a:schemeClr val="accent1"/>
+          </a:lnRef>
+          <a:fillRef idx="3">
+            <a:schemeClr val="accent1"/>
+          </a:fillRef>
+          <a:effectRef idx="2">
+            <a:schemeClr val="accent1"/>
+          </a:effectRef>
+          <a:fontRef idx="minor">
+            <a:schemeClr val="lt1"/>
+          </a:fontRef>
+        </p:style>
+        <p:txBody>
+          <a:bodyPr rtlCol="0" anchor="ctr"/>
+          <a:lstStyle/>
+          <a:p>
+            <a:pPr algn="ctr"/>
+          </a:p>
+        </p:txBody>
+      </p:sp>
+      <p:sp>
+        <p:nvSpPr>
+          <p:cNvPr id="13" name="TextBox 12"/>
           <p:cNvSpPr txBox="1"/>
           <p:nvPr/>
         </p:nvSpPr>
         <p:spPr>
           <a:xfrm>
-            <a:off x="4407408" y="4434840"/>
-            <a:ext cx="3163824" cy="685800"/>
+            <a:off x="4910328" y="3081528"/>
+            <a:ext cx="2834640" cy="1051560"/>
           </a:xfrm>
           <a:prstGeom prst="rect">
             <a:avLst/>
@@ -4166,40 +3958,40 @@
           <a:lstStyle/>
           <a:p>
             <a:r>
-              <a:rPr sz="1400" b="1">
+              <a:rPr sz="1600" b="1">
                 <a:solidFill>
                   <a:srgbClr val="C88600"/>
                 </a:solidFill>
                 <a:latin typeface="Segoe UI"/>
               </a:rPr>
-              <a:t>STEP UP</a:t>
-            </a:r>
-          </a:p>
-          <a:p>
-            <a:r>
-              <a:rPr sz="1050" b="0">
+              <a:t>AMBER · DOUBLE-CHECK</a:t>
+            </a:r>
+          </a:p>
+          <a:p>
+            <a:r>
+              <a:rPr sz="1200" b="0">
                 <a:solidFill>
                   <a:srgbClr val="33415C"/>
                 </a:solidFill>
                 <a:latin typeface="Segoe UI"/>
               </a:rPr>
-              <a:t>thin evidence, digital render, 422 → in-app confirmation</a:t>
-            </a:r>
-          </a:p>
-        </p:txBody>
-      </p:sp>
-      <p:sp>
-        <p:nvSpPr>
-          <p:cNvPr id="12" name="Rectangle 11"/>
+              <a:t>Can't be sure. Confirm the payment in the app instead.</a:t>
+            </a:r>
+          </a:p>
+        </p:txBody>
+      </p:sp>
+      <p:sp>
+        <p:nvSpPr>
+          <p:cNvPr id="14" name="Rounded Rectangle 13"/>
           <p:cNvSpPr/>
           <p:nvPr/>
         </p:nvSpPr>
         <p:spPr>
           <a:xfrm>
-            <a:off x="7909560" y="4343400"/>
-            <a:ext cx="3566160" cy="868680"/>
-          </a:xfrm>
-          <a:prstGeom prst="rect">
+            <a:off x="8001000" y="2971800"/>
+            <a:ext cx="3566160" cy="1234440"/>
+          </a:xfrm>
+          <a:prstGeom prst="roundRect">
             <a:avLst/>
           </a:prstGeom>
           <a:solidFill>
@@ -4236,14 +4028,58 @@
       </p:sp>
       <p:sp>
         <p:nvSpPr>
-          <p:cNvPr id="13" name="TextBox 12"/>
+          <p:cNvPr id="15" name="Oval 14"/>
+          <p:cNvSpPr/>
+          <p:nvPr/>
+        </p:nvSpPr>
+        <p:spPr>
+          <a:xfrm>
+            <a:off x="8165592" y="3136392"/>
+            <a:ext cx="292608" cy="292608"/>
+          </a:xfrm>
+          <a:prstGeom prst="ellipse">
+            <a:avLst/>
+          </a:prstGeom>
+          <a:solidFill>
+            <a:srgbClr val="D6394B"/>
+          </a:solidFill>
+          <a:ln>
+            <a:noFill/>
+          </a:ln>
+          <a:effectLst/>
+        </p:spPr>
+        <p:style>
+          <a:lnRef idx="1">
+            <a:schemeClr val="accent1"/>
+          </a:lnRef>
+          <a:fillRef idx="3">
+            <a:schemeClr val="accent1"/>
+          </a:fillRef>
+          <a:effectRef idx="2">
+            <a:schemeClr val="accent1"/>
+          </a:effectRef>
+          <a:fontRef idx="minor">
+            <a:schemeClr val="lt1"/>
+          </a:fontRef>
+        </p:style>
+        <p:txBody>
+          <a:bodyPr rtlCol="0" anchor="ctr"/>
+          <a:lstStyle/>
+          <a:p>
+            <a:pPr algn="ctr"/>
+          </a:p>
+        </p:txBody>
+      </p:sp>
+      <p:sp>
+        <p:nvSpPr>
+          <p:cNvPr id="16" name="TextBox 15"/>
           <p:cNvSpPr txBox="1"/>
           <p:nvPr/>
         </p:nvSpPr>
         <p:spPr>
           <a:xfrm>
-            <a:off x="8019288" y="4434840"/>
-            <a:ext cx="3346704" cy="685800"/>
+            <a:off x="8567928" y="3081528"/>
+            <a:ext cx="2880360" cy="1051560"/>
           </a:xfrm>
           <a:prstGeom prst="rect">
             <a:avLst/>
@@ -4257,38 +4093,38 @@
           <a:lstStyle/>
           <a:p>
             <a:r>
-              <a:rPr sz="1400" b="1">
+              <a:rPr sz="1600" b="1">
                 <a:solidFill>
                   <a:srgbClr val="D6394B"/>
                 </a:solidFill>
                 <a:latin typeface="Segoe UI"/>
               </a:rPr>
-              <a:t>HOLD</a:t>
-            </a:r>
-          </a:p>
-          <a:p>
-            <a:r>
-              <a:rPr sz="1050" b="0">
+              <a:t>RED · STOP</a:t>
+            </a:r>
+          </a:p>
+          <a:p>
+            <a:r>
+              <a:rPr sz="1200" b="0">
                 <a:solidFill>
                   <a:srgbClr val="33415C"/>
                 </a:solidFill>
                 <a:latin typeface="Segoe UI"/>
               </a:rPr>
-              <a:t>mismatch · any hot segment · re-sent audio → blocked</a:t>
-            </a:r>
-          </a:p>
-        </p:txBody>
-      </p:sp>
-      <p:sp>
-        <p:nvSpPr>
-          <p:cNvPr id="14" name="TextBox 13"/>
+              <a:t>A fake was caught. The call is cut, the payment blocked.</a:t>
+            </a:r>
+          </a:p>
+        </p:txBody>
+      </p:sp>
+      <p:sp>
+        <p:nvSpPr>
+          <p:cNvPr id="17" name="TextBox 16"/>
           <p:cNvSpPr txBox="1"/>
           <p:nvPr/>
         </p:nvSpPr>
         <p:spPr>
           <a:xfrm>
-            <a:off x="640080" y="5394960"/>
-            <a:ext cx="10972800" cy="731520"/>
+            <a:off x="640080" y="4617720"/>
+            <a:ext cx="10972800" cy="1280160"/>
           </a:xfrm>
           <a:prstGeom prst="rect">
             <a:avLst/>
@@ -4302,49 +4138,42 @@
           <a:lstStyle/>
           <a:p>
             <a:r>
-              <a:rPr sz="1250" b="0">
+              <a:rPr sz="1600" b="0">
                 <a:solidFill>
                   <a:srgbClr val="33415C"/>
                 </a:solidFill>
                 <a:latin typeface="Segoe UI"/>
               </a:rPr>
-              <a:t>Two clocks on screen: the </a:t>
-            </a:r>
-            <a:r>
-              <a:rPr sz="1250" b="1">
+              <a:t>The red light is not a warning — </a:t>
+            </a:r>
+            <a:r>
+              <a:rPr sz="1600" b="1">
                 <a:solidFill>
                   <a:srgbClr val="0F1B2D"/>
                 </a:solidFill>
                 <a:latin typeface="Segoe UI"/>
               </a:rPr>
-              <a:t>risk timeline</a:t>
-            </a:r>
-            <a:r>
-              <a:rPr sz="1250" b="0">
+              <a:t>watch the demo: the audio stops mid-sentence</a:t>
+            </a:r>
+            <a:r>
+              <a:rPr sz="1600" b="0">
                 <a:solidFill>
                   <a:srgbClr val="33415C"/>
                 </a:solidFill>
                 <a:latin typeface="Segoe UI"/>
               </a:rPr>
-              <a:t> shows which window is being checked; the </a:t>
-            </a:r>
-            <a:r>
-              <a:rPr sz="1250" b="1">
-                <a:solidFill>
-                  <a:srgbClr val="0F1B2D"/>
-                </a:solidFill>
-                <a:latin typeface="Segoe UI"/>
-              </a:rPr>
-              <a:t>transaction badge</a:t>
-            </a:r>
-            <a:r>
-              <a:rPr sz="1250" b="0">
-                <a:solidFill>
-                  <a:srgbClr val="33415C"/>
-                </a:solidFill>
-                <a:latin typeface="Segoe UI"/>
-              </a:rPr>
-              <a:t> shows payment state. Judges verify everything by trying it — including speaking themselves.</a:t>
+              <a:t> and the transaction flips to “payment blocked”.</a:t>
+            </a:r>
+          </a:p>
+          <a:p>
+            <a:r>
+              <a:rPr sz="1400" b="0">
+                <a:solidFill>
+                  <a:srgbClr val="64748B"/>
+                </a:solidFill>
+                <a:latin typeface="Segoe UI"/>
+              </a:rPr>
+              <a:t>And it works on voices it has never heard: our judges can enrol their own voice and try it live.</a:t>
             </a:r>
           </a:p>
         </p:txBody>
@@ -4434,13 +4263,13 @@
           <a:lstStyle/>
           <a:p>
             <a:r>
-              <a:rPr sz="1300" b="1">
+              <a:rPr sz="1200" b="1">
                 <a:solidFill>
                   <a:srgbClr val="0E9F6E"/>
                 </a:solidFill>
                 <a:latin typeface="Segoe UI"/>
               </a:rPr>
-              <a:t>SLIDE 3</a:t>
+              <a:t>SLIDE 3 · THE ENGINE</a:t>
             </a:r>
           </a:p>
         </p:txBody>
@@ -4468,13 +4297,13 @@
           <a:lstStyle/>
           <a:p>
             <a:r>
-              <a:rPr sz="2900" b="1">
+              <a:rPr sz="3400" b="1">
                 <a:solidFill>
                   <a:srgbClr val="0F1B2D"/>
                 </a:solidFill>
                 <a:latin typeface="Segoe UI"/>
               </a:rPr>
-              <a:t>DetectifAI — the engine, not a feature</a:t>
+              <a:t>DetectifAI listens in slices — that's the trick</a:t>
             </a:r>
           </a:p>
         </p:txBody>
@@ -4487,7 +4316,7 @@
         </p:nvSpPr>
         <p:spPr>
           <a:xfrm>
-            <a:off x="658368" y="1426464"/>
+            <a:off x="658368" y="1481328"/>
             <a:ext cx="914400" cy="45720"/>
           </a:xfrm>
           <a:prstGeom prst="rect">
@@ -4531,8 +4360,8 @@
         </p:nvSpPr>
         <p:spPr>
           <a:xfrm>
-            <a:off x="640080" y="6327648"/>
-            <a:ext cx="11155680" cy="411480"/>
+            <a:off x="640080" y="6355080"/>
+            <a:ext cx="11155680" cy="365760"/>
           </a:xfrm>
           <a:prstGeom prst="rect">
             <a:avLst/>
@@ -4546,13 +4375,13 @@
           <a:lstStyle/>
           <a:p>
             <a:r>
-              <a:rPr sz="1050">
+              <a:rPr sz="1100">
                 <a:solidFill>
                   <a:srgbClr val="64748B"/>
                 </a:solidFill>
                 <a:latin typeface="Segoe UI"/>
               </a:rPr>
-              <a:t>Judge link: https://unclone-verified-agent.onrender.com   ·   in-product docs: Impact · Calibration · Scale &amp; Viability pages</a:t>
+              <a:t>Try it live — https://unclone-verified-agent.onrender.com</a:t>
             </a:r>
           </a:p>
         </p:txBody>
@@ -4565,8 +4394,8 @@
         </p:nvSpPr>
         <p:spPr>
           <a:xfrm>
-            <a:off x="640080" y="1645920"/>
-            <a:ext cx="5852160" cy="4480560"/>
+            <a:off x="640080" y="1828800"/>
+            <a:ext cx="10972800" cy="1371600"/>
           </a:xfrm>
           <a:prstGeom prst="rect">
             <a:avLst/>
@@ -4579,245 +4408,106 @@
           </a:bodyPr>
           <a:lstStyle/>
           <a:p>
-            <a:pPr>
-              <a:spcAft>
-                <a:spcPts val="900"/>
-              </a:spcAft>
-            </a:pPr>
-            <a:r>
-              <a:rPr sz="1300" b="1">
+            <a:r>
+              <a:rPr sz="1900" b="0">
+                <a:solidFill>
+                  <a:srgbClr val="33415C"/>
+                </a:solidFill>
+                <a:latin typeface="Segoe UI"/>
+              </a:rPr>
+              <a:t>One call = several </a:t>
+            </a:r>
+            <a:r>
+              <a:rPr sz="1900" b="1">
                 <a:solidFill>
                   <a:srgbClr val="0F1B2D"/>
                 </a:solidFill>
                 <a:latin typeface="Segoe UI"/>
               </a:rPr>
-              <a:t>Both checks, one call: </a:t>
-            </a:r>
-            <a:r>
-              <a:rPr sz="1300" b="0">
+              <a:t>6-second slices</a:t>
+            </a:r>
+            <a:r>
+              <a:rPr sz="1900" b="0">
                 <a:solidFill>
                   <a:srgbClr val="33415C"/>
                 </a:solidFill>
                 <a:latin typeface="Segoe UI"/>
               </a:rPr>
-              <a:t>POST /v1/speakers/verify with detect_deepfake=true — speaker verification against the enrolled agent plus synthetic-speech detection as </a:t>
-            </a:r>
-            <a:r>
-              <a:rPr sz="1300" b="1">
+              <a:t>. Every slice gets two checks: </a:t>
+            </a:r>
+            <a:r>
+              <a:rPr sz="1900" b="1">
                 <a:solidFill>
                   <a:srgbClr val="0F1B2D"/>
                 </a:solidFill>
                 <a:latin typeface="Segoe UI"/>
               </a:rPr>
-              <a:t>4 s segments at 2 s stride</a:t>
-            </a:r>
-            <a:r>
-              <a:rPr sz="1300" b="0">
+              <a:t>voice fingerprint</a:t>
+            </a:r>
+            <a:r>
+              <a:rPr sz="1900" b="0">
                 <a:solidFill>
                   <a:srgbClr val="33415C"/>
                 </a:solidFill>
                 <a:latin typeface="Segoe UI"/>
               </a:rPr>
-              <a:t>.</a:t>
-            </a:r>
-          </a:p>
-          <a:p>
-            <a:pPr>
-              <a:spcAft>
-                <a:spcPts val="900"/>
-              </a:spcAft>
-            </a:pPr>
-            <a:r>
-              <a:rPr sz="1300" b="1">
+              <a:t> (is it the agent?) and </a:t>
+            </a:r>
+            <a:r>
+              <a:rPr sz="1900" b="1">
                 <a:solidFill>
                   <a:srgbClr val="0F1B2D"/>
                 </a:solidFill>
                 <a:latin typeface="Segoe UI"/>
               </a:rPr>
-              <a:t>Depth — act on the worst segment: </a:t>
-            </a:r>
-            <a:r>
-              <a:rPr sz="1300" b="0">
+              <a:t>machine-voice check</a:t>
+            </a:r>
+            <a:r>
+              <a:rPr sz="1900" b="0">
                 <a:solidFill>
                   <a:srgbClr val="33415C"/>
                 </a:solidFill>
                 <a:latin typeface="Segoe UI"/>
               </a:rPr>
-              <a:t>an aggregate can launder a 3-second clone. The policy holds on the </a:t>
-            </a:r>
-            <a:r>
-              <a:rPr sz="1300" b="1">
+              <a:t> (does it sound synthetic?).</a:t>
+            </a:r>
+          </a:p>
+          <a:p>
+            <a:r>
+              <a:rPr sz="1900" b="0">
+                <a:solidFill>
+                  <a:srgbClr val="33415C"/>
+                </a:solidFill>
+                <a:latin typeface="Segoe UI"/>
+              </a:rPr>
+              <a:t>A scammer only needs </a:t>
+            </a:r>
+            <a:r>
+              <a:rPr sz="1900" b="1">
                 <a:solidFill>
                   <a:srgbClr val="0F1B2D"/>
                 </a:solidFill>
                 <a:latin typeface="Segoe UI"/>
               </a:rPr>
-              <a:t>segment maximum</a:t>
-            </a:r>
-            <a:r>
-              <a:rPr sz="1300" b="0">
+              <a:t>3 bad seconds</a:t>
+            </a:r>
+            <a:r>
+              <a:rPr sz="1900" b="0">
                 <a:solidFill>
                   <a:srgbClr val="33415C"/>
                 </a:solidFill>
                 <a:latin typeface="Segoe UI"/>
               </a:rPr>
-              <a:t>.</a:t>
-            </a:r>
-          </a:p>
-          <a:p>
-            <a:pPr>
-              <a:spcAft>
-                <a:spcPts val="900"/>
-              </a:spcAft>
-            </a:pPr>
-            <a:r>
-              <a:rPr sz="1300" b="1">
+              <a:t> to steal the money — so we never average. </a:t>
+            </a:r>
+            <a:r>
+              <a:rPr sz="1900" b="1">
                 <a:solidFill>
                   <a:srgbClr val="0F1B2D"/>
                 </a:solidFill>
                 <a:latin typeface="Segoe UI"/>
               </a:rPr>
-              <a:t>Two signals, layered: </a:t>
-            </a:r>
-            <a:r>
-              <a:rPr sz="1300" b="1">
-                <a:solidFill>
-                  <a:srgbClr val="0F1B2D"/>
-                </a:solidFill>
-                <a:latin typeface="Segoe UI"/>
-              </a:rPr>
-              <a:t>capture-and-replay</a:t>
-            </a:r>
-            <a:r>
-              <a:rPr sz="1300" b="0">
-                <a:solidFill>
-                  <a:srgbClr val="33415C"/>
-                </a:solidFill>
-                <a:latin typeface="Segoe UI"/>
-              </a:rPr>
-              <a:t> — identical audio re-sent mid-call is held on content identity; </a:t>
-            </a:r>
-            <a:r>
-              <a:rPr sz="1300" b="1">
-                <a:solidFill>
-                  <a:srgbClr val="0F1B2D"/>
-                </a:solidFill>
-                <a:latin typeface="Segoe UI"/>
-              </a:rPr>
-              <a:t>stdlib forensics</a:t>
-            </a:r>
-            <a:r>
-              <a:rPr sz="1300" b="0">
-                <a:solidFill>
-                  <a:srgbClr val="33415C"/>
-                </a:solidFill>
-                <a:latin typeface="Segoe UI"/>
-              </a:rPr>
-              <a:t> — digital render artifact ≥ 0.85 escalates (never convicts). Weights live in one policy module.</a:t>
-            </a:r>
-          </a:p>
-          <a:p>
-            <a:pPr>
-              <a:spcAft>
-                <a:spcPts val="900"/>
-              </a:spcAft>
-            </a:pPr>
-            <a:r>
-              <a:rPr sz="1300" b="1">
-                <a:solidFill>
-                  <a:srgbClr val="0F1B2D"/>
-                </a:solidFill>
-                <a:latin typeface="Segoe UI"/>
-              </a:rPr>
-              <a:t>Calibrated, transfer-checked: </a:t>
-            </a:r>
-            <a:r>
-              <a:rPr sz="1300" b="0">
-                <a:solidFill>
-                  <a:srgbClr val="33415C"/>
-                </a:solidFill>
-                <a:latin typeface="Segoe UI"/>
-              </a:rPr>
-              <a:t>n = </a:t>
-            </a:r>
-            <a:r>
-              <a:rPr sz="1300" b="1">
-                <a:solidFill>
-                  <a:srgbClr val="0F1B2D"/>
-                </a:solidFill>
-                <a:latin typeface="Segoe UI"/>
-              </a:rPr>
-              <a:t>27 labelled segments</a:t>
-            </a:r>
-            <a:r>
-              <a:rPr sz="1300" b="0">
-                <a:solidFill>
-                  <a:srgbClr val="33415C"/>
-                </a:solidFill>
-                <a:latin typeface="Segoe UI"/>
-              </a:rPr>
-              <a:t>, two transform families, two voices. Genuine/clone separation is complete (genuine ≤ 0.021 vs clone ≥ 0.998) and </a:t>
-            </a:r>
-            <a:r>
-              <a:rPr sz="1300" b="1">
-                <a:solidFill>
-                  <a:srgbClr val="0F1B2D"/>
-                </a:solidFill>
-                <a:latin typeface="Segoe UI"/>
-              </a:rPr>
-              <a:t>transfers</a:t>
-            </a:r>
-            <a:r>
-              <a:rPr sz="1300" b="0">
-                <a:solidFill>
-                  <a:srgbClr val="33415C"/>
-                </a:solidFill>
-                <a:latin typeface="Segoe UI"/>
-              </a:rPr>
-              <a:t> — including through a telephony band-pass. Honest caveat: FAR/FRR vs unseen real speakers is open — “tuned and transfer-checked”, not “validated”.</a:t>
-            </a:r>
-          </a:p>
-          <a:p>
-            <a:pPr>
-              <a:spcAft>
-                <a:spcPts val="900"/>
-              </a:spcAft>
-            </a:pPr>
-            <a:r>
-              <a:rPr sz="1300" b="1">
-                <a:solidFill>
-                  <a:srgbClr val="0F1B2D"/>
-                </a:solidFill>
-                <a:latin typeface="Segoe UI"/>
-              </a:rPr>
-              <a:t>Fail-closed: </a:t>
-            </a:r>
-            <a:r>
-              <a:rPr sz="1300" b="0">
-                <a:solidFill>
-                  <a:srgbClr val="33415C"/>
-                </a:solidFill>
-                <a:latin typeface="Segoe UI"/>
-              </a:rPr>
-              <a:t>silent (422), partial evidence, 5xx and budget-exhaustion all step up. </a:t>
-            </a:r>
-            <a:r>
-              <a:rPr sz="1300" b="1">
-                <a:solidFill>
-                  <a:srgbClr val="0F1B2D"/>
-                </a:solidFill>
-                <a:latin typeface="Segoe UI"/>
-              </a:rPr>
-              <a:t>No error path returns proceed.</a:t>
-            </a:r>
-            <a:r>
-              <a:rPr sz="1300" b="0">
-                <a:solidFill>
-                  <a:srgbClr val="33415C"/>
-                </a:solidFill>
-                <a:latin typeface="Segoe UI"/>
-              </a:rPr>
-              <a:t> Fresh, credit-paying runs are an explicit opt-in behind a per-session cap.</a:t>
+              <a:t>One bad slice stops the call.</a:t>
             </a:r>
           </a:p>
         </p:txBody>
@@ -4830,8 +4520,8 @@
         </p:nvSpPr>
         <p:spPr>
           <a:xfrm>
-            <a:off x="6720840" y="1645920"/>
-            <a:ext cx="4846320" cy="274320"/>
+            <a:off x="685800" y="3520440"/>
+            <a:ext cx="6492240" cy="365760"/>
           </a:xfrm>
           <a:prstGeom prst="rect">
             <a:avLst/>
@@ -4845,429 +4535,27 @@
           <a:lstStyle/>
           <a:p>
             <a:r>
-              <a:rPr sz="1100" b="1">
-                <a:solidFill>
-                  <a:srgbClr val="D6394B"/>
-                </a:solidFill>
-                <a:latin typeface="Segoe UI"/>
-              </a:rPr>
-              <a:t>AGGREGATE-BLIND HIJACK — HELD (live API)</a:t>
-            </a:r>
-          </a:p>
-        </p:txBody>
-      </p:sp>
-      <p:sp>
-        <p:nvSpPr>
-          <p:cNvPr id="9" name="TextBox 8"/>
-          <p:cNvSpPr txBox="1"/>
-          <p:nvPr/>
-        </p:nvSpPr>
-        <p:spPr>
-          <a:xfrm>
-            <a:off x="6720840" y="1920240"/>
-            <a:ext cx="1554480" cy="274320"/>
-          </a:xfrm>
-          <a:prstGeom prst="rect">
-            <a:avLst/>
-          </a:prstGeom>
-          <a:noFill/>
-        </p:spPr>
-        <p:txBody>
-          <a:bodyPr wrap="square">
-            <a:spAutoFit/>
-          </a:bodyPr>
-          <a:lstStyle/>
-          <a:p>
-            <a:r>
-              <a:rPr sz="1100">
-                <a:solidFill>
-                  <a:srgbClr val="64748B"/>
-                </a:solidFill>
-                <a:latin typeface="Segoe UI"/>
-              </a:rPr>
-              <a:t>voice similarity</a:t>
-            </a:r>
-          </a:p>
-        </p:txBody>
-      </p:sp>
-      <p:sp>
-        <p:nvSpPr>
-          <p:cNvPr id="10" name="Rectangle 9"/>
+              <a:rPr sz="1400" b="1">
+                <a:solidFill>
+                  <a:srgbClr val="0F1B2D"/>
+                </a:solidFill>
+                <a:latin typeface="Segoe UI"/>
+              </a:rPr>
+              <a:t>The sneaky attack, caught (from the live demo):</a:t>
+            </a:r>
+          </a:p>
+        </p:txBody>
+      </p:sp>
+      <p:sp>
+        <p:nvSpPr>
+          <p:cNvPr id="9" name="Rectangle 8"/>
           <p:cNvSpPr/>
           <p:nvPr/>
         </p:nvSpPr>
         <p:spPr>
           <a:xfrm>
-            <a:off x="8321040" y="1965960"/>
-            <a:ext cx="2468879" cy="146304"/>
-          </a:xfrm>
-          <a:prstGeom prst="rect">
-            <a:avLst/>
-          </a:prstGeom>
-          <a:solidFill>
-            <a:srgbClr val="E6ECF5"/>
-          </a:solidFill>
-          <a:ln>
-            <a:noFill/>
-          </a:ln>
-          <a:effectLst/>
-        </p:spPr>
-        <p:style>
-          <a:lnRef idx="1">
-            <a:schemeClr val="accent1"/>
-          </a:lnRef>
-          <a:fillRef idx="3">
-            <a:schemeClr val="accent1"/>
-          </a:fillRef>
-          <a:effectRef idx="2">
-            <a:schemeClr val="accent1"/>
-          </a:effectRef>
-          <a:fontRef idx="minor">
-            <a:schemeClr val="lt1"/>
-          </a:fontRef>
-        </p:style>
-        <p:txBody>
-          <a:bodyPr rtlCol="0" anchor="ctr"/>
-          <a:lstStyle/>
-          <a:p>
-            <a:pPr algn="ctr"/>
-          </a:p>
-        </p:txBody>
-      </p:sp>
-      <p:sp>
-        <p:nvSpPr>
-          <p:cNvPr id="11" name="Rectangle 10"/>
-          <p:cNvSpPr/>
-          <p:nvPr/>
-        </p:nvSpPr>
-        <p:spPr>
-          <a:xfrm>
-            <a:off x="8321040" y="1965960"/>
-            <a:ext cx="1893630" cy="146304"/>
-          </a:xfrm>
-          <a:prstGeom prst="rect">
-            <a:avLst/>
-          </a:prstGeom>
-          <a:solidFill>
-            <a:srgbClr val="0E9F6E"/>
-          </a:solidFill>
-          <a:ln>
-            <a:noFill/>
-          </a:ln>
-          <a:effectLst/>
-        </p:spPr>
-        <p:style>
-          <a:lnRef idx="1">
-            <a:schemeClr val="accent1"/>
-          </a:lnRef>
-          <a:fillRef idx="3">
-            <a:schemeClr val="accent1"/>
-          </a:fillRef>
-          <a:effectRef idx="2">
-            <a:schemeClr val="accent1"/>
-          </a:effectRef>
-          <a:fontRef idx="minor">
-            <a:schemeClr val="lt1"/>
-          </a:fontRef>
-        </p:style>
-        <p:txBody>
-          <a:bodyPr rtlCol="0" anchor="ctr"/>
-          <a:lstStyle/>
-          <a:p>
-            <a:pPr algn="ctr"/>
-          </a:p>
-        </p:txBody>
-      </p:sp>
-      <p:sp>
-        <p:nvSpPr>
-          <p:cNvPr id="12" name="Rectangle 11"/>
-          <p:cNvSpPr/>
-          <p:nvPr/>
-        </p:nvSpPr>
-        <p:spPr>
-          <a:xfrm>
-            <a:off x="9629546" y="1901952"/>
-            <a:ext cx="18288" cy="274320"/>
-          </a:xfrm>
-          <a:prstGeom prst="rect">
-            <a:avLst/>
-          </a:prstGeom>
-          <a:solidFill>
-            <a:srgbClr val="0F1B2D"/>
-          </a:solidFill>
-          <a:ln>
-            <a:noFill/>
-          </a:ln>
-          <a:effectLst/>
-        </p:spPr>
-        <p:style>
-          <a:lnRef idx="1">
-            <a:schemeClr val="accent1"/>
-          </a:lnRef>
-          <a:fillRef idx="3">
-            <a:schemeClr val="accent1"/>
-          </a:fillRef>
-          <a:effectRef idx="2">
-            <a:schemeClr val="accent1"/>
-          </a:effectRef>
-          <a:fontRef idx="minor">
-            <a:schemeClr val="lt1"/>
-          </a:fontRef>
-        </p:style>
-        <p:txBody>
-          <a:bodyPr rtlCol="0" anchor="ctr"/>
-          <a:lstStyle/>
-          <a:p>
-            <a:pPr algn="ctr"/>
-          </a:p>
-        </p:txBody>
-      </p:sp>
-      <p:sp>
-        <p:nvSpPr>
-          <p:cNvPr id="13" name="TextBox 12"/>
-          <p:cNvSpPr txBox="1"/>
-          <p:nvPr/>
-        </p:nvSpPr>
-        <p:spPr>
-          <a:xfrm>
-            <a:off x="10835639" y="1911096"/>
-            <a:ext cx="731520" cy="274320"/>
-          </a:xfrm>
-          <a:prstGeom prst="rect">
-            <a:avLst/>
-          </a:prstGeom>
-          <a:noFill/>
-        </p:spPr>
-        <p:txBody>
-          <a:bodyPr wrap="square">
-            <a:spAutoFit/>
-          </a:bodyPr>
-          <a:lstStyle/>
-          <a:p>
-            <a:pPr algn="r"/>
-            <a:r>
-              <a:rPr sz="1150" b="1">
-                <a:solidFill>
-                  <a:srgbClr val="0E9F6E"/>
-                </a:solidFill>
-                <a:latin typeface="Segoe UI"/>
-              </a:rPr>
-              <a:t>0.767</a:t>
-            </a:r>
-          </a:p>
-        </p:txBody>
-      </p:sp>
-      <p:sp>
-        <p:nvSpPr>
-          <p:cNvPr id="14" name="TextBox 13"/>
-          <p:cNvSpPr txBox="1"/>
-          <p:nvPr/>
-        </p:nvSpPr>
-        <p:spPr>
-          <a:xfrm>
-            <a:off x="6720840" y="2249424"/>
-            <a:ext cx="1554480" cy="274320"/>
-          </a:xfrm>
-          <a:prstGeom prst="rect">
-            <a:avLst/>
-          </a:prstGeom>
-          <a:noFill/>
-        </p:spPr>
-        <p:txBody>
-          <a:bodyPr wrap="square">
-            <a:spAutoFit/>
-          </a:bodyPr>
-          <a:lstStyle/>
-          <a:p>
-            <a:r>
-              <a:rPr sz="1100">
-                <a:solidFill>
-                  <a:srgbClr val="64748B"/>
-                </a:solidFill>
-                <a:latin typeface="Segoe UI"/>
-              </a:rPr>
-              <a:t>AI-gen score</a:t>
-            </a:r>
-          </a:p>
-        </p:txBody>
-      </p:sp>
-      <p:sp>
-        <p:nvSpPr>
-          <p:cNvPr id="15" name="Rectangle 14"/>
-          <p:cNvSpPr/>
-          <p:nvPr/>
-        </p:nvSpPr>
-        <p:spPr>
-          <a:xfrm>
-            <a:off x="8321040" y="2295144"/>
-            <a:ext cx="2468879" cy="146304"/>
-          </a:xfrm>
-          <a:prstGeom prst="rect">
-            <a:avLst/>
-          </a:prstGeom>
-          <a:solidFill>
-            <a:srgbClr val="E6ECF5"/>
-          </a:solidFill>
-          <a:ln>
-            <a:noFill/>
-          </a:ln>
-          <a:effectLst/>
-        </p:spPr>
-        <p:style>
-          <a:lnRef idx="1">
-            <a:schemeClr val="accent1"/>
-          </a:lnRef>
-          <a:fillRef idx="3">
-            <a:schemeClr val="accent1"/>
-          </a:fillRef>
-          <a:effectRef idx="2">
-            <a:schemeClr val="accent1"/>
-          </a:effectRef>
-          <a:fontRef idx="minor">
-            <a:schemeClr val="lt1"/>
-          </a:fontRef>
-        </p:style>
-        <p:txBody>
-          <a:bodyPr rtlCol="0" anchor="ctr"/>
-          <a:lstStyle/>
-          <a:p>
-            <a:pPr algn="ctr"/>
-          </a:p>
-        </p:txBody>
-      </p:sp>
-      <p:sp>
-        <p:nvSpPr>
-          <p:cNvPr id="16" name="Rectangle 15"/>
-          <p:cNvSpPr/>
-          <p:nvPr/>
-        </p:nvSpPr>
-        <p:spPr>
-          <a:xfrm>
-            <a:off x="8321040" y="2295144"/>
-            <a:ext cx="832012" cy="146304"/>
-          </a:xfrm>
-          <a:prstGeom prst="rect">
-            <a:avLst/>
-          </a:prstGeom>
-          <a:solidFill>
-            <a:srgbClr val="0E9F6E"/>
-          </a:solidFill>
-          <a:ln>
-            <a:noFill/>
-          </a:ln>
-          <a:effectLst/>
-        </p:spPr>
-        <p:style>
-          <a:lnRef idx="1">
-            <a:schemeClr val="accent1"/>
-          </a:lnRef>
-          <a:fillRef idx="3">
-            <a:schemeClr val="accent1"/>
-          </a:fillRef>
-          <a:effectRef idx="2">
-            <a:schemeClr val="accent1"/>
-          </a:effectRef>
-          <a:fontRef idx="minor">
-            <a:schemeClr val="lt1"/>
-          </a:fontRef>
-        </p:style>
-        <p:txBody>
-          <a:bodyPr rtlCol="0" anchor="ctr"/>
-          <a:lstStyle/>
-          <a:p>
-            <a:pPr algn="ctr"/>
-          </a:p>
-        </p:txBody>
-      </p:sp>
-      <p:sp>
-        <p:nvSpPr>
-          <p:cNvPr id="17" name="Rectangle 16"/>
-          <p:cNvSpPr/>
-          <p:nvPr/>
-        </p:nvSpPr>
-        <p:spPr>
-          <a:xfrm>
-            <a:off x="9851745" y="2231136"/>
-            <a:ext cx="18288" cy="274320"/>
-          </a:xfrm>
-          <a:prstGeom prst="rect">
-            <a:avLst/>
-          </a:prstGeom>
-          <a:solidFill>
-            <a:srgbClr val="0F1B2D"/>
-          </a:solidFill>
-          <a:ln>
-            <a:noFill/>
-          </a:ln>
-          <a:effectLst/>
-        </p:spPr>
-        <p:style>
-          <a:lnRef idx="1">
-            <a:schemeClr val="accent1"/>
-          </a:lnRef>
-          <a:fillRef idx="3">
-            <a:schemeClr val="accent1"/>
-          </a:fillRef>
-          <a:effectRef idx="2">
-            <a:schemeClr val="accent1"/>
-          </a:effectRef>
-          <a:fontRef idx="minor">
-            <a:schemeClr val="lt1"/>
-          </a:fontRef>
-        </p:style>
-        <p:txBody>
-          <a:bodyPr rtlCol="0" anchor="ctr"/>
-          <a:lstStyle/>
-          <a:p>
-            <a:pPr algn="ctr"/>
-          </a:p>
-        </p:txBody>
-      </p:sp>
-      <p:sp>
-        <p:nvSpPr>
-          <p:cNvPr id="18" name="TextBox 17"/>
-          <p:cNvSpPr txBox="1"/>
-          <p:nvPr/>
-        </p:nvSpPr>
-        <p:spPr>
-          <a:xfrm>
-            <a:off x="10835639" y="2240280"/>
-            <a:ext cx="731520" cy="274320"/>
-          </a:xfrm>
-          <a:prstGeom prst="rect">
-            <a:avLst/>
-          </a:prstGeom>
-          <a:noFill/>
-        </p:spPr>
-        <p:txBody>
-          <a:bodyPr wrap="square">
-            <a:spAutoFit/>
-          </a:bodyPr>
-          <a:lstStyle/>
-          <a:p>
-            <a:pPr algn="r"/>
-            <a:r>
-              <a:rPr sz="1150" b="1">
-                <a:solidFill>
-                  <a:srgbClr val="0E9F6E"/>
-                </a:solidFill>
-                <a:latin typeface="Segoe UI"/>
-              </a:rPr>
-              <a:t>0.337</a:t>
-            </a:r>
-          </a:p>
-        </p:txBody>
-      </p:sp>
-      <p:sp>
-        <p:nvSpPr>
-          <p:cNvPr id="19" name="Rectangle 18"/>
-          <p:cNvSpPr/>
-          <p:nvPr/>
-        </p:nvSpPr>
-        <p:spPr>
-          <a:xfrm>
-            <a:off x="6702552" y="2615184"/>
-            <a:ext cx="4882896" cy="420623"/>
+            <a:off x="658368" y="3904487"/>
+            <a:ext cx="6547103" cy="512064"/>
           </a:xfrm>
           <a:prstGeom prst="rect">
             <a:avLst/>
@@ -5306,14 +4594,14 @@
       </p:sp>
       <p:sp>
         <p:nvSpPr>
-          <p:cNvPr id="20" name="Rectangle 19"/>
+          <p:cNvPr id="10" name="Rectangle 9"/>
           <p:cNvSpPr/>
           <p:nvPr/>
         </p:nvSpPr>
         <p:spPr>
           <a:xfrm>
-            <a:off x="6720840" y="2633472"/>
-            <a:ext cx="1491175" cy="384048"/>
+            <a:off x="685800" y="3931920"/>
+            <a:ext cx="1854925" cy="457200"/>
           </a:xfrm>
           <a:prstGeom prst="rect">
             <a:avLst/>
@@ -5350,14 +4638,14 @@
       </p:sp>
       <p:sp>
         <p:nvSpPr>
-          <p:cNvPr id="21" name="Rectangle 20"/>
+          <p:cNvPr id="11" name="Rectangle 10"/>
           <p:cNvSpPr/>
           <p:nvPr/>
         </p:nvSpPr>
         <p:spPr>
           <a:xfrm>
-            <a:off x="7466427" y="2633472"/>
-            <a:ext cx="1491175" cy="384048"/>
+            <a:off x="2540725" y="3931920"/>
+            <a:ext cx="1854925" cy="457200"/>
           </a:xfrm>
           <a:prstGeom prst="rect">
             <a:avLst/>
@@ -5394,58 +4682,14 @@
       </p:sp>
       <p:sp>
         <p:nvSpPr>
-          <p:cNvPr id="22" name="Rectangle 21"/>
+          <p:cNvPr id="12" name="Rectangle 11"/>
           <p:cNvSpPr/>
           <p:nvPr/>
         </p:nvSpPr>
         <p:spPr>
           <a:xfrm>
-            <a:off x="8212015" y="2633472"/>
-            <a:ext cx="1491175" cy="384048"/>
-          </a:xfrm>
-          <a:prstGeom prst="rect">
-            <a:avLst/>
-          </a:prstGeom>
-          <a:solidFill>
-            <a:srgbClr val="0E9F6E"/>
-          </a:solidFill>
-          <a:ln>
-            <a:noFill/>
-          </a:ln>
-          <a:effectLst/>
-        </p:spPr>
-        <p:style>
-          <a:lnRef idx="1">
-            <a:schemeClr val="accent1"/>
-          </a:lnRef>
-          <a:fillRef idx="3">
-            <a:schemeClr val="accent1"/>
-          </a:fillRef>
-          <a:effectRef idx="2">
-            <a:schemeClr val="accent1"/>
-          </a:effectRef>
-          <a:fontRef idx="minor">
-            <a:schemeClr val="lt1"/>
-          </a:fontRef>
-        </p:style>
-        <p:txBody>
-          <a:bodyPr rtlCol="0" anchor="ctr"/>
-          <a:lstStyle/>
-          <a:p>
-            <a:pPr algn="ctr"/>
-          </a:p>
-        </p:txBody>
-      </p:sp>
-      <p:sp>
-        <p:nvSpPr>
-          <p:cNvPr id="23" name="Rectangle 22"/>
-          <p:cNvSpPr/>
-          <p:nvPr/>
-        </p:nvSpPr>
-        <p:spPr>
-          <a:xfrm>
-            <a:off x="9703190" y="2633472"/>
-            <a:ext cx="745587" cy="384048"/>
+            <a:off x="4395651" y="3931920"/>
+            <a:ext cx="927462" cy="457200"/>
           </a:xfrm>
           <a:prstGeom prst="rect">
             <a:avLst/>
@@ -5482,14 +4726,14 @@
       </p:sp>
       <p:sp>
         <p:nvSpPr>
-          <p:cNvPr id="24" name="Rectangle 23"/>
+          <p:cNvPr id="13" name="Rectangle 12"/>
           <p:cNvSpPr/>
           <p:nvPr/>
         </p:nvSpPr>
         <p:spPr>
           <a:xfrm>
-            <a:off x="10448778" y="2633472"/>
-            <a:ext cx="745587" cy="384048"/>
+            <a:off x="5323114" y="3931920"/>
+            <a:ext cx="927462" cy="457200"/>
           </a:xfrm>
           <a:prstGeom prst="rect">
             <a:avLst/>
@@ -5526,203 +4770,14 @@
       </p:sp>
       <p:sp>
         <p:nvSpPr>
-          <p:cNvPr id="25" name="TextBox 24"/>
-          <p:cNvSpPr txBox="1"/>
-          <p:nvPr/>
-        </p:nvSpPr>
-        <p:spPr>
-          <a:xfrm>
-            <a:off x="6720840" y="3072384"/>
-            <a:ext cx="4846320" cy="274320"/>
-          </a:xfrm>
-          <a:prstGeom prst="rect">
-            <a:avLst/>
-          </a:prstGeom>
-          <a:noFill/>
-        </p:spPr>
-        <p:txBody>
-          <a:bodyPr wrap="square">
-            <a:spAutoFit/>
-          </a:bodyPr>
-          <a:lstStyle/>
-          <a:p>
-            <a:r>
-              <a:rPr sz="1050">
-                <a:solidFill>
-                  <a:srgbClr val="64748B"/>
-                </a:solidFill>
-                <a:latin typeface="Segoe UI"/>
-              </a:rPr>
-              <a:t>aggregate says “real” — segment max 0.999 at 8–13 s → HOLD</a:t>
-            </a:r>
-          </a:p>
-        </p:txBody>
-      </p:sp>
-      <p:sp>
-        <p:nvSpPr>
-          <p:cNvPr id="26" name="TextBox 25"/>
-          <p:cNvSpPr txBox="1"/>
-          <p:nvPr/>
-        </p:nvSpPr>
-        <p:spPr>
-          <a:xfrm>
-            <a:off x="6720840" y="3401568"/>
-            <a:ext cx="4846320" cy="822960"/>
-          </a:xfrm>
-          <a:prstGeom prst="rect">
-            <a:avLst/>
-          </a:prstGeom>
-          <a:noFill/>
-        </p:spPr>
-        <p:txBody>
-          <a:bodyPr wrap="square">
-            <a:spAutoFit/>
-          </a:bodyPr>
-          <a:lstStyle/>
-          <a:p>
-            <a:r>
-              <a:rPr sz="1150" b="1">
-                <a:solidFill>
-                  <a:srgbClr val="0F1B2D"/>
-                </a:solidFill>
-                <a:latin typeface="Segoe UI"/>
-              </a:rPr>
-              <a:t>An aggregate-only policy approves this call.</a:t>
-            </a:r>
-            <a:r>
-              <a:rPr sz="1150" b="0">
-                <a:solidFill>
-                  <a:srgbClr val="33415C"/>
-                </a:solidFill>
-                <a:latin typeface="Segoe UI"/>
-              </a:rPr>
-              <a:t> Only the segment view catches the clone.</a:t>
-            </a:r>
-          </a:p>
-        </p:txBody>
-      </p:sp>
-      <p:sp>
-        <p:nvSpPr>
-          <p:cNvPr id="27" name="TextBox 26"/>
-          <p:cNvSpPr txBox="1"/>
-          <p:nvPr/>
-        </p:nvSpPr>
-        <p:spPr>
-          <a:xfrm>
-            <a:off x="6720840" y="4160520"/>
-            <a:ext cx="4846320" cy="274320"/>
-          </a:xfrm>
-          <a:prstGeom prst="rect">
-            <a:avLst/>
-          </a:prstGeom>
-          <a:noFill/>
-        </p:spPr>
-        <p:txBody>
-          <a:bodyPr wrap="square">
-            <a:spAutoFit/>
-          </a:bodyPr>
-          <a:lstStyle/>
-          <a:p>
-            <a:r>
-              <a:rPr sz="1100" b="1">
-                <a:solidFill>
-                  <a:srgbClr val="D6394B"/>
-                </a:solidFill>
-                <a:latin typeface="Segoe UI"/>
-              </a:rPr>
-              <a:t>SECOND TRANSFER CHECK — HELD (fresh score)</a:t>
-            </a:r>
-          </a:p>
-        </p:txBody>
-      </p:sp>
-      <p:sp>
-        <p:nvSpPr>
-          <p:cNvPr id="28" name="TextBox 27"/>
-          <p:cNvSpPr txBox="1"/>
-          <p:nvPr/>
-        </p:nvSpPr>
-        <p:spPr>
-          <a:xfrm>
-            <a:off x="6720840" y="4434840"/>
-            <a:ext cx="1554480" cy="274320"/>
-          </a:xfrm>
-          <a:prstGeom prst="rect">
-            <a:avLst/>
-          </a:prstGeom>
-          <a:noFill/>
-        </p:spPr>
-        <p:txBody>
-          <a:bodyPr wrap="square">
-            <a:spAutoFit/>
-          </a:bodyPr>
-          <a:lstStyle/>
-          <a:p>
-            <a:r>
-              <a:rPr sz="1100">
-                <a:solidFill>
-                  <a:srgbClr val="64748B"/>
-                </a:solidFill>
-                <a:latin typeface="Segoe UI"/>
-              </a:rPr>
-              <a:t>voice similarity</a:t>
-            </a:r>
-          </a:p>
-        </p:txBody>
-      </p:sp>
-      <p:sp>
-        <p:nvSpPr>
-          <p:cNvPr id="29" name="Rectangle 28"/>
+          <p:cNvPr id="14" name="Rectangle 13"/>
           <p:cNvSpPr/>
           <p:nvPr/>
         </p:nvSpPr>
         <p:spPr>
           <a:xfrm>
-            <a:off x="8321040" y="4480559"/>
-            <a:ext cx="2468879" cy="146304"/>
-          </a:xfrm>
-          <a:prstGeom prst="rect">
-            <a:avLst/>
-          </a:prstGeom>
-          <a:solidFill>
-            <a:srgbClr val="E6ECF5"/>
-          </a:solidFill>
-          <a:ln>
-            <a:noFill/>
-          </a:ln>
-          <a:effectLst/>
-        </p:spPr>
-        <p:style>
-          <a:lnRef idx="1">
-            <a:schemeClr val="accent1"/>
-          </a:lnRef>
-          <a:fillRef idx="3">
-            <a:schemeClr val="accent1"/>
-          </a:fillRef>
-          <a:effectRef idx="2">
-            <a:schemeClr val="accent1"/>
-          </a:effectRef>
-          <a:fontRef idx="minor">
-            <a:schemeClr val="lt1"/>
-          </a:fontRef>
-        </p:style>
-        <p:txBody>
-          <a:bodyPr rtlCol="0" anchor="ctr"/>
-          <a:lstStyle/>
-          <a:p>
-            <a:pPr algn="ctr"/>
-          </a:p>
-        </p:txBody>
-      </p:sp>
-      <p:sp>
-        <p:nvSpPr>
-          <p:cNvPr id="30" name="Rectangle 29"/>
-          <p:cNvSpPr/>
-          <p:nvPr/>
-        </p:nvSpPr>
-        <p:spPr>
-          <a:xfrm>
-            <a:off x="8321040" y="4480559"/>
-            <a:ext cx="120975" cy="146304"/>
+            <a:off x="6250577" y="3931920"/>
+            <a:ext cx="927462" cy="457200"/>
           </a:xfrm>
           <a:prstGeom prst="rect">
             <a:avLst/>
@@ -5759,58 +4814,14 @@
       </p:sp>
       <p:sp>
         <p:nvSpPr>
-          <p:cNvPr id="31" name="Rectangle 30"/>
-          <p:cNvSpPr/>
-          <p:nvPr/>
-        </p:nvSpPr>
-        <p:spPr>
-          <a:xfrm>
-            <a:off x="9629546" y="4416552"/>
-            <a:ext cx="18288" cy="274320"/>
-          </a:xfrm>
-          <a:prstGeom prst="rect">
-            <a:avLst/>
-          </a:prstGeom>
-          <a:solidFill>
-            <a:srgbClr val="0F1B2D"/>
-          </a:solidFill>
-          <a:ln>
-            <a:noFill/>
-          </a:ln>
-          <a:effectLst/>
-        </p:spPr>
-        <p:style>
-          <a:lnRef idx="1">
-            <a:schemeClr val="accent1"/>
-          </a:lnRef>
-          <a:fillRef idx="3">
-            <a:schemeClr val="accent1"/>
-          </a:fillRef>
-          <a:effectRef idx="2">
-            <a:schemeClr val="accent1"/>
-          </a:effectRef>
-          <a:fontRef idx="minor">
-            <a:schemeClr val="lt1"/>
-          </a:fontRef>
-        </p:style>
-        <p:txBody>
-          <a:bodyPr rtlCol="0" anchor="ctr"/>
-          <a:lstStyle/>
-          <a:p>
-            <a:pPr algn="ctr"/>
-          </a:p>
-        </p:txBody>
-      </p:sp>
-      <p:sp>
-        <p:nvSpPr>
-          <p:cNvPr id="32" name="TextBox 31"/>
+          <p:cNvPr id="15" name="TextBox 14"/>
           <p:cNvSpPr txBox="1"/>
           <p:nvPr/>
         </p:nvSpPr>
         <p:spPr>
           <a:xfrm>
-            <a:off x="10835639" y="4425696"/>
-            <a:ext cx="731520" cy="274320"/>
+            <a:off x="685800" y="4462272"/>
+            <a:ext cx="6492240" cy="502920"/>
           </a:xfrm>
           <a:prstGeom prst="rect">
             <a:avLst/>
@@ -5823,29 +4834,28 @@
           </a:bodyPr>
           <a:lstStyle/>
           <a:p>
-            <a:pPr algn="r"/>
-            <a:r>
-              <a:rPr sz="1150" b="1">
-                <a:solidFill>
-                  <a:srgbClr val="D6394B"/>
-                </a:solidFill>
-                <a:latin typeface="Segoe UI"/>
-              </a:rPr>
-              <a:t>0.049</a:t>
-            </a:r>
-          </a:p>
-        </p:txBody>
-      </p:sp>
-      <p:sp>
-        <p:nvSpPr>
-          <p:cNvPr id="33" name="TextBox 32"/>
+            <a:r>
+              <a:rPr sz="1200" b="0">
+                <a:solidFill>
+                  <a:srgbClr val="33415C"/>
+                </a:solidFill>
+                <a:latin typeface="Segoe UI"/>
+              </a:rPr>
+              <a:t>Fingerprint passed · overall score said “human” · but slice 3–4 of the call (9–12 s) scored 0.999 “machine” → RED.  An average-hunting system would have approved this call.</a:t>
+            </a:r>
+          </a:p>
+        </p:txBody>
+      </p:sp>
+      <p:sp>
+        <p:nvSpPr>
+          <p:cNvPr id="16" name="TextBox 15"/>
           <p:cNvSpPr txBox="1"/>
           <p:nvPr/>
         </p:nvSpPr>
         <p:spPr>
           <a:xfrm>
-            <a:off x="6720840" y="4764024"/>
-            <a:ext cx="1554480" cy="274320"/>
+            <a:off x="7635240" y="3520440"/>
+            <a:ext cx="3931920" cy="2286000"/>
           </a:xfrm>
           <a:prstGeom prst="rect">
             <a:avLst/>
@@ -5859,400 +4869,57 @@
           <a:lstStyle/>
           <a:p>
             <a:r>
-              <a:rPr sz="1100">
-                <a:solidFill>
-                  <a:srgbClr val="64748B"/>
-                </a:solidFill>
-                <a:latin typeface="Segoe UI"/>
-              </a:rPr>
-              <a:t>AI-gen score</a:t>
-            </a:r>
-          </a:p>
-        </p:txBody>
-      </p:sp>
-      <p:sp>
-        <p:nvSpPr>
-          <p:cNvPr id="34" name="Rectangle 33"/>
-          <p:cNvSpPr/>
-          <p:nvPr/>
-        </p:nvSpPr>
-        <p:spPr>
-          <a:xfrm>
-            <a:off x="8321040" y="4809744"/>
-            <a:ext cx="2468879" cy="146304"/>
-          </a:xfrm>
-          <a:prstGeom prst="rect">
-            <a:avLst/>
-          </a:prstGeom>
-          <a:solidFill>
-            <a:srgbClr val="E6ECF5"/>
-          </a:solidFill>
-          <a:ln>
-            <a:noFill/>
-          </a:ln>
-          <a:effectLst/>
-        </p:spPr>
-        <p:style>
-          <a:lnRef idx="1">
-            <a:schemeClr val="accent1"/>
-          </a:lnRef>
-          <a:fillRef idx="3">
-            <a:schemeClr val="accent1"/>
-          </a:fillRef>
-          <a:effectRef idx="2">
-            <a:schemeClr val="accent1"/>
-          </a:effectRef>
-          <a:fontRef idx="minor">
-            <a:schemeClr val="lt1"/>
-          </a:fontRef>
-        </p:style>
-        <p:txBody>
-          <a:bodyPr rtlCol="0" anchor="ctr"/>
-          <a:lstStyle/>
-          <a:p>
-            <a:pPr algn="ctr"/>
-          </a:p>
-        </p:txBody>
-      </p:sp>
-      <p:sp>
-        <p:nvSpPr>
-          <p:cNvPr id="35" name="Rectangle 34"/>
-          <p:cNvSpPr/>
-          <p:nvPr/>
-        </p:nvSpPr>
-        <p:spPr>
-          <a:xfrm>
-            <a:off x="8321040" y="4809744"/>
-            <a:ext cx="2466411" cy="146304"/>
-          </a:xfrm>
-          <a:prstGeom prst="rect">
-            <a:avLst/>
-          </a:prstGeom>
-          <a:solidFill>
-            <a:srgbClr val="0E9F6E"/>
-          </a:solidFill>
-          <a:ln>
-            <a:noFill/>
-          </a:ln>
-          <a:effectLst/>
-        </p:spPr>
-        <p:style>
-          <a:lnRef idx="1">
-            <a:schemeClr val="accent1"/>
-          </a:lnRef>
-          <a:fillRef idx="3">
-            <a:schemeClr val="accent1"/>
-          </a:fillRef>
-          <a:effectRef idx="2">
-            <a:schemeClr val="accent1"/>
-          </a:effectRef>
-          <a:fontRef idx="minor">
-            <a:schemeClr val="lt1"/>
-          </a:fontRef>
-        </p:style>
-        <p:txBody>
-          <a:bodyPr rtlCol="0" anchor="ctr"/>
-          <a:lstStyle/>
-          <a:p>
-            <a:pPr algn="ctr"/>
-          </a:p>
-        </p:txBody>
-      </p:sp>
-      <p:sp>
-        <p:nvSpPr>
-          <p:cNvPr id="36" name="Rectangle 35"/>
-          <p:cNvSpPr/>
-          <p:nvPr/>
-        </p:nvSpPr>
-        <p:spPr>
-          <a:xfrm>
-            <a:off x="9851745" y="4745736"/>
-            <a:ext cx="18288" cy="274320"/>
-          </a:xfrm>
-          <a:prstGeom prst="rect">
-            <a:avLst/>
-          </a:prstGeom>
-          <a:solidFill>
-            <a:srgbClr val="0F1B2D"/>
-          </a:solidFill>
-          <a:ln>
-            <a:noFill/>
-          </a:ln>
-          <a:effectLst/>
-        </p:spPr>
-        <p:style>
-          <a:lnRef idx="1">
-            <a:schemeClr val="accent1"/>
-          </a:lnRef>
-          <a:fillRef idx="3">
-            <a:schemeClr val="accent1"/>
-          </a:fillRef>
-          <a:effectRef idx="2">
-            <a:schemeClr val="accent1"/>
-          </a:effectRef>
-          <a:fontRef idx="minor">
-            <a:schemeClr val="lt1"/>
-          </a:fontRef>
-        </p:style>
-        <p:txBody>
-          <a:bodyPr rtlCol="0" anchor="ctr"/>
-          <a:lstStyle/>
-          <a:p>
-            <a:pPr algn="ctr"/>
-          </a:p>
-        </p:txBody>
-      </p:sp>
-      <p:sp>
-        <p:nvSpPr>
-          <p:cNvPr id="37" name="TextBox 36"/>
-          <p:cNvSpPr txBox="1"/>
-          <p:nvPr/>
-        </p:nvSpPr>
-        <p:spPr>
-          <a:xfrm>
-            <a:off x="10835639" y="4754880"/>
-            <a:ext cx="731520" cy="274320"/>
-          </a:xfrm>
-          <a:prstGeom prst="rect">
-            <a:avLst/>
-          </a:prstGeom>
-          <a:noFill/>
-        </p:spPr>
-        <p:txBody>
-          <a:bodyPr wrap="square">
-            <a:spAutoFit/>
-          </a:bodyPr>
-          <a:lstStyle/>
-          <a:p>
-            <a:pPr algn="r"/>
-            <a:r>
-              <a:rPr sz="1150" b="1">
-                <a:solidFill>
-                  <a:srgbClr val="0E9F6E"/>
-                </a:solidFill>
-                <a:latin typeface="Segoe UI"/>
-              </a:rPr>
-              <a:t>0.999</a:t>
-            </a:r>
-          </a:p>
-        </p:txBody>
-      </p:sp>
-      <p:sp>
-        <p:nvSpPr>
-          <p:cNvPr id="38" name="Rectangle 37"/>
-          <p:cNvSpPr/>
-          <p:nvPr/>
-        </p:nvSpPr>
-        <p:spPr>
-          <a:xfrm>
-            <a:off x="6702552" y="5129784"/>
-            <a:ext cx="4882896" cy="420623"/>
-          </a:xfrm>
-          <a:prstGeom prst="rect">
-            <a:avLst/>
-          </a:prstGeom>
-          <a:solidFill>
-            <a:srgbClr val="F2F6FB"/>
-          </a:solidFill>
-          <a:ln w="9525">
-            <a:solidFill>
-              <a:srgbClr val="D3DEEE"/>
-            </a:solidFill>
-          </a:ln>
-          <a:effectLst/>
-        </p:spPr>
-        <p:style>
-          <a:lnRef idx="1">
-            <a:schemeClr val="accent1"/>
-          </a:lnRef>
-          <a:fillRef idx="3">
-            <a:schemeClr val="accent1"/>
-          </a:fillRef>
-          <a:effectRef idx="2">
-            <a:schemeClr val="accent1"/>
-          </a:effectRef>
-          <a:fontRef idx="minor">
-            <a:schemeClr val="lt1"/>
-          </a:fontRef>
-        </p:style>
-        <p:txBody>
-          <a:bodyPr rtlCol="0" anchor="ctr"/>
-          <a:lstStyle/>
-          <a:p>
-            <a:pPr algn="ctr"/>
-          </a:p>
-        </p:txBody>
-      </p:sp>
-      <p:sp>
-        <p:nvSpPr>
-          <p:cNvPr id="39" name="Rectangle 38"/>
-          <p:cNvSpPr/>
-          <p:nvPr/>
-        </p:nvSpPr>
-        <p:spPr>
-          <a:xfrm>
-            <a:off x="6720840" y="5148072"/>
-            <a:ext cx="1938528" cy="384048"/>
-          </a:xfrm>
-          <a:prstGeom prst="rect">
-            <a:avLst/>
-          </a:prstGeom>
-          <a:solidFill>
-            <a:srgbClr val="D6394B"/>
-          </a:solidFill>
-          <a:ln>
-            <a:noFill/>
-          </a:ln>
-          <a:effectLst/>
-        </p:spPr>
-        <p:style>
-          <a:lnRef idx="1">
-            <a:schemeClr val="accent1"/>
-          </a:lnRef>
-          <a:fillRef idx="3">
-            <a:schemeClr val="accent1"/>
-          </a:fillRef>
-          <a:effectRef idx="2">
-            <a:schemeClr val="accent1"/>
-          </a:effectRef>
-          <a:fontRef idx="minor">
-            <a:schemeClr val="lt1"/>
-          </a:fontRef>
-        </p:style>
-        <p:txBody>
-          <a:bodyPr rtlCol="0" anchor="ctr"/>
-          <a:lstStyle/>
-          <a:p>
-            <a:pPr algn="ctr"/>
-          </a:p>
-        </p:txBody>
-      </p:sp>
-      <p:sp>
-        <p:nvSpPr>
-          <p:cNvPr id="40" name="Rectangle 39"/>
-          <p:cNvSpPr/>
-          <p:nvPr/>
-        </p:nvSpPr>
-        <p:spPr>
-          <a:xfrm>
-            <a:off x="8659367" y="5148072"/>
-            <a:ext cx="484632" cy="384048"/>
-          </a:xfrm>
-          <a:prstGeom prst="rect">
-            <a:avLst/>
-          </a:prstGeom>
-          <a:solidFill>
-            <a:srgbClr val="D6394B"/>
-          </a:solidFill>
-          <a:ln>
-            <a:noFill/>
-          </a:ln>
-          <a:effectLst/>
-        </p:spPr>
-        <p:style>
-          <a:lnRef idx="1">
-            <a:schemeClr val="accent1"/>
-          </a:lnRef>
-          <a:fillRef idx="3">
-            <a:schemeClr val="accent1"/>
-          </a:fillRef>
-          <a:effectRef idx="2">
-            <a:schemeClr val="accent1"/>
-          </a:effectRef>
-          <a:fontRef idx="minor">
-            <a:schemeClr val="lt1"/>
-          </a:fontRef>
-        </p:style>
-        <p:txBody>
-          <a:bodyPr rtlCol="0" anchor="ctr"/>
-          <a:lstStyle/>
-          <a:p>
-            <a:pPr algn="ctr"/>
-          </a:p>
-        </p:txBody>
-      </p:sp>
-      <p:sp>
-        <p:nvSpPr>
-          <p:cNvPr id="41" name="TextBox 40"/>
-          <p:cNvSpPr txBox="1"/>
-          <p:nvPr/>
-        </p:nvSpPr>
-        <p:spPr>
-          <a:xfrm>
-            <a:off x="6720840" y="5586983"/>
-            <a:ext cx="4846320" cy="274320"/>
-          </a:xfrm>
-          <a:prstGeom prst="rect">
-            <a:avLst/>
-          </a:prstGeom>
-          <a:noFill/>
-        </p:spPr>
-        <p:txBody>
-          <a:bodyPr wrap="square">
-            <a:spAutoFit/>
-          </a:bodyPr>
-          <a:lstStyle/>
-          <a:p>
-            <a:r>
-              <a:rPr sz="1050">
-                <a:solidFill>
-                  <a:srgbClr val="64748B"/>
-                </a:solidFill>
-                <a:latin typeface="Segoe UI"/>
-              </a:rPr>
-              <a:t>engine-2 pitch-converted TTS: segs 0.999 / 0.9993 → HOLD</a:t>
-            </a:r>
-          </a:p>
-        </p:txBody>
-      </p:sp>
-      <p:sp>
-        <p:nvSpPr>
-          <p:cNvPr id="42" name="TextBox 41"/>
-          <p:cNvSpPr txBox="1"/>
-          <p:nvPr/>
-        </p:nvSpPr>
-        <p:spPr>
-          <a:xfrm>
-            <a:off x="6720840" y="5870448"/>
-            <a:ext cx="4846320" cy="457200"/>
-          </a:xfrm>
-          <a:prstGeom prst="rect">
-            <a:avLst/>
-          </a:prstGeom>
-          <a:noFill/>
-        </p:spPr>
-        <p:txBody>
-          <a:bodyPr wrap="square">
-            <a:spAutoFit/>
-          </a:bodyPr>
-          <a:lstStyle/>
-          <a:p>
-            <a:r>
-              <a:rPr sz="1100" b="0">
+              <a:rPr sz="1400" b="1">
+                <a:solidFill>
+                  <a:srgbClr val="0F1B2D"/>
+                </a:solidFill>
+                <a:latin typeface="Segoe UI"/>
+              </a:rPr>
+              <a:t>Try it in 30 seconds:</a:t>
+            </a:r>
+          </a:p>
+          <a:p>
+            <a:r>
+              <a:rPr sz="1500" b="0">
                 <a:solidFill>
                   <a:srgbClr val="33415C"/>
                 </a:solidFill>
                 <a:latin typeface="Segoe UI"/>
               </a:rPr>
-              <a:t>Telephony-band variant of the same attack: still </a:t>
-            </a:r>
-            <a:r>
-              <a:rPr sz="1100" b="1">
-                <a:solidFill>
-                  <a:srgbClr val="0F1B2D"/>
-                </a:solidFill>
-                <a:latin typeface="Segoe UI"/>
-              </a:rPr>
-              <a:t>0.998</a:t>
-            </a:r>
-            <a:r>
-              <a:rPr sz="1100" b="0">
+              <a:t>• Press Call 1 → green</a:t>
+            </a:r>
+          </a:p>
+          <a:p>
+            <a:r>
+              <a:rPr sz="1500" b="0">
                 <a:solidFill>
                   <a:srgbClr val="33415C"/>
                 </a:solidFill>
                 <a:latin typeface="Segoe UI"/>
               </a:rPr>
-              <a:t> — band-limiting helps detection.</a:t>
+              <a:t>• Press Call 2 → red, call stops</a:t>
+            </a:r>
+          </a:p>
+          <a:p>
+            <a:r>
+              <a:rPr sz="1500" b="0">
+                <a:solidFill>
+                  <a:srgbClr val="33415C"/>
+                </a:solidFill>
+                <a:latin typeface="Segoe UI"/>
+              </a:rPr>
+              <a:t>• Press the sneaky call → red from one slice</a:t>
+            </a:r>
+          </a:p>
+          <a:p>
+            <a:r>
+              <a:rPr sz="1500" b="0">
+                <a:solidFill>
+                  <a:srgbClr val="33415C"/>
+                </a:solidFill>
+                <a:latin typeface="Segoe UI"/>
+              </a:rPr>
+              <a:t>• Enrol your own voice → try it live</a:t>
             </a:r>
           </a:p>
         </p:txBody>
@@ -6342,13 +5009,13 @@
           <a:lstStyle/>
           <a:p>
             <a:r>
-              <a:rPr sz="1300" b="1">
+              <a:rPr sz="1200" b="1">
                 <a:solidFill>
                   <a:srgbClr val="0E9F6E"/>
                 </a:solidFill>
                 <a:latin typeface="Segoe UI"/>
               </a:rPr>
-              <a:t>SLIDE 4</a:t>
+              <a:t>SLIDE 4 · IMPACT</a:t>
             </a:r>
           </a:p>
         </p:txBody>
@@ -6376,13 +5043,13 @@
           <a:lstStyle/>
           <a:p>
             <a:r>
-              <a:rPr sz="3200" b="1">
+              <a:rPr sz="3400" b="1">
                 <a:solidFill>
                   <a:srgbClr val="0F1B2D"/>
                 </a:solidFill>
                 <a:latin typeface="Segoe UI"/>
               </a:rPr>
-              <a:t>Impact</a:t>
+              <a:t>What one caught call is worth</a:t>
             </a:r>
           </a:p>
         </p:txBody>
@@ -6395,7 +5062,7 @@
         </p:nvSpPr>
         <p:spPr>
           <a:xfrm>
-            <a:off x="658368" y="1426464"/>
+            <a:off x="658368" y="1481328"/>
             <a:ext cx="914400" cy="45720"/>
           </a:xfrm>
           <a:prstGeom prst="rect">
@@ -6439,8 +5106,8 @@
         </p:nvSpPr>
         <p:spPr>
           <a:xfrm>
-            <a:off x="640080" y="6327648"/>
-            <a:ext cx="11155680" cy="411480"/>
+            <a:off x="640080" y="6355080"/>
+            <a:ext cx="11155680" cy="365760"/>
           </a:xfrm>
           <a:prstGeom prst="rect">
             <a:avLst/>
@@ -6454,13 +5121,13 @@
           <a:lstStyle/>
           <a:p>
             <a:r>
-              <a:rPr sz="1050">
+              <a:rPr sz="1100">
                 <a:solidFill>
                   <a:srgbClr val="64748B"/>
                 </a:solidFill>
                 <a:latin typeface="Segoe UI"/>
               </a:rPr>
-              <a:t>Judge link: https://unclone-verified-agent.onrender.com   ·   in-product docs: Impact · Calibration · Scale &amp; Viability pages</a:t>
+              <a:t>Try it live — https://unclone-verified-agent.onrender.com</a:t>
             </a:r>
           </a:p>
         </p:txBody>
@@ -6473,8 +5140,8 @@
         </p:nvSpPr>
         <p:spPr>
           <a:xfrm>
-            <a:off x="640080" y="1783080"/>
-            <a:ext cx="6766560" cy="4480560"/>
+            <a:off x="640080" y="1965960"/>
+            <a:ext cx="6309360" cy="3840480"/>
           </a:xfrm>
           <a:prstGeom prst="rect">
             <a:avLst/>
@@ -6489,182 +5156,155 @@
           <a:p>
             <a:pPr>
               <a:spcAft>
-                <a:spcPts val="1000"/>
+                <a:spcPts val="1400"/>
               </a:spcAft>
             </a:pPr>
             <a:r>
-              <a:rPr sz="1400" b="1">
+              <a:rPr sz="1800" b="1">
                 <a:solidFill>
                   <a:srgbClr val="0F1B2D"/>
                 </a:solidFill>
                 <a:latin typeface="Segoe UI"/>
               </a:rPr>
-              <a:t>The model, five visible inputs: </a:t>
-            </a:r>
-            <a:r>
-              <a:rPr sz="1400" b="0">
+              <a:t>Loss per voice scam:  </a:t>
+            </a:r>
+            <a:r>
+              <a:rPr sz="1800" b="0">
                 <a:solidFill>
                   <a:srgbClr val="33415C"/>
                 </a:solidFill>
                 <a:latin typeface="Segoe UI"/>
               </a:rPr>
-              <a:t>1.56 M flagged calls/yr [A] × 1.33 % incidence [FTC/UK-APP] × $5,700 avg loss [FTC] × 80 % detection [calibration] × 70 % step-up conversion [A] ≈ </a:t>
-            </a:r>
-            <a:r>
-              <a:rPr sz="1400" b="1">
+              <a:t>≈ </a:t>
+            </a:r>
+            <a:r>
+              <a:rPr sz="1800" b="1">
                 <a:solidFill>
                   <a:srgbClr val="0F1B2D"/>
                 </a:solidFill>
                 <a:latin typeface="Segoe UI"/>
               </a:rPr>
-              <a:t>$66 M / yr prevented per mid-size bank</a:t>
-            </a:r>
-            <a:r>
-              <a:rPr sz="1400" b="0">
+              <a:t>$5,700</a:t>
+            </a:r>
+            <a:r>
+              <a:rPr sz="1800" b="0">
                 <a:solidFill>
                   <a:srgbClr val="33415C"/>
                 </a:solidFill>
                 <a:latin typeface="Segoe UI"/>
               </a:rPr>
-              <a:t>.</a:t>
+              <a:t> (≈ ₹4.8 lakh). (FTC 2024)</a:t>
             </a:r>
           </a:p>
           <a:p>
             <a:pPr>
               <a:spcAft>
-                <a:spcPts val="1000"/>
+                <a:spcPts val="1400"/>
               </a:spcAft>
             </a:pPr>
             <a:r>
-              <a:rPr sz="1400" b="1">
+              <a:rPr sz="1800" b="1">
                 <a:solidFill>
                   <a:srgbClr val="0F1B2D"/>
                 </a:solidFill>
                 <a:latin typeface="Segoe UI"/>
               </a:rPr>
-              <a:t>The number the deck was missing — precision at prevalence: </a:t>
-            </a:r>
-            <a:r>
-              <a:rPr sz="1400" b="0">
+              <a:t>Cost to check a risky call:  </a:t>
+            </a:r>
+            <a:r>
+              <a:rPr sz="1800" b="0">
                 <a:solidFill>
                   <a:srgbClr val="33415C"/>
                 </a:solidFill>
                 <a:latin typeface="Segoe UI"/>
               </a:rPr>
-              <a:t>screening flagged traffic gives ~</a:t>
-            </a:r>
-            <a:r>
-              <a:rPr sz="1400" b="1">
+              <a:t>≈ </a:t>
+            </a:r>
+            <a:r>
+              <a:rPr sz="1800" b="1">
                 <a:solidFill>
                   <a:srgbClr val="0F1B2D"/>
                 </a:solidFill>
                 <a:latin typeface="Segoe UI"/>
               </a:rPr>
-              <a:t>52 %</a:t>
-            </a:r>
-            <a:r>
-              <a:rPr sz="1400" b="0">
+              <a:t>50 cents.</a:t>
+            </a:r>
+            <a:r>
+              <a:rPr sz="1800" b="0">
                 <a:solidFill>
                   <a:srgbClr val="33415C"/>
                 </a:solidFill>
                 <a:latin typeface="Segoe UI"/>
               </a:rPr>
-              <a:t> precision at 80 % recall / 1 % FPR, ≈ </a:t>
-            </a:r>
-            <a:r>
-              <a:rPr sz="1400" b="1">
-                <a:solidFill>
-                  <a:srgbClr val="0F1B2D"/>
-                </a:solidFill>
-                <a:latin typeface="Segoe UI"/>
-              </a:rPr>
-              <a:t>10 false alarms per 1,000</a:t>
-            </a:r>
-            <a:r>
-              <a:rPr sz="1400" b="0">
-                <a:solidFill>
-                  <a:srgbClr val="33415C"/>
-                </a:solidFill>
-                <a:latin typeface="Segoe UI"/>
-              </a:rPr>
-              <a:t> genuine flagged calls — one false step-up per real catch. The same rates on the full inbound firehose give ~7 %: </a:t>
-            </a:r>
-            <a:r>
-              <a:rPr sz="1400" b="1">
-                <a:solidFill>
-                  <a:srgbClr val="0F1B2D"/>
-                </a:solidFill>
-                <a:latin typeface="Segoe UI"/>
-              </a:rPr>
-              <a:t>screen flagged traffic, not the firehose</a:t>
-            </a:r>
-            <a:r>
-              <a:rPr sz="1400" b="0">
-                <a:solidFill>
-                  <a:srgbClr val="33415C"/>
-                </a:solidFill>
-                <a:latin typeface="Segoe UI"/>
-              </a:rPr>
-              <a:t> is the design thesis.</a:t>
+              <a:t> The whole product story is this gap.</a:t>
             </a:r>
           </a:p>
           <a:p>
             <a:pPr>
               <a:spcAft>
-                <a:spcPts val="1000"/>
+                <a:spcPts val="1400"/>
               </a:spcAft>
             </a:pPr>
             <a:r>
-              <a:rPr sz="1400" b="1">
+              <a:rPr sz="1700" b="1">
                 <a:solidFill>
                   <a:srgbClr val="0F1B2D"/>
                 </a:solidFill>
                 <a:latin typeface="Segoe UI"/>
               </a:rPr>
-              <a:t>Latency, measured: </a:t>
-            </a:r>
-            <a:r>
-              <a:rPr sz="1400" b="1">
+              <a:t>At one big bank scale:  </a:t>
+            </a:r>
+            <a:r>
+              <a:rPr sz="1700" b="0">
+                <a:solidFill>
+                  <a:srgbClr val="33415C"/>
+                </a:solidFill>
+                <a:latin typeface="Segoe UI"/>
+              </a:rPr>
+              <a:t>≈ </a:t>
+            </a:r>
+            <a:r>
+              <a:rPr sz="1700" b="1">
                 <a:solidFill>
                   <a:srgbClr val="0F1B2D"/>
                 </a:solidFill>
                 <a:latin typeface="Segoe UI"/>
               </a:rPr>
-              <a:t>p50 0.6–2.6 s</a:t>
-            </a:r>
-            <a:r>
-              <a:rPr sz="1400" b="0">
+              <a:t>$66 M/yr</a:t>
+            </a:r>
+            <a:r>
+              <a:rPr sz="1700" b="0">
                 <a:solidFill>
                   <a:srgbClr val="33415C"/>
                 </a:solidFill>
                 <a:latin typeface="Segoe UI"/>
               </a:rPr>
-              <a:t> per window on the deployed build; the intervention point is the payment authorisation — inside the window. L3 telephony (blocking mid-conversation) is declared future work.</a:t>
+              <a:t> of prevented losses. That's the five-frame model: 1.56 M risky calls × 1.33 % scams × $5,700 × 80 % caught × 70 % stopped.</a:t>
             </a:r>
           </a:p>
           <a:p>
             <a:pPr>
               <a:spcAft>
-                <a:spcPts val="1000"/>
+                <a:spcPts val="1400"/>
               </a:spcAft>
             </a:pPr>
             <a:r>
-              <a:rPr sz="1400" b="1">
+              <a:rPr sz="1700" b="1">
                 <a:solidFill>
                   <a:srgbClr val="0F1B2D"/>
                 </a:solidFill>
                 <a:latin typeface="Segoe UI"/>
               </a:rPr>
-              <a:t>Customer cost bounded: </a:t>
-            </a:r>
-            <a:r>
-              <a:rPr sz="1400" b="0">
+              <a:t>False alarms are cheap:  </a:t>
+            </a:r>
+            <a:r>
+              <a:rPr sz="1700" b="0">
                 <a:solidFill>
                   <a:srgbClr val="33415C"/>
                 </a:solidFill>
                 <a:latin typeface="Segoe UI"/>
               </a:rPr>
-              <a:t>a false hold ends the call — the customer uses the app. Inconvenience, never lockout.</a:t>
+              <a:t>worst case, the customer confirms in the app. Nobody is ever locked out.</a:t>
             </a:r>
           </a:p>
         </p:txBody>
@@ -6677,8 +5317,8 @@
         </p:nvSpPr>
         <p:spPr>
           <a:xfrm>
-            <a:off x="7726679" y="2011680"/>
-            <a:ext cx="3840480" cy="1828800"/>
+            <a:off x="7406640" y="2331720"/>
+            <a:ext cx="4114800" cy="2377440"/>
           </a:xfrm>
           <a:prstGeom prst="rect">
             <a:avLst/>
@@ -6723,8 +5363,8 @@
         </p:nvSpPr>
         <p:spPr>
           <a:xfrm>
-            <a:off x="7909560" y="2176272"/>
-            <a:ext cx="3474720" cy="1554480"/>
+            <a:off x="7680960" y="2560320"/>
+            <a:ext cx="3566160" cy="2011680"/>
           </a:xfrm>
           <a:prstGeom prst="rect">
             <a:avLst/>
@@ -6738,24 +5378,24 @@
           <a:lstStyle/>
           <a:p>
             <a:r>
-              <a:rPr sz="4600" b="1">
+              <a:rPr sz="5600" b="1">
                 <a:solidFill>
                   <a:srgbClr val="0E9F6E"/>
                 </a:solidFill>
                 <a:latin typeface="Segoe UI"/>
               </a:rPr>
-              <a:t>$0.87</a:t>
-            </a:r>
-          </a:p>
-          <a:p>
-            <a:r>
-              <a:rPr sz="1250" b="0">
+              <a:t>~100×</a:t>
+            </a:r>
+          </a:p>
+          <a:p>
+            <a:r>
+              <a:rPr sz="1400" b="0">
                 <a:solidFill>
                   <a:srgbClr val="33415C"/>
                 </a:solidFill>
                 <a:latin typeface="Segoe UI"/>
               </a:rPr>
-              <a:t>cost per caught fraud — ≈ $0.45 per analysed flagged call ÷ 52 % precision, against a $5,700 average loss.</a:t>
+              <a:t>return on the checking cost: a 50-cent check that catches a $5,700 theft.</a:t>
             </a:r>
           </a:p>
         </p:txBody>
@@ -6768,8 +5408,8 @@
         </p:nvSpPr>
         <p:spPr>
           <a:xfrm>
-            <a:off x="7726679" y="4069080"/>
-            <a:ext cx="3840480" cy="1828800"/>
+            <a:off x="7589520" y="5029200"/>
+            <a:ext cx="4023360" cy="914400"/>
           </a:xfrm>
           <a:prstGeom prst="rect">
             <a:avLst/>
@@ -6783,49 +5423,13 @@
           <a:lstStyle/>
           <a:p>
             <a:r>
-              <a:rPr sz="1200" b="0">
-                <a:solidFill>
-                  <a:srgbClr val="33415C"/>
-                </a:solidFill>
-                <a:latin typeface="Segoe UI"/>
-              </a:rPr>
-              <a:t>Every avoided incident also avoids the </a:t>
-            </a:r>
-            <a:r>
-              <a:rPr sz="1200" b="1">
-                <a:solidFill>
-                  <a:srgbClr val="0F1B2D"/>
-                </a:solidFill>
-                <a:latin typeface="Segoe UI"/>
-              </a:rPr>
-              <a:t>customer-trust cost</a:t>
-            </a:r>
-            <a:r>
-              <a:rPr sz="1200" b="0">
-                <a:solidFill>
-                  <a:srgbClr val="33415C"/>
-                </a:solidFill>
-                <a:latin typeface="Segoe UI"/>
-              </a:rPr>
-              <a:t> of a bank-branded fraud call. Full model with every assumption tagged: the </a:t>
-            </a:r>
-            <a:r>
-              <a:rPr sz="1200" b="1">
-                <a:solidFill>
-                  <a:srgbClr val="0F1B2D"/>
-                </a:solidFill>
-                <a:latin typeface="Segoe UI"/>
-              </a:rPr>
-              <a:t>Impact</a:t>
-            </a:r>
-            <a:r>
-              <a:rPr sz="1200" b="0">
-                <a:solidFill>
-                  <a:srgbClr val="33415C"/>
-                </a:solidFill>
-                <a:latin typeface="Segoe UI"/>
-              </a:rPr>
-              <a:t> page in the product.</a:t>
+              <a:rPr sz="1250" b="0">
+                <a:solidFill>
+                  <a:srgbClr val="64748B"/>
+                </a:solidFill>
+                <a:latin typeface="Segoe UI"/>
+              </a:rPr>
+              <a:t>Latency: p50 &lt; 1 s per slice on the deployed build — inside the decision window.</a:t>
             </a:r>
           </a:p>
         </p:txBody>
@@ -6915,13 +5519,13 @@
           <a:lstStyle/>
           <a:p>
             <a:r>
-              <a:rPr sz="1300" b="1">
+              <a:rPr sz="1200" b="1">
                 <a:solidFill>
                   <a:srgbClr val="0E9F6E"/>
                 </a:solidFill>
                 <a:latin typeface="Segoe UI"/>
               </a:rPr>
-              <a:t>SLIDE 5</a:t>
+              <a:t>SLIDE 5 · SCALE</a:t>
             </a:r>
           </a:p>
         </p:txBody>
@@ -6949,13 +5553,13 @@
           <a:lstStyle/>
           <a:p>
             <a:r>
-              <a:rPr sz="3200" b="1">
+              <a:rPr sz="3400" b="1">
                 <a:solidFill>
                   <a:srgbClr val="0F1B2D"/>
                 </a:solidFill>
                 <a:latin typeface="Segoe UI"/>
               </a:rPr>
-              <a:t>Scale and viability</a:t>
+              <a:t>Banks pay for it — and starting needs zero data</a:t>
             </a:r>
           </a:p>
         </p:txBody>
@@ -6968,7 +5572,7 @@
         </p:nvSpPr>
         <p:spPr>
           <a:xfrm>
-            <a:off x="658368" y="1426464"/>
+            <a:off x="658368" y="1481328"/>
             <a:ext cx="914400" cy="45720"/>
           </a:xfrm>
           <a:prstGeom prst="rect">
@@ -7012,8 +5616,8 @@
         </p:nvSpPr>
         <p:spPr>
           <a:xfrm>
-            <a:off x="640080" y="6327648"/>
-            <a:ext cx="11155680" cy="411480"/>
+            <a:off x="640080" y="6355080"/>
+            <a:ext cx="11155680" cy="365760"/>
           </a:xfrm>
           <a:prstGeom prst="rect">
             <a:avLst/>
@@ -7027,13 +5631,13 @@
           <a:lstStyle/>
           <a:p>
             <a:r>
-              <a:rPr sz="1050">
+              <a:rPr sz="1100">
                 <a:solidFill>
                   <a:srgbClr val="64748B"/>
                 </a:solidFill>
                 <a:latin typeface="Segoe UI"/>
               </a:rPr>
-              <a:t>Judge link: https://unclone-verified-agent.onrender.com   ·   in-product docs: Impact · Calibration · Scale &amp; Viability pages</a:t>
+              <a:t>Try it live — https://unclone-verified-agent.onrender.com</a:t>
             </a:r>
           </a:p>
         </p:txBody>
@@ -7046,8 +5650,8 @@
         </p:nvSpPr>
         <p:spPr>
           <a:xfrm>
-            <a:off x="640080" y="1737360"/>
-            <a:ext cx="5669280" cy="4480560"/>
+            <a:off x="640080" y="1874519"/>
+            <a:ext cx="10972800" cy="3931920"/>
           </a:xfrm>
           <a:prstGeom prst="rect">
             <a:avLst/>
@@ -7062,352 +5666,164 @@
           <a:p>
             <a:pPr>
               <a:spcAft>
-                <a:spcPts val="900"/>
+                <a:spcPts val="1400"/>
               </a:spcAft>
             </a:pPr>
             <a:r>
-              <a:rPr sz="1300" b="1">
+              <a:rPr sz="1700" b="1">
                 <a:solidFill>
                   <a:srgbClr val="0F1B2D"/>
                 </a:solidFill>
                 <a:latin typeface="Segoe UI"/>
               </a:rPr>
-              <a:t>Who pays, and why a user-side verifier wins the channel conflict: </a:t>
-            </a:r>
-            <a:r>
-              <a:rPr sz="1300" b="0">
+              <a:t>Who pays:  </a:t>
+            </a:r>
+            <a:r>
+              <a:rPr sz="1700" b="0">
                 <a:solidFill>
                   <a:srgbClr val="33415C"/>
                 </a:solidFill>
                 <a:latin typeface="Segoe UI"/>
               </a:rPr>
-              <a:t>the bank's fraud-ops + digital-channels team. The conflict (revenue wants the call; risk stops it) is resolved </a:t>
-            </a:r>
-            <a:r>
-              <a:rPr sz="1300" b="1">
+              <a:t>the bank's fraud team. A bank can't stop a </a:t>
+            </a:r>
+            <a:r>
+              <a:rPr sz="1700" b="1">
                 <a:solidFill>
                   <a:srgbClr val="0F1B2D"/>
                 </a:solidFill>
                 <a:latin typeface="Segoe UI"/>
               </a:rPr>
-              <a:t>structurally</a:t>
-            </a:r>
-            <a:r>
-              <a:rPr sz="1300" b="0">
+              <a:t>perfect clone</a:t>
+            </a:r>
+            <a:r>
+              <a:rPr sz="1700" b="0">
                 <a:solidFill>
                   <a:srgbClr val="33415C"/>
                 </a:solidFill>
                 <a:latin typeface="Segoe UI"/>
               </a:rPr>
-              <a:t>: the verifier is the </a:t>
-            </a:r>
-            <a:r>
-              <a:rPr sz="1300" b="1">
+              <a:t> from inside its own call centre — the clone is its own agent's voice. Only the </a:t>
+            </a:r>
+            <a:r>
+              <a:rPr sz="1700" b="1">
                 <a:solidFill>
                   <a:srgbClr val="0F1B2D"/>
                 </a:solidFill>
                 <a:latin typeface="Segoe UI"/>
               </a:rPr>
-              <a:t>customer's</a:t>
-            </a:r>
-            <a:r>
-              <a:rPr sz="1300" b="0">
+              <a:t>customer's side</a:t>
+            </a:r>
+            <a:r>
+              <a:rPr sz="1700" b="0">
                 <a:solidFill>
                   <a:srgbClr val="33415C"/>
                 </a:solidFill>
                 <a:latin typeface="Segoe UI"/>
               </a:rPr>
-              <a:t> control, so it protects the one case the contact centre cannot see — a perfect clone of the agent's own voice — and produces the decision log regulators ask for.</a:t>
+              <a:t> can.</a:t>
             </a:r>
           </a:p>
           <a:p>
             <a:pPr>
               <a:spcAft>
-                <a:spcPts val="900"/>
+                <a:spcPts val="1400"/>
               </a:spcAft>
             </a:pPr>
             <a:r>
-              <a:rPr sz="1300" b="1">
+              <a:rPr sz="1700" b="1">
                 <a:solidFill>
                   <a:srgbClr val="0F1B2D"/>
                 </a:solidFill>
                 <a:latin typeface="Segoe UI"/>
               </a:rPr>
-              <a:t>Distribution: </a:t>
-            </a:r>
-            <a:r>
-              <a:rPr sz="1300" b="0">
+              <a:t>Starting takes a day, not a dataset:  </a:t>
+            </a:r>
+            <a:r>
+              <a:rPr sz="1700" b="0">
                 <a:solidFill>
                   <a:srgbClr val="33415C"/>
                 </a:solidFill>
                 <a:latin typeface="Segoe UI"/>
               </a:rPr>
-              <a:t>SDK in the bank's app (where the step-up prompt already lives), then CCaaS. Telephony is the later expansion.</a:t>
+              <a:t>banks already record their agents for compliance. Take </a:t>
+            </a:r>
+            <a:r>
+              <a:rPr sz="1700" b="1">
+                <a:solidFill>
+                  <a:srgbClr val="0F1B2D"/>
+                </a:solidFill>
+                <a:latin typeface="Segoe UI"/>
+              </a:rPr>
+              <a:t>15–60 s of that recording</a:t>
+            </a:r>
+            <a:r>
+              <a:rPr sz="1700" b="0">
+                <a:solidFill>
+                  <a:srgbClr val="33415C"/>
+                </a:solidFill>
+                <a:latin typeface="Segoe UI"/>
+              </a:rPr>
+              <a:t>, enrol it — done. </a:t>
+            </a:r>
+            <a:r>
+              <a:rPr sz="1700" b="1">
+                <a:solidFill>
+                  <a:srgbClr val="0F1B2D"/>
+                </a:solidFill>
+                <a:latin typeface="Segoe UI"/>
+              </a:rPr>
+              <a:t>We train nothing.</a:t>
             </a:r>
           </a:p>
           <a:p>
             <a:pPr>
               <a:spcAft>
-                <a:spcPts val="900"/>
+                <a:spcPts val="1400"/>
               </a:spcAft>
             </a:pPr>
             <a:r>
-              <a:rPr sz="1300" b="1">
+              <a:rPr sz="1700" b="1">
                 <a:solidFill>
                   <a:srgbClr val="0F1B2D"/>
                 </a:solidFill>
                 <a:latin typeface="Segoe UI"/>
               </a:rPr>
-              <a:t>Day-1 question — answered productised: </a:t>
-            </a:r>
-            <a:r>
-              <a:rPr sz="1300" b="1">
-                <a:solidFill>
-                  <a:srgbClr val="0F1B2D"/>
-                </a:solidFill>
-                <a:latin typeface="Segoe UI"/>
-              </a:rPr>
-              <a:t>we don't train.</a:t>
-            </a:r>
-            <a:r>
-              <a:rPr sz="1300" b="0">
+              <a:t>The honest scoreboard:  </a:t>
+            </a:r>
+            <a:r>
+              <a:rPr sz="1700" b="0">
                 <a:solidFill>
                   <a:srgbClr val="33415C"/>
                 </a:solidFill>
                 <a:latin typeface="Segoe UI"/>
               </a:rPr>
-              <a:t> The runbook (Scale page): source = the bank's own compliance recordings of the payment-desk roster; basis = same privacy basis as the recordings; store = vendor template only, we hold ids and scores; delete = one call per offboarding agent, evidenced in the log.</a:t>
+              <a:t>live now — 3 attacked calls + your own voice, every failure fails *safe* (amber, never auto-approve). Next — the phone-network version. We say which is which.</a:t>
             </a:r>
           </a:p>
           <a:p>
             <a:pPr>
               <a:spcAft>
-                <a:spcPts val="900"/>
+                <a:spcPts val="1400"/>
               </a:spcAft>
             </a:pPr>
             <a:r>
-              <a:rPr sz="1300" b="1">
+              <a:rPr sz="1700" b="1">
                 <a:solidFill>
                   <a:srgbClr val="0F1B2D"/>
                 </a:solidFill>
                 <a:latin typeface="Segoe UI"/>
               </a:rPr>
-              <a:t>Pilot: </a:t>
-            </a:r>
-            <a:r>
-              <a:rPr sz="1300" b="0">
+              <a:t>First pilot:  </a:t>
+            </a:r>
+            <a:r>
+              <a:rPr sz="1700" b="0">
                 <a:solidFill>
                   <a:srgbClr val="33415C"/>
                 </a:solidFill>
                 <a:latin typeface="Segoe UI"/>
               </a:rPr>
-              <a:t>above-limit flagged calls · metric = prevented loss with false-step-up ≤ 2 % · 6 weeks · success = ≥1 prevented incident with a full decision log.</a:t>
-            </a:r>
-          </a:p>
-        </p:txBody>
-      </p:sp>
-      <p:sp>
-        <p:nvSpPr>
-          <p:cNvPr id="8" name="TextBox 7"/>
-          <p:cNvSpPr txBox="1"/>
-          <p:nvPr/>
-        </p:nvSpPr>
-        <p:spPr>
-          <a:xfrm>
-            <a:off x="6629400" y="1737360"/>
-            <a:ext cx="4937760" cy="365760"/>
-          </a:xfrm>
-          <a:prstGeom prst="rect">
-            <a:avLst/>
-          </a:prstGeom>
-          <a:noFill/>
-        </p:spPr>
-        <p:txBody>
-          <a:bodyPr wrap="square">
-            <a:spAutoFit/>
-          </a:bodyPr>
-          <a:lstStyle/>
-          <a:p>
-            <a:r>
-              <a:rPr sz="1400" b="1">
-                <a:solidFill>
-                  <a:srgbClr val="0F1B2D"/>
-                </a:solidFill>
-                <a:latin typeface="Segoe UI"/>
-              </a:rPr>
-              <a:t>What is verified vs what remains honest</a:t>
-            </a:r>
-          </a:p>
-        </p:txBody>
-      </p:sp>
-      <p:sp>
-        <p:nvSpPr>
-          <p:cNvPr id="9" name="TextBox 8"/>
-          <p:cNvSpPr txBox="1"/>
-          <p:nvPr/>
-        </p:nvSpPr>
-        <p:spPr>
-          <a:xfrm>
-            <a:off x="6629400" y="2194560"/>
-            <a:ext cx="4937760" cy="914400"/>
-          </a:xfrm>
-          <a:prstGeom prst="rect">
-            <a:avLst/>
-          </a:prstGeom>
-          <a:noFill/>
-        </p:spPr>
-        <p:txBody>
-          <a:bodyPr wrap="square">
-            <a:spAutoFit/>
-          </a:bodyPr>
-          <a:lstStyle/>
-          <a:p>
-            <a:r>
-              <a:rPr sz="1250" b="1">
-                <a:solidFill>
-                  <a:srgbClr val="0E9F6E"/>
-                </a:solidFill>
-                <a:latin typeface="Segoe UI"/>
-              </a:rPr>
-              <a:t>Verified live</a:t>
-            </a:r>
-            <a:r>
-              <a:rPr sz="1200" b="0">
-                <a:solidFill>
-                  <a:srgbClr val="33415C"/>
-                </a:solidFill>
-                <a:latin typeface="Segoe UI"/>
-              </a:rPr>
-              <a:t>genuine → PROCEEDS · hijack → HELD (call terminated) · subtle → HELD · silent → STEP UP · replay → HELD · render → STEP UP</a:t>
-            </a:r>
-          </a:p>
-        </p:txBody>
-      </p:sp>
-      <p:sp>
-        <p:nvSpPr>
-          <p:cNvPr id="10" name="TextBox 9"/>
-          <p:cNvSpPr txBox="1"/>
-          <p:nvPr/>
-        </p:nvSpPr>
-        <p:spPr>
-          <a:xfrm>
-            <a:off x="6629400" y="3127248"/>
-            <a:ext cx="4937760" cy="914400"/>
-          </a:xfrm>
-          <a:prstGeom prst="rect">
-            <a:avLst/>
-          </a:prstGeom>
-          <a:noFill/>
-        </p:spPr>
-        <p:txBody>
-          <a:bodyPr wrap="square">
-            <a:spAutoFit/>
-          </a:bodyPr>
-          <a:lstStyle/>
-          <a:p>
-            <a:r>
-              <a:rPr sz="1250" b="1">
-                <a:solidFill>
-                  <a:srgbClr val="C88600"/>
-                </a:solidFill>
-                <a:latin typeface="Segoe UI"/>
-              </a:rPr>
-              <a:t>Measurably open</a:t>
-            </a:r>
-            <a:r>
-              <a:rPr sz="1200" b="0">
-                <a:solidFill>
-                  <a:srgbClr val="33415C"/>
-                </a:solidFill>
-                <a:latin typeface="Segoe UI"/>
-              </a:rPr>
-              <a:t>FAR/FRR vs unseen real speakers · second true TTS engine · mic flow rehearsed live</a:t>
-            </a:r>
-          </a:p>
-        </p:txBody>
-      </p:sp>
-      <p:sp>
-        <p:nvSpPr>
-          <p:cNvPr id="11" name="TextBox 10"/>
-          <p:cNvSpPr txBox="1"/>
-          <p:nvPr/>
-        </p:nvSpPr>
-        <p:spPr>
-          <a:xfrm>
-            <a:off x="6629400" y="4059935"/>
-            <a:ext cx="4937760" cy="914400"/>
-          </a:xfrm>
-          <a:prstGeom prst="rect">
-            <a:avLst/>
-          </a:prstGeom>
-          <a:noFill/>
-        </p:spPr>
-        <p:txBody>
-          <a:bodyPr wrap="square">
-            <a:spAutoFit/>
-          </a:bodyPr>
-          <a:lstStyle/>
-          <a:p>
-            <a:r>
-              <a:rPr sz="1250" b="1">
-                <a:solidFill>
-                  <a:srgbClr val="D6394B"/>
-                </a:solidFill>
-                <a:latin typeface="Segoe UI"/>
-              </a:rPr>
-              <a:t>Declared future work</a:t>
-            </a:r>
-            <a:r>
-              <a:rPr sz="1200" b="0">
-                <a:solidFill>
-                  <a:srgbClr val="33415C"/>
-                </a:solidFill>
-                <a:latin typeface="Segoe UI"/>
-              </a:rPr>
-              <a:t>L3 telephony (mid-call block) · two-service attestation · real pilot partner</a:t>
-            </a:r>
-          </a:p>
-        </p:txBody>
-      </p:sp>
-      <p:sp>
-        <p:nvSpPr>
-          <p:cNvPr id="12" name="TextBox 11"/>
-          <p:cNvSpPr txBox="1"/>
-          <p:nvPr/>
-        </p:nvSpPr>
-        <p:spPr>
-          <a:xfrm>
-            <a:off x="6629400" y="5166360"/>
-            <a:ext cx="4937760" cy="914400"/>
-          </a:xfrm>
-          <a:prstGeom prst="rect">
-            <a:avLst/>
-          </a:prstGeom>
-          <a:noFill/>
-        </p:spPr>
-        <p:txBody>
-          <a:bodyPr wrap="square">
-            <a:spAutoFit/>
-          </a:bodyPr>
-          <a:lstStyle/>
-          <a:p>
-            <a:r>
-              <a:rPr sz="1200" b="1">
-                <a:solidFill>
-                  <a:srgbClr val="0F1B2D"/>
-                </a:solidFill>
-                <a:latin typeface="Segoe UI"/>
-              </a:rPr>
-              <a:t>Self-audit posture:</a:t>
-            </a:r>
-            <a:r>
-              <a:rPr sz="1200" b="0">
-                <a:solidFill>
-                  <a:srgbClr val="33415C"/>
-                </a:solidFill>
-                <a:latin typeface="Segoe UI"/>
-              </a:rPr>
-              <a:t> the build is scored 57/70 pessimistically with the audit in the repo — the team-hours items (rehearsal, interviews) are the remaining gap, by design of the cutoff.</a:t>
+              <a:t>6 weeks, flagged calls only. Success = one caught scam with the full evidence log shown — then scale.</a:t>
             </a:r>
           </a:p>
         </p:txBody>

</xml_diff>

<commit_message>
Four-layer engine slide: four plain questions per slice, blind-spot logic shown
Slide 3 of the simple deck now presents the defence as four questions a judge
would naturally ask of any voice: right voice? / sounds human? / room sounds
real? (forensics, explained as a room-tone scan) / being replayed? — plus the
why-four-layers line that names each layer's blind spot and who covers it.

🤖 Generated with Codebuff
Co-Authored-By: Codebuff <noreply@codebuff.com>
</commit_message>
<xml_diff>
--- a/UNCLONE-day2-deck.pptx
+++ b/UNCLONE-day2-deck.pptx
@@ -4303,7 +4303,7 @@
                 </a:solidFill>
                 <a:latin typeface="Segoe UI"/>
               </a:rPr>
-              <a:t>DetectifAI listens in slices — that's the trick</a:t>
+              <a:t>Four questions, asked every 6 seconds</a:t>
             </a:r>
           </a:p>
         </p:txBody>
@@ -4394,8 +4394,8 @@
         </p:nvSpPr>
         <p:spPr>
           <a:xfrm>
-            <a:off x="640080" y="1828800"/>
-            <a:ext cx="10972800" cy="1371600"/>
+            <a:off x="640080" y="1783080"/>
+            <a:ext cx="10972800" cy="685800"/>
           </a:xfrm>
           <a:prstGeom prst="rect">
             <a:avLst/>
@@ -4409,16 +4409,16 @@
           <a:lstStyle/>
           <a:p>
             <a:r>
-              <a:rPr sz="1900" b="0">
+              <a:rPr sz="1800" b="0">
                 <a:solidFill>
                   <a:srgbClr val="33415C"/>
                 </a:solidFill>
                 <a:latin typeface="Segoe UI"/>
               </a:rPr>
-              <a:t>One call = several </a:t>
-            </a:r>
-            <a:r>
-              <a:rPr sz="1900" b="1">
+              <a:t>The call is chopped into </a:t>
+            </a:r>
+            <a:r>
+              <a:rPr sz="1800" b="1">
                 <a:solidFill>
                   <a:srgbClr val="0F1B2D"/>
                 </a:solidFill>
@@ -4427,137 +4427,47 @@
               <a:t>6-second slices</a:t>
             </a:r>
             <a:r>
-              <a:rPr sz="1900" b="0">
+              <a:rPr sz="1800" b="0">
                 <a:solidFill>
                   <a:srgbClr val="33415C"/>
                 </a:solidFill>
                 <a:latin typeface="Segoe UI"/>
               </a:rPr>
-              <a:t>. Every slice gets two checks: </a:t>
-            </a:r>
-            <a:r>
-              <a:rPr sz="1900" b="1">
+              <a:t>, and each slice answers four questions. If any answer is wrong — red or amber, </a:t>
+            </a:r>
+            <a:r>
+              <a:rPr sz="1800" b="1">
                 <a:solidFill>
                   <a:srgbClr val="0F1B2D"/>
                 </a:solidFill>
                 <a:latin typeface="Segoe UI"/>
               </a:rPr>
-              <a:t>voice fingerprint</a:t>
-            </a:r>
-            <a:r>
-              <a:rPr sz="1900" b="0">
+              <a:t>never auto-approve</a:t>
+            </a:r>
+            <a:r>
+              <a:rPr sz="1800" b="0">
                 <a:solidFill>
                   <a:srgbClr val="33415C"/>
                 </a:solidFill>
                 <a:latin typeface="Segoe UI"/>
               </a:rPr>
-              <a:t> (is it the agent?) and </a:t>
-            </a:r>
-            <a:r>
-              <a:rPr sz="1900" b="1">
-                <a:solidFill>
-                  <a:srgbClr val="0F1B2D"/>
-                </a:solidFill>
-                <a:latin typeface="Segoe UI"/>
-              </a:rPr>
-              <a:t>machine-voice check</a:t>
-            </a:r>
-            <a:r>
-              <a:rPr sz="1900" b="0">
-                <a:solidFill>
-                  <a:srgbClr val="33415C"/>
-                </a:solidFill>
-                <a:latin typeface="Segoe UI"/>
-              </a:rPr>
-              <a:t> (does it sound synthetic?).</a:t>
-            </a:r>
-          </a:p>
-          <a:p>
-            <a:r>
-              <a:rPr sz="1900" b="0">
-                <a:solidFill>
-                  <a:srgbClr val="33415C"/>
-                </a:solidFill>
-                <a:latin typeface="Segoe UI"/>
-              </a:rPr>
-              <a:t>A scammer only needs </a:t>
-            </a:r>
-            <a:r>
-              <a:rPr sz="1900" b="1">
-                <a:solidFill>
-                  <a:srgbClr val="0F1B2D"/>
-                </a:solidFill>
-                <a:latin typeface="Segoe UI"/>
-              </a:rPr>
-              <a:t>3 bad seconds</a:t>
-            </a:r>
-            <a:r>
-              <a:rPr sz="1900" b="0">
-                <a:solidFill>
-                  <a:srgbClr val="33415C"/>
-                </a:solidFill>
-                <a:latin typeface="Segoe UI"/>
-              </a:rPr>
-              <a:t> to steal the money — so we never average. </a:t>
-            </a:r>
-            <a:r>
-              <a:rPr sz="1900" b="1">
-                <a:solidFill>
-                  <a:srgbClr val="0F1B2D"/>
-                </a:solidFill>
-                <a:latin typeface="Segoe UI"/>
-              </a:rPr>
-              <a:t>One bad slice stops the call.</a:t>
-            </a:r>
-          </a:p>
-        </p:txBody>
-      </p:sp>
-      <p:sp>
-        <p:nvSpPr>
-          <p:cNvPr id="8" name="TextBox 7"/>
-          <p:cNvSpPr txBox="1"/>
-          <p:nvPr/>
-        </p:nvSpPr>
-        <p:spPr>
-          <a:xfrm>
-            <a:off x="685800" y="3520440"/>
-            <a:ext cx="6492240" cy="365760"/>
-          </a:xfrm>
-          <a:prstGeom prst="rect">
-            <a:avLst/>
-          </a:prstGeom>
-          <a:noFill/>
-        </p:spPr>
-        <p:txBody>
-          <a:bodyPr wrap="square">
-            <a:spAutoFit/>
-          </a:bodyPr>
-          <a:lstStyle/>
-          <a:p>
-            <a:r>
-              <a:rPr sz="1400" b="1">
-                <a:solidFill>
-                  <a:srgbClr val="0F1B2D"/>
-                </a:solidFill>
-                <a:latin typeface="Segoe UI"/>
-              </a:rPr>
-              <a:t>The sneaky attack, caught (from the live demo):</a:t>
-            </a:r>
-          </a:p>
-        </p:txBody>
-      </p:sp>
-      <p:sp>
-        <p:nvSpPr>
-          <p:cNvPr id="9" name="Rectangle 8"/>
+              <a:t>.</a:t>
+            </a:r>
+          </a:p>
+        </p:txBody>
+      </p:sp>
+      <p:sp>
+        <p:nvSpPr>
+          <p:cNvPr id="8" name="Rounded Rectangle 7"/>
           <p:cNvSpPr/>
           <p:nvPr/>
         </p:nvSpPr>
         <p:spPr>
           <a:xfrm>
-            <a:off x="658368" y="3904487"/>
-            <a:ext cx="6547103" cy="512064"/>
-          </a:xfrm>
-          <a:prstGeom prst="rect">
+            <a:off x="640080" y="2651760"/>
+            <a:ext cx="5440680" cy="1371600"/>
+          </a:xfrm>
+          <a:prstGeom prst="roundRect">
             <a:avLst/>
           </a:prstGeom>
           <a:solidFill>
@@ -4594,23 +4504,70 @@
       </p:sp>
       <p:sp>
         <p:nvSpPr>
-          <p:cNvPr id="10" name="Rectangle 9"/>
-          <p:cNvSpPr/>
+          <p:cNvPr id="9" name="TextBox 8"/>
+          <p:cNvSpPr txBox="1"/>
           <p:nvPr/>
         </p:nvSpPr>
         <p:spPr>
           <a:xfrm>
-            <a:off x="685800" y="3931920"/>
-            <a:ext cx="1854925" cy="457200"/>
+            <a:off x="804671" y="2734056"/>
+            <a:ext cx="5111496" cy="1207008"/>
           </a:xfrm>
           <a:prstGeom prst="rect">
             <a:avLst/>
           </a:prstGeom>
+          <a:noFill/>
+        </p:spPr>
+        <p:txBody>
+          <a:bodyPr wrap="square">
+            <a:spAutoFit/>
+          </a:bodyPr>
+          <a:lstStyle/>
+          <a:p>
+            <a:r>
+              <a:rPr sz="1450" b="1">
+                <a:solidFill>
+                  <a:srgbClr val="0E9F6E"/>
+                </a:solidFill>
+                <a:latin typeface="Segoe UI"/>
+              </a:rPr>
+              <a:t>1 · Is it the right voice?</a:t>
+            </a:r>
+          </a:p>
+          <a:p>
+            <a:r>
+              <a:rPr sz="1150" b="0">
+                <a:solidFill>
+                  <a:srgbClr val="33415C"/>
+                </a:solidFill>
+                <a:latin typeface="Segoe UI"/>
+              </a:rPr>
+              <a:t>The bank agent's voice fingerprint (enrolled once) is compared to every slice. A cheap clone with a different voice fails here.</a:t>
+            </a:r>
+          </a:p>
+        </p:txBody>
+      </p:sp>
+      <p:sp>
+        <p:nvSpPr>
+          <p:cNvPr id="10" name="Rounded Rectangle 9"/>
+          <p:cNvSpPr/>
+          <p:nvPr/>
+        </p:nvSpPr>
+        <p:spPr>
+          <a:xfrm>
+            <a:off x="6217920" y="2651760"/>
+            <a:ext cx="5440680" cy="1371600"/>
+          </a:xfrm>
+          <a:prstGeom prst="roundRect">
+            <a:avLst/>
+          </a:prstGeom>
           <a:solidFill>
-            <a:srgbClr val="0E9F6E"/>
+            <a:srgbClr val="F2F6FB"/>
           </a:solidFill>
-          <a:ln>
-            <a:noFill/>
+          <a:ln w="9525">
+            <a:solidFill>
+              <a:srgbClr val="D3DEEE"/>
+            </a:solidFill>
           </a:ln>
           <a:effectLst/>
         </p:spPr>
@@ -4638,23 +4595,70 @@
       </p:sp>
       <p:sp>
         <p:nvSpPr>
-          <p:cNvPr id="11" name="Rectangle 10"/>
-          <p:cNvSpPr/>
+          <p:cNvPr id="11" name="TextBox 10"/>
+          <p:cNvSpPr txBox="1"/>
           <p:nvPr/>
         </p:nvSpPr>
         <p:spPr>
           <a:xfrm>
-            <a:off x="2540725" y="3931920"/>
-            <a:ext cx="1854925" cy="457200"/>
+            <a:off x="6382512" y="2734056"/>
+            <a:ext cx="5111496" cy="1207008"/>
           </a:xfrm>
           <a:prstGeom prst="rect">
             <a:avLst/>
           </a:prstGeom>
+          <a:noFill/>
+        </p:spPr>
+        <p:txBody>
+          <a:bodyPr wrap="square">
+            <a:spAutoFit/>
+          </a:bodyPr>
+          <a:lstStyle/>
+          <a:p>
+            <a:r>
+              <a:rPr sz="1450" b="1">
+                <a:solidFill>
+                  <a:srgbClr val="0E9F6E"/>
+                </a:solidFill>
+                <a:latin typeface="Segoe UI"/>
+              </a:rPr>
+              <a:t>2 · Does it sound human?</a:t>
+            </a:r>
+          </a:p>
+          <a:p>
+            <a:r>
+              <a:rPr sz="1150" b="0">
+                <a:solidFill>
+                  <a:srgbClr val="33415C"/>
+                </a:solidFill>
+                <a:latin typeface="Segoe UI"/>
+              </a:rPr>
+              <a:t>DetectifAI scores every 4-second piece for machine artefacts. A perfect same-voice clone can pass Q1 — but its machine-made pieces still score “0.999 synthetic” → red.</a:t>
+            </a:r>
+          </a:p>
+        </p:txBody>
+      </p:sp>
+      <p:sp>
+        <p:nvSpPr>
+          <p:cNvPr id="12" name="Rounded Rectangle 11"/>
+          <p:cNvSpPr/>
+          <p:nvPr/>
+        </p:nvSpPr>
+        <p:spPr>
+          <a:xfrm>
+            <a:off x="640080" y="4133087"/>
+            <a:ext cx="5440680" cy="1371600"/>
+          </a:xfrm>
+          <a:prstGeom prst="roundRect">
+            <a:avLst/>
+          </a:prstGeom>
           <a:solidFill>
-            <a:srgbClr val="0E9F6E"/>
+            <a:srgbClr val="F2F6FB"/>
           </a:solidFill>
-          <a:ln>
-            <a:noFill/>
+          <a:ln w="9525">
+            <a:solidFill>
+              <a:srgbClr val="D3DEEE"/>
+            </a:solidFill>
           </a:ln>
           <a:effectLst/>
         </p:spPr>
@@ -4682,23 +4686,70 @@
       </p:sp>
       <p:sp>
         <p:nvSpPr>
-          <p:cNvPr id="12" name="Rectangle 11"/>
-          <p:cNvSpPr/>
+          <p:cNvPr id="13" name="TextBox 12"/>
+          <p:cNvSpPr txBox="1"/>
           <p:nvPr/>
         </p:nvSpPr>
         <p:spPr>
           <a:xfrm>
-            <a:off x="4395651" y="3931920"/>
-            <a:ext cx="927462" cy="457200"/>
+            <a:off x="804671" y="4215383"/>
+            <a:ext cx="5111496" cy="1207008"/>
           </a:xfrm>
           <a:prstGeom prst="rect">
             <a:avLst/>
           </a:prstGeom>
+          <a:noFill/>
+        </p:spPr>
+        <p:txBody>
+          <a:bodyPr wrap="square">
+            <a:spAutoFit/>
+          </a:bodyPr>
+          <a:lstStyle/>
+          <a:p>
+            <a:r>
+              <a:rPr sz="1450" b="1">
+                <a:solidFill>
+                  <a:srgbClr val="C88600"/>
+                </a:solidFill>
+                <a:latin typeface="Segoe UI"/>
+              </a:rPr>
+              <a:t>3 · Does the room sound real?</a:t>
+            </a:r>
+          </a:p>
+          <a:p>
+            <a:r>
+              <a:rPr sz="1150" b="0">
+                <a:solidFill>
+                  <a:srgbClr val="33415C"/>
+                </a:solidFill>
+                <a:latin typeface="Segoe UI"/>
+              </a:rPr>
+              <a:t>Forensics = a room-tone scan. Recordings of real calls carry the faint noise of a real space; computer-generated voices are born in digital silence. No room → amber.</a:t>
+            </a:r>
+          </a:p>
+        </p:txBody>
+      </p:sp>
+      <p:sp>
+        <p:nvSpPr>
+          <p:cNvPr id="14" name="Rounded Rectangle 13"/>
+          <p:cNvSpPr/>
+          <p:nvPr/>
+        </p:nvSpPr>
+        <p:spPr>
+          <a:xfrm>
+            <a:off x="6217920" y="4133087"/>
+            <a:ext cx="5440680" cy="1371600"/>
+          </a:xfrm>
+          <a:prstGeom prst="roundRect">
+            <a:avLst/>
+          </a:prstGeom>
           <a:solidFill>
-            <a:srgbClr val="D6394B"/>
+            <a:srgbClr val="F2F6FB"/>
           </a:solidFill>
-          <a:ln>
-            <a:noFill/>
+          <a:ln w="9525">
+            <a:solidFill>
+              <a:srgbClr val="D3DEEE"/>
+            </a:solidFill>
           </a:ln>
           <a:effectLst/>
         </p:spPr>
@@ -4726,102 +4777,14 @@
       </p:sp>
       <p:sp>
         <p:nvSpPr>
-          <p:cNvPr id="13" name="Rectangle 12"/>
-          <p:cNvSpPr/>
-          <p:nvPr/>
-        </p:nvSpPr>
-        <p:spPr>
-          <a:xfrm>
-            <a:off x="5323114" y="3931920"/>
-            <a:ext cx="927462" cy="457200"/>
-          </a:xfrm>
-          <a:prstGeom prst="rect">
-            <a:avLst/>
-          </a:prstGeom>
-          <a:solidFill>
-            <a:srgbClr val="D6394B"/>
-          </a:solidFill>
-          <a:ln>
-            <a:noFill/>
-          </a:ln>
-          <a:effectLst/>
-        </p:spPr>
-        <p:style>
-          <a:lnRef idx="1">
-            <a:schemeClr val="accent1"/>
-          </a:lnRef>
-          <a:fillRef idx="3">
-            <a:schemeClr val="accent1"/>
-          </a:fillRef>
-          <a:effectRef idx="2">
-            <a:schemeClr val="accent1"/>
-          </a:effectRef>
-          <a:fontRef idx="minor">
-            <a:schemeClr val="lt1"/>
-          </a:fontRef>
-        </p:style>
-        <p:txBody>
-          <a:bodyPr rtlCol="0" anchor="ctr"/>
-          <a:lstStyle/>
-          <a:p>
-            <a:pPr algn="ctr"/>
-          </a:p>
-        </p:txBody>
-      </p:sp>
-      <p:sp>
-        <p:nvSpPr>
-          <p:cNvPr id="14" name="Rectangle 13"/>
-          <p:cNvSpPr/>
-          <p:nvPr/>
-        </p:nvSpPr>
-        <p:spPr>
-          <a:xfrm>
-            <a:off x="6250577" y="3931920"/>
-            <a:ext cx="927462" cy="457200"/>
-          </a:xfrm>
-          <a:prstGeom prst="rect">
-            <a:avLst/>
-          </a:prstGeom>
-          <a:solidFill>
-            <a:srgbClr val="D6394B"/>
-          </a:solidFill>
-          <a:ln>
-            <a:noFill/>
-          </a:ln>
-          <a:effectLst/>
-        </p:spPr>
-        <p:style>
-          <a:lnRef idx="1">
-            <a:schemeClr val="accent1"/>
-          </a:lnRef>
-          <a:fillRef idx="3">
-            <a:schemeClr val="accent1"/>
-          </a:fillRef>
-          <a:effectRef idx="2">
-            <a:schemeClr val="accent1"/>
-          </a:effectRef>
-          <a:fontRef idx="minor">
-            <a:schemeClr val="lt1"/>
-          </a:fontRef>
-        </p:style>
-        <p:txBody>
-          <a:bodyPr rtlCol="0" anchor="ctr"/>
-          <a:lstStyle/>
-          <a:p>
-            <a:pPr algn="ctr"/>
-          </a:p>
-        </p:txBody>
-      </p:sp>
-      <p:sp>
-        <p:nvSpPr>
           <p:cNvPr id="15" name="TextBox 14"/>
           <p:cNvSpPr txBox="1"/>
           <p:nvPr/>
         </p:nvSpPr>
         <p:spPr>
           <a:xfrm>
-            <a:off x="685800" y="4462272"/>
-            <a:ext cx="6492240" cy="502920"/>
+            <a:off x="6382512" y="4215383"/>
+            <a:ext cx="5111496" cy="1207008"/>
           </a:xfrm>
           <a:prstGeom prst="rect">
             <a:avLst/>
@@ -4835,13 +4798,24 @@
           <a:lstStyle/>
           <a:p>
             <a:r>
-              <a:rPr sz="1200" b="0">
+              <a:rPr sz="1450" b="1">
+                <a:solidFill>
+                  <a:srgbClr val="D6394B"/>
+                </a:solidFill>
+                <a:latin typeface="Segoe UI"/>
+              </a:rPr>
+              <a:t>4 · Is it being replayed?</a:t>
+            </a:r>
+          </a:p>
+          <a:p>
+            <a:r>
+              <a:rPr sz="1150" b="0">
                 <a:solidFill>
                   <a:srgbClr val="33415C"/>
                 </a:solidFill>
                 <a:latin typeface="Segoe UI"/>
               </a:rPr>
-              <a:t>Fingerprint passed · overall score said “human” · but slice 3–4 of the call (9–12 s) scored 0.999 “machine” → RED.  An average-hunting system would have approved this call.</a:t>
+              <a:t>The exact same audio arriving twice is a recording being re-run, not a live conversation — blocked on the spot, however real it sounds.</a:t>
             </a:r>
           </a:p>
         </p:txBody>
@@ -4854,8 +4828,8 @@
         </p:nvSpPr>
         <p:spPr>
           <a:xfrm>
-            <a:off x="7635240" y="3520440"/>
-            <a:ext cx="3931920" cy="2286000"/>
+            <a:off x="640080" y="5715000"/>
+            <a:ext cx="10972800" cy="594360"/>
           </a:xfrm>
           <a:prstGeom prst="rect">
             <a:avLst/>
@@ -4869,57 +4843,22 @@
           <a:lstStyle/>
           <a:p>
             <a:r>
-              <a:rPr sz="1400" b="1">
+              <a:rPr sz="1350" b="1">
                 <a:solidFill>
                   <a:srgbClr val="0F1B2D"/>
                 </a:solidFill>
                 <a:latin typeface="Segoe UI"/>
               </a:rPr>
-              <a:t>Try it in 30 seconds:</a:t>
-            </a:r>
-          </a:p>
-          <a:p>
-            <a:r>
-              <a:rPr sz="1500" b="0">
+              <a:t>Why four layers:</a:t>
+            </a:r>
+            <a:r>
+              <a:rPr sz="1350" b="0">
                 <a:solidFill>
                   <a:srgbClr val="33415C"/>
                 </a:solidFill>
                 <a:latin typeface="Segoe UI"/>
               </a:rPr>
-              <a:t>• Press Call 1 → green</a:t>
-            </a:r>
-          </a:p>
-          <a:p>
-            <a:r>
-              <a:rPr sz="1500" b="0">
-                <a:solidFill>
-                  <a:srgbClr val="33415C"/>
-                </a:solidFill>
-                <a:latin typeface="Segoe UI"/>
-              </a:rPr>
-              <a:t>• Press Call 2 → red, call stops</a:t>
-            </a:r>
-          </a:p>
-          <a:p>
-            <a:r>
-              <a:rPr sz="1500" b="0">
-                <a:solidFill>
-                  <a:srgbClr val="33415C"/>
-                </a:solidFill>
-                <a:latin typeface="Segoe UI"/>
-              </a:rPr>
-              <a:t>• Press the sneaky call → red from one slice</a:t>
-            </a:r>
-          </a:p>
-          <a:p>
-            <a:r>
-              <a:rPr sz="1500" b="0">
-                <a:solidFill>
-                  <a:srgbClr val="33415C"/>
-                </a:solidFill>
-                <a:latin typeface="Segoe UI"/>
-              </a:rPr>
-              <a:t>• Enrol your own voice → try it live</a:t>
+              <a:t> each check's blind spot is another check's job — a same-voice clone fools Q1 but fails Q2; a brand-new TTS engine may slip past Q2 but has no real room behind it (Q3); a straight replay leaves nothing to analyse — and still gets caught (Q4).</a:t>
             </a:r>
           </a:p>
         </p:txBody>

</xml_diff>

<commit_message>
deck: reword engine layers — every slice is checked against the enrolled agent 🤖 Generated with Codebuff Co-Authored-By: Codebuff <noreply@codebuff.com>
</commit_message>
<xml_diff>
--- a/UNCLONE-day2-deck.pptx
+++ b/UNCLONE-day2-deck.pptx
@@ -3696,7 +3696,7 @@
                 </a:solidFill>
                 <a:latin typeface="Segoe UI"/>
               </a:rPr>
-              <a:t> side of the call listens every 6 seconds and asks one question: </a:t>
+              <a:t> side of the call listens and checks, every 6 seconds, </a:t>
             </a:r>
             <a:r>
               <a:rPr sz="1900" b="1">
@@ -3705,7 +3705,7 @@
                 </a:solidFill>
                 <a:latin typeface="Segoe UI"/>
               </a:rPr>
-              <a:t>is this the real bank agent, or a machine copying them?</a:t>
+              <a:t>is each slice the real enrolled agent — or a machine copying them?</a:t>
             </a:r>
           </a:p>
         </p:txBody>
@@ -3840,7 +3840,7 @@
                 </a:solidFill>
                 <a:latin typeface="Segoe UI"/>
               </a:rPr>
-              <a:t>Real voice, sounds human. Carry on with the call.</a:t>
+              <a:t>Real agent voice, no machine parts. Carry on with the call.</a:t>
             </a:r>
           </a:p>
         </p:txBody>
@@ -4542,7 +4542,7 @@
                 </a:solidFill>
                 <a:latin typeface="Segoe UI"/>
               </a:rPr>
-              <a:t>The bank agent's voice fingerprint (enrolled once) is compared to every slice. A cheap clone with a different voice fails here.</a:t>
+              <a:t>Every 6-second slice is checked against the voice fingerprint enrolled from the real bank agent; a slice that sounds like someone else fails here.</a:t>
             </a:r>
           </a:p>
         </p:txBody>
@@ -4622,7 +4622,7 @@
                 </a:solidFill>
                 <a:latin typeface="Segoe UI"/>
               </a:rPr>
-              <a:t>2 · Does it sound human?</a:t>
+              <a:t>2 · Does any of it sound machine-made?</a:t>
             </a:r>
           </a:p>
           <a:p>
@@ -4633,7 +4633,7 @@
                 </a:solidFill>
                 <a:latin typeface="Segoe UI"/>
               </a:rPr>
-              <a:t>DetectifAI scores every 4-second piece for machine artefacts. A perfect same-voice clone can pass Q1 — but its machine-made pieces still score “0.999 synthetic” → red.</a:t>
+              <a:t>The same AI scores every 4-second piece for machine artefacts. A perfect same-voice clone can pass Q1 — but its machine-made pieces still score “0.999 synthetic” → red.</a:t>
             </a:r>
           </a:p>
         </p:txBody>
@@ -4858,7 +4858,7 @@
                 </a:solidFill>
                 <a:latin typeface="Segoe UI"/>
               </a:rPr>
-              <a:t> each check's blind spot is another check's job — a same-voice clone fools Q1 but fails Q2; a brand-new TTS engine may slip past Q2 but has no real room behind it (Q3); a straight replay leaves nothing to analyse — and still gets caught (Q4).</a:t>
+              <a:t> each check's blind spot is another check's job — a same-voice clone fools Q1 but fails Q2; a brand-new TTS engine may slip past Q2 but has no real room behind it (Q3); a straight replay of the agent's own recording fools Q1 to Q3 — and still gets caught (Q4).</a:t>
             </a:r>
           </a:p>
         </p:txBody>

</xml_diff>

<commit_message>
deck: slide 3 now shows the four Q cards plus the attacker-variant table 🤖 Generated with Codebuff Co-Authored-By: Codebuff <noreply@codebuff.com>
</commit_message>
<xml_diff>
--- a/UNCLONE-day2-deck.pptx
+++ b/UNCLONE-day2-deck.pptx
@@ -3325,7 +3325,7 @@
                 </a:solidFill>
                 <a:latin typeface="Segoe UI"/>
               </a:rPr>
-              <a:t>“This is your bank about a ₹86,499 payment above your limit.”</a:t>
+              <a:t>This is your bank about a Rs 86,499 payment above your limit.</a:t>
             </a:r>
             <a:r>
               <a:rPr sz="1900" b="0">
@@ -3832,17 +3832,6 @@
               <a:t>GREEN · GO</a:t>
             </a:r>
           </a:p>
-          <a:p>
-            <a:r>
-              <a:rPr sz="1200" b="0">
-                <a:solidFill>
-                  <a:srgbClr val="33415C"/>
-                </a:solidFill>
-                <a:latin typeface="Segoe UI"/>
-              </a:rPr>
-              <a:t>Real agent voice, no machine parts. Carry on with the call.</a:t>
-            </a:r>
-          </a:p>
         </p:txBody>
       </p:sp>
       <p:sp>
@@ -3967,17 +3956,6 @@
               <a:t>AMBER · DOUBLE-CHECK</a:t>
             </a:r>
           </a:p>
-          <a:p>
-            <a:r>
-              <a:rPr sz="1200" b="0">
-                <a:solidFill>
-                  <a:srgbClr val="33415C"/>
-                </a:solidFill>
-                <a:latin typeface="Segoe UI"/>
-              </a:rPr>
-              <a:t>Can't be sure. Confirm the payment in the app instead.</a:t>
-            </a:r>
-          </a:p>
         </p:txBody>
       </p:sp>
       <p:sp>
@@ -4102,17 +4080,6 @@
               <a:t>RED · STOP</a:t>
             </a:r>
           </a:p>
-          <a:p>
-            <a:r>
-              <a:rPr sz="1200" b="0">
-                <a:solidFill>
-                  <a:srgbClr val="33415C"/>
-                </a:solidFill>
-                <a:latin typeface="Segoe UI"/>
-              </a:rPr>
-              <a:t>A fake was caught. The call is cut, the payment blocked.</a:t>
-            </a:r>
-          </a:p>
         </p:txBody>
       </p:sp>
       <p:sp>
@@ -4162,7 +4129,7 @@
                 </a:solidFill>
                 <a:latin typeface="Segoe UI"/>
               </a:rPr>
-              <a:t> and the transaction flips to “payment blocked”.</a:t>
+              <a:t> and the transaction flips to payment blocked.</a:t>
             </a:r>
           </a:p>
           <a:p>
@@ -4394,8 +4361,8 @@
         </p:nvSpPr>
         <p:spPr>
           <a:xfrm>
-            <a:off x="640080" y="1783080"/>
-            <a:ext cx="10972800" cy="685800"/>
+            <a:off x="640080" y="1737360"/>
+            <a:ext cx="10972800" cy="640080"/>
           </a:xfrm>
           <a:prstGeom prst="rect">
             <a:avLst/>
@@ -4464,8 +4431,8 @@
         </p:nvSpPr>
         <p:spPr>
           <a:xfrm>
-            <a:off x="640080" y="2651760"/>
-            <a:ext cx="5440680" cy="1371600"/>
+            <a:off x="640080" y="2606040"/>
+            <a:ext cx="5440680" cy="1261872"/>
           </a:xfrm>
           <a:prstGeom prst="roundRect">
             <a:avLst/>
@@ -4510,8 +4477,8 @@
         </p:nvSpPr>
         <p:spPr>
           <a:xfrm>
-            <a:off x="804671" y="2734056"/>
-            <a:ext cx="5111496" cy="1207008"/>
+            <a:off x="804671" y="2688336"/>
+            <a:ext cx="5111496" cy="1097280"/>
           </a:xfrm>
           <a:prstGeom prst="rect">
             <a:avLst/>
@@ -4542,7 +4509,7 @@
                 </a:solidFill>
                 <a:latin typeface="Segoe UI"/>
               </a:rPr>
-              <a:t>Every 6-second slice is checked against the voice fingerprint enrolled from the real bank agent; a slice that sounds like someone else fails here.</a:t>
+              <a:t>Every 6-second slice is checked against the voice fingerprint enrolled from the real bank agent; a different-voice clone fails here.</a:t>
             </a:r>
           </a:p>
         </p:txBody>
@@ -4555,8 +4522,8 @@
         </p:nvSpPr>
         <p:spPr>
           <a:xfrm>
-            <a:off x="6217920" y="2651760"/>
-            <a:ext cx="5440680" cy="1371600"/>
+            <a:off x="6217920" y="2606040"/>
+            <a:ext cx="5440680" cy="1261872"/>
           </a:xfrm>
           <a:prstGeom prst="roundRect">
             <a:avLst/>
@@ -4601,8 +4568,8 @@
         </p:nvSpPr>
         <p:spPr>
           <a:xfrm>
-            <a:off x="6382512" y="2734056"/>
-            <a:ext cx="5111496" cy="1207008"/>
+            <a:off x="6382512" y="2688336"/>
+            <a:ext cx="5111496" cy="1097280"/>
           </a:xfrm>
           <a:prstGeom prst="rect">
             <a:avLst/>
@@ -4633,7 +4600,7 @@
                 </a:solidFill>
                 <a:latin typeface="Segoe UI"/>
               </a:rPr>
-              <a:t>The same AI scores every 4-second piece for machine artefacts. A perfect same-voice clone can pass Q1 — but its machine-made pieces still score “0.999 synthetic” → red.</a:t>
+              <a:t>Same AI scores every 4-second piece for generator artefacts — a same-voice clone can pass Q1 but not this.</a:t>
             </a:r>
           </a:p>
         </p:txBody>
@@ -4646,8 +4613,8 @@
         </p:nvSpPr>
         <p:spPr>
           <a:xfrm>
-            <a:off x="640080" y="4133087"/>
-            <a:ext cx="5440680" cy="1371600"/>
+            <a:off x="640080" y="3977639"/>
+            <a:ext cx="5440680" cy="1261872"/>
           </a:xfrm>
           <a:prstGeom prst="roundRect">
             <a:avLst/>
@@ -4692,8 +4659,8 @@
         </p:nvSpPr>
         <p:spPr>
           <a:xfrm>
-            <a:off x="804671" y="4215383"/>
-            <a:ext cx="5111496" cy="1207008"/>
+            <a:off x="804671" y="4059935"/>
+            <a:ext cx="5111496" cy="1097280"/>
           </a:xfrm>
           <a:prstGeom prst="rect">
             <a:avLst/>
@@ -4724,7 +4691,7 @@
                 </a:solidFill>
                 <a:latin typeface="Segoe UI"/>
               </a:rPr>
-              <a:t>Forensics = a room-tone scan. Recordings of real calls carry the faint noise of a real space; computer-generated voices are born in digital silence. No room → amber.</a:t>
+              <a:t>Forensics checks for a real acoustic room. A pure digital render has none — that is an escalation only.</a:t>
             </a:r>
           </a:p>
         </p:txBody>
@@ -4737,8 +4704,8 @@
         </p:nvSpPr>
         <p:spPr>
           <a:xfrm>
-            <a:off x="6217920" y="4133087"/>
-            <a:ext cx="5440680" cy="1371600"/>
+            <a:off x="6217920" y="3977639"/>
+            <a:ext cx="5440680" cy="1261872"/>
           </a:xfrm>
           <a:prstGeom prst="roundRect">
             <a:avLst/>
@@ -4783,8 +4750,8 @@
         </p:nvSpPr>
         <p:spPr>
           <a:xfrm>
-            <a:off x="6382512" y="4215383"/>
-            <a:ext cx="5111496" cy="1207008"/>
+            <a:off x="6382512" y="4059935"/>
+            <a:ext cx="5111496" cy="1097280"/>
           </a:xfrm>
           <a:prstGeom prst="rect">
             <a:avLst/>
@@ -4815,7 +4782,7 @@
                 </a:solidFill>
                 <a:latin typeface="Segoe UI"/>
               </a:rPr>
-              <a:t>The exact same audio arriving twice is a recording being re-run, not a live conversation — blocked on the spot, however real it sounds.</a:t>
+              <a:t>Identical audio arriving twice is a recording being re-run, not a live call — blocked on the spot.</a:t>
             </a:r>
           </a:p>
         </p:txBody>
@@ -4828,8 +4795,8 @@
         </p:nvSpPr>
         <p:spPr>
           <a:xfrm>
-            <a:off x="640080" y="5715000"/>
-            <a:ext cx="10972800" cy="594360"/>
+            <a:off x="640080" y="5074920"/>
+            <a:ext cx="10972800" cy="274320"/>
           </a:xfrm>
           <a:prstGeom prst="rect">
             <a:avLst/>
@@ -4843,22 +4810,821 @@
           <a:lstStyle/>
           <a:p>
             <a:r>
-              <a:rPr sz="1350" b="1">
+              <a:rPr sz="1200" b="1">
                 <a:solidFill>
                   <a:srgbClr val="0F1B2D"/>
                 </a:solidFill>
                 <a:latin typeface="Segoe UI"/>
               </a:rPr>
-              <a:t>Why four layers:</a:t>
-            </a:r>
-            <a:r>
-              <a:rPr sz="1350" b="0">
+              <a:t>Four real attacker variants — and which layer bites each one:</a:t>
+            </a:r>
+          </a:p>
+        </p:txBody>
+      </p:sp>
+      <p:sp>
+        <p:nvSpPr>
+          <p:cNvPr id="17" name="Rectangle 16"/>
+          <p:cNvSpPr/>
+          <p:nvPr/>
+        </p:nvSpPr>
+        <p:spPr>
+          <a:xfrm>
+            <a:off x="640080" y="5413248"/>
+            <a:ext cx="10972800" cy="242316"/>
+          </a:xfrm>
+          <a:prstGeom prst="rect">
+            <a:avLst/>
+          </a:prstGeom>
+          <a:solidFill>
+            <a:srgbClr val="F2F6FB"/>
+          </a:solidFill>
+          <a:ln w="9525">
+            <a:solidFill>
+              <a:srgbClr val="D3DEEE"/>
+            </a:solidFill>
+          </a:ln>
+          <a:effectLst/>
+        </p:spPr>
+        <p:style>
+          <a:lnRef idx="1">
+            <a:schemeClr val="accent1"/>
+          </a:lnRef>
+          <a:fillRef idx="3">
+            <a:schemeClr val="accent1"/>
+          </a:fillRef>
+          <a:effectRef idx="2">
+            <a:schemeClr val="accent1"/>
+          </a:effectRef>
+          <a:fontRef idx="minor">
+            <a:schemeClr val="lt1"/>
+          </a:fontRef>
+        </p:style>
+        <p:txBody>
+          <a:bodyPr rtlCol="0" anchor="ctr"/>
+          <a:lstStyle/>
+          <a:p>
+            <a:pPr algn="ctr"/>
+          </a:p>
+        </p:txBody>
+      </p:sp>
+      <p:sp>
+        <p:nvSpPr>
+          <p:cNvPr id="18" name="TextBox 17"/>
+          <p:cNvSpPr txBox="1"/>
+          <p:nvPr/>
+        </p:nvSpPr>
+        <p:spPr>
+          <a:xfrm>
+            <a:off x="694944" y="5422392"/>
+            <a:ext cx="2084831" cy="251459"/>
+          </a:xfrm>
+          <a:prstGeom prst="rect">
+            <a:avLst/>
+          </a:prstGeom>
+          <a:noFill/>
+        </p:spPr>
+        <p:txBody>
+          <a:bodyPr wrap="square">
+            <a:spAutoFit/>
+          </a:bodyPr>
+          <a:lstStyle/>
+          <a:p>
+            <a:pPr>
+              <a:spcAft>
+                <a:spcPts val="0"/>
+              </a:spcAft>
+            </a:pPr>
+            <a:r>
+              <a:rPr sz="1100" b="1">
+                <a:solidFill>
+                  <a:srgbClr val="0F1B2D"/>
+                </a:solidFill>
+                <a:latin typeface="Segoe UI"/>
+              </a:rPr>
+              <a:t>A · Different voice clone</a:t>
+            </a:r>
+          </a:p>
+        </p:txBody>
+      </p:sp>
+      <p:sp>
+        <p:nvSpPr>
+          <p:cNvPr id="19" name="TextBox 18"/>
+          <p:cNvSpPr txBox="1"/>
+          <p:nvPr/>
+        </p:nvSpPr>
+        <p:spPr>
+          <a:xfrm>
+            <a:off x="2935224" y="5422392"/>
+            <a:ext cx="3273552" cy="251459"/>
+          </a:xfrm>
+          <a:prstGeom prst="rect">
+            <a:avLst/>
+          </a:prstGeom>
+          <a:noFill/>
+        </p:spPr>
+        <p:txBody>
+          <a:bodyPr wrap="square">
+            <a:spAutoFit/>
+          </a:bodyPr>
+          <a:lstStyle/>
+          <a:p>
+            <a:pPr>
+              <a:spcAft>
+                <a:spcPts val="0"/>
+              </a:spcAft>
+            </a:pPr>
+            <a:r>
+              <a:rPr sz="1050" b="0">
                 <a:solidFill>
                   <a:srgbClr val="33415C"/>
                 </a:solidFill>
                 <a:latin typeface="Segoe UI"/>
               </a:rPr>
-              <a:t> each check's blind spot is another check's job — a same-voice clone fools Q1 but fails Q2; a brand-new TTS engine may slip past Q2 but has no real room behind it (Q3); a straight replay of the agent's own recording fools Q1 to Q3 — and still gets caught (Q4).</a:t>
+              <a:t>Downtown, cheap TTS clone of another person.</a:t>
+            </a:r>
+          </a:p>
+        </p:txBody>
+      </p:sp>
+      <p:sp>
+        <p:nvSpPr>
+          <p:cNvPr id="20" name="TextBox 19"/>
+          <p:cNvSpPr txBox="1"/>
+          <p:nvPr/>
+        </p:nvSpPr>
+        <p:spPr>
+          <a:xfrm>
+            <a:off x="6318503" y="5422392"/>
+            <a:ext cx="3182112" cy="251459"/>
+          </a:xfrm>
+          <a:prstGeom prst="rect">
+            <a:avLst/>
+          </a:prstGeom>
+          <a:noFill/>
+        </p:spPr>
+        <p:txBody>
+          <a:bodyPr wrap="square">
+            <a:spAutoFit/>
+          </a:bodyPr>
+          <a:lstStyle/>
+          <a:p>
+            <a:pPr>
+              <a:spcAft>
+                <a:spcPts val="0"/>
+              </a:spcAft>
+            </a:pPr>
+            <a:r>
+              <a:rPr sz="1050" b="0">
+                <a:solidFill>
+                  <a:srgbClr val="33415C"/>
+                </a:solidFill>
+                <a:latin typeface="Segoe UI"/>
+              </a:rPr>
+              <a:t>fingerprint fails (similarity &lt; 0.53)</a:t>
+            </a:r>
+          </a:p>
+        </p:txBody>
+      </p:sp>
+      <p:sp>
+        <p:nvSpPr>
+          <p:cNvPr id="21" name="TextBox 20"/>
+          <p:cNvSpPr txBox="1"/>
+          <p:nvPr/>
+        </p:nvSpPr>
+        <p:spPr>
+          <a:xfrm>
+            <a:off x="9610344" y="5422392"/>
+            <a:ext cx="1993391" cy="251459"/>
+          </a:xfrm>
+          <a:prstGeom prst="rect">
+            <a:avLst/>
+          </a:prstGeom>
+          <a:noFill/>
+        </p:spPr>
+        <p:txBody>
+          <a:bodyPr wrap="square">
+            <a:spAutoFit/>
+          </a:bodyPr>
+          <a:lstStyle/>
+          <a:p>
+            <a:pPr algn="l">
+              <a:spcAft>
+                <a:spcPts val="0"/>
+              </a:spcAft>
+            </a:pPr>
+            <a:r>
+              <a:rPr sz="1050" b="1">
+                <a:solidFill>
+                  <a:srgbClr val="D6394B"/>
+                </a:solidFill>
+                <a:latin typeface="Segoe UI"/>
+              </a:rPr>
+              <a:t>RED HOLD</a:t>
+            </a:r>
+          </a:p>
+        </p:txBody>
+      </p:sp>
+      <p:sp>
+        <p:nvSpPr>
+          <p:cNvPr id="22" name="Rectangle 21"/>
+          <p:cNvSpPr/>
+          <p:nvPr/>
+        </p:nvSpPr>
+        <p:spPr>
+          <a:xfrm>
+            <a:off x="640080" y="5682996"/>
+            <a:ext cx="10972800" cy="242316"/>
+          </a:xfrm>
+          <a:prstGeom prst="rect">
+            <a:avLst/>
+          </a:prstGeom>
+          <a:solidFill>
+            <a:srgbClr val="E7EEF6"/>
+          </a:solidFill>
+          <a:ln w="9525">
+            <a:solidFill>
+              <a:srgbClr val="D3DEEE"/>
+            </a:solidFill>
+          </a:ln>
+          <a:effectLst/>
+        </p:spPr>
+        <p:style>
+          <a:lnRef idx="1">
+            <a:schemeClr val="accent1"/>
+          </a:lnRef>
+          <a:fillRef idx="3">
+            <a:schemeClr val="accent1"/>
+          </a:fillRef>
+          <a:effectRef idx="2">
+            <a:schemeClr val="accent1"/>
+          </a:effectRef>
+          <a:fontRef idx="minor">
+            <a:schemeClr val="lt1"/>
+          </a:fontRef>
+        </p:style>
+        <p:txBody>
+          <a:bodyPr rtlCol="0" anchor="ctr"/>
+          <a:lstStyle/>
+          <a:p>
+            <a:pPr algn="ctr"/>
+          </a:p>
+        </p:txBody>
+      </p:sp>
+      <p:sp>
+        <p:nvSpPr>
+          <p:cNvPr id="23" name="TextBox 22"/>
+          <p:cNvSpPr txBox="1"/>
+          <p:nvPr/>
+        </p:nvSpPr>
+        <p:spPr>
+          <a:xfrm>
+            <a:off x="694944" y="5692140"/>
+            <a:ext cx="2084831" cy="251459"/>
+          </a:xfrm>
+          <a:prstGeom prst="rect">
+            <a:avLst/>
+          </a:prstGeom>
+          <a:noFill/>
+        </p:spPr>
+        <p:txBody>
+          <a:bodyPr wrap="square">
+            <a:spAutoFit/>
+          </a:bodyPr>
+          <a:lstStyle/>
+          <a:p>
+            <a:pPr>
+              <a:spcAft>
+                <a:spcPts val="0"/>
+              </a:spcAft>
+            </a:pPr>
+            <a:r>
+              <a:rPr sz="1100" b="1">
+                <a:solidFill>
+                  <a:srgbClr val="0F1B2D"/>
+                </a:solidFill>
+                <a:latin typeface="Segoe UI"/>
+              </a:rPr>
+              <a:t>B · Same-voice clone (our Call 2 / 3)</a:t>
+            </a:r>
+          </a:p>
+        </p:txBody>
+      </p:sp>
+      <p:sp>
+        <p:nvSpPr>
+          <p:cNvPr id="24" name="TextBox 23"/>
+          <p:cNvSpPr txBox="1"/>
+          <p:nvPr/>
+        </p:nvSpPr>
+        <p:spPr>
+          <a:xfrm>
+            <a:off x="2935224" y="5692140"/>
+            <a:ext cx="3273552" cy="251459"/>
+          </a:xfrm>
+          <a:prstGeom prst="rect">
+            <a:avLst/>
+          </a:prstGeom>
+          <a:noFill/>
+        </p:spPr>
+        <p:txBody>
+          <a:bodyPr wrap="square">
+            <a:spAutoFit/>
+          </a:bodyPr>
+          <a:lstStyle/>
+          <a:p>
+            <a:pPr>
+              <a:spcAft>
+                <a:spcPts val="0"/>
+              </a:spcAft>
+            </a:pPr>
+            <a:r>
+              <a:rPr sz="1050" b="0">
+                <a:solidFill>
+                  <a:srgbClr val="33415C"/>
+                </a:solidFill>
+                <a:latin typeface="Segoe UI"/>
+              </a:rPr>
+              <a:t>Same tool, only the agent's timbre.</a:t>
+            </a:r>
+          </a:p>
+        </p:txBody>
+      </p:sp>
+      <p:sp>
+        <p:nvSpPr>
+          <p:cNvPr id="25" name="TextBox 24"/>
+          <p:cNvSpPr txBox="1"/>
+          <p:nvPr/>
+        </p:nvSpPr>
+        <p:spPr>
+          <a:xfrm>
+            <a:off x="6318503" y="5692140"/>
+            <a:ext cx="3182112" cy="251459"/>
+          </a:xfrm>
+          <a:prstGeom prst="rect">
+            <a:avLst/>
+          </a:prstGeom>
+          <a:noFill/>
+        </p:spPr>
+        <p:txBody>
+          <a:bodyPr wrap="square">
+            <a:spAutoFit/>
+          </a:bodyPr>
+          <a:lstStyle/>
+          <a:p>
+            <a:pPr>
+              <a:spcAft>
+                <a:spcPts val="0"/>
+              </a:spcAft>
+            </a:pPr>
+            <a:r>
+              <a:rPr sz="1050" b="0">
+                <a:solidFill>
+                  <a:srgbClr val="33415C"/>
+                </a:solidFill>
+                <a:latin typeface="Segoe UI"/>
+              </a:rPr>
+              <a:t>fingerprint may pass, but deepfake flags machine artefacts per 4-s slice; one hot &gt;= 0.90 holds</a:t>
+            </a:r>
+          </a:p>
+        </p:txBody>
+      </p:sp>
+      <p:sp>
+        <p:nvSpPr>
+          <p:cNvPr id="26" name="TextBox 25"/>
+          <p:cNvSpPr txBox="1"/>
+          <p:nvPr/>
+        </p:nvSpPr>
+        <p:spPr>
+          <a:xfrm>
+            <a:off x="9610344" y="5692140"/>
+            <a:ext cx="1993391" cy="251459"/>
+          </a:xfrm>
+          <a:prstGeom prst="rect">
+            <a:avLst/>
+          </a:prstGeom>
+          <a:noFill/>
+        </p:spPr>
+        <p:txBody>
+          <a:bodyPr wrap="square">
+            <a:spAutoFit/>
+          </a:bodyPr>
+          <a:lstStyle/>
+          <a:p>
+            <a:pPr algn="l">
+              <a:spcAft>
+                <a:spcPts val="0"/>
+              </a:spcAft>
+            </a:pPr>
+            <a:r>
+              <a:rPr sz="1050" b="1">
+                <a:solidFill>
+                  <a:srgbClr val="D6394B"/>
+                </a:solidFill>
+                <a:latin typeface="Segoe UI"/>
+              </a:rPr>
+              <a:t>RED HOLD</a:t>
+            </a:r>
+          </a:p>
+        </p:txBody>
+      </p:sp>
+      <p:sp>
+        <p:nvSpPr>
+          <p:cNvPr id="27" name="Rectangle 26"/>
+          <p:cNvSpPr/>
+          <p:nvPr/>
+        </p:nvSpPr>
+        <p:spPr>
+          <a:xfrm>
+            <a:off x="640080" y="5952744"/>
+            <a:ext cx="10972800" cy="242316"/>
+          </a:xfrm>
+          <a:prstGeom prst="rect">
+            <a:avLst/>
+          </a:prstGeom>
+          <a:solidFill>
+            <a:srgbClr val="F2F6FB"/>
+          </a:solidFill>
+          <a:ln w="9525">
+            <a:solidFill>
+              <a:srgbClr val="D3DEEE"/>
+            </a:solidFill>
+          </a:ln>
+          <a:effectLst/>
+        </p:spPr>
+        <p:style>
+          <a:lnRef idx="1">
+            <a:schemeClr val="accent1"/>
+          </a:lnRef>
+          <a:fillRef idx="3">
+            <a:schemeClr val="accent1"/>
+          </a:fillRef>
+          <a:effectRef idx="2">
+            <a:schemeClr val="accent1"/>
+          </a:effectRef>
+          <a:fontRef idx="minor">
+            <a:schemeClr val="lt1"/>
+          </a:fontRef>
+        </p:style>
+        <p:txBody>
+          <a:bodyPr rtlCol="0" anchor="ctr"/>
+          <a:lstStyle/>
+          <a:p>
+            <a:pPr algn="ctr"/>
+          </a:p>
+        </p:txBody>
+      </p:sp>
+      <p:sp>
+        <p:nvSpPr>
+          <p:cNvPr id="28" name="TextBox 27"/>
+          <p:cNvSpPr txBox="1"/>
+          <p:nvPr/>
+        </p:nvSpPr>
+        <p:spPr>
+          <a:xfrm>
+            <a:off x="694944" y="5961888"/>
+            <a:ext cx="2084831" cy="251459"/>
+          </a:xfrm>
+          <a:prstGeom prst="rect">
+            <a:avLst/>
+          </a:prstGeom>
+          <a:noFill/>
+        </p:spPr>
+        <p:txBody>
+          <a:bodyPr wrap="square">
+            <a:spAutoFit/>
+          </a:bodyPr>
+          <a:lstStyle/>
+          <a:p>
+            <a:pPr>
+              <a:spcAft>
+                <a:spcPts val="0"/>
+              </a:spcAft>
+            </a:pPr>
+            <a:r>
+              <a:rPr sz="1100" b="1">
+                <a:solidFill>
+                  <a:srgbClr val="0F1B2D"/>
+                </a:solidFill>
+                <a:latin typeface="Segoe UI"/>
+              </a:rPr>
+              <a:t>C · Clone that also fools deepfake</a:t>
+            </a:r>
+          </a:p>
+        </p:txBody>
+      </p:sp>
+      <p:sp>
+        <p:nvSpPr>
+          <p:cNvPr id="29" name="TextBox 28"/>
+          <p:cNvSpPr txBox="1"/>
+          <p:nvPr/>
+        </p:nvSpPr>
+        <p:spPr>
+          <a:xfrm>
+            <a:off x="2935224" y="5961888"/>
+            <a:ext cx="3273552" cy="251459"/>
+          </a:xfrm>
+          <a:prstGeom prst="rect">
+            <a:avLst/>
+          </a:prstGeom>
+          <a:noFill/>
+        </p:spPr>
+        <p:txBody>
+          <a:bodyPr wrap="square">
+            <a:spAutoFit/>
+          </a:bodyPr>
+          <a:lstStyle/>
+          <a:p>
+            <a:pPr>
+              <a:spcAft>
+                <a:spcPts val="0"/>
+              </a:spcAft>
+            </a:pPr>
+            <a:r>
+              <a:rPr sz="1050" b="0">
+                <a:solidFill>
+                  <a:srgbClr val="33415C"/>
+                </a:solidFill>
+                <a:latin typeface="Segoe UI"/>
+              </a:rPr>
+              <a:t>Newer engine unseen in training; deepfake low, similarity high.</a:t>
+            </a:r>
+          </a:p>
+        </p:txBody>
+      </p:sp>
+      <p:sp>
+        <p:nvSpPr>
+          <p:cNvPr id="30" name="TextBox 29"/>
+          <p:cNvSpPr txBox="1"/>
+          <p:nvPr/>
+        </p:nvSpPr>
+        <p:spPr>
+          <a:xfrm>
+            <a:off x="6318503" y="5961888"/>
+            <a:ext cx="3182112" cy="251459"/>
+          </a:xfrm>
+          <a:prstGeom prst="rect">
+            <a:avLst/>
+          </a:prstGeom>
+          <a:noFill/>
+        </p:spPr>
+        <p:txBody>
+          <a:bodyPr wrap="square">
+            <a:spAutoFit/>
+          </a:bodyPr>
+          <a:lstStyle/>
+          <a:p>
+            <a:pPr>
+              <a:spcAft>
+                <a:spcPts val="0"/>
+              </a:spcAft>
+            </a:pPr>
+            <a:r>
+              <a:rPr sz="1050" b="0">
+                <a:solidFill>
+                  <a:srgbClr val="33415C"/>
+                </a:solidFill>
+                <a:latin typeface="Segoe UI"/>
+              </a:rPr>
+              <a:t>forensics catches a pure digital render: no room tone</a:t>
+            </a:r>
+          </a:p>
+        </p:txBody>
+      </p:sp>
+      <p:sp>
+        <p:nvSpPr>
+          <p:cNvPr id="31" name="TextBox 30"/>
+          <p:cNvSpPr txBox="1"/>
+          <p:nvPr/>
+        </p:nvSpPr>
+        <p:spPr>
+          <a:xfrm>
+            <a:off x="9610344" y="5961888"/>
+            <a:ext cx="1993391" cy="251459"/>
+          </a:xfrm>
+          <a:prstGeom prst="rect">
+            <a:avLst/>
+          </a:prstGeom>
+          <a:noFill/>
+        </p:spPr>
+        <p:txBody>
+          <a:bodyPr wrap="square">
+            <a:spAutoFit/>
+          </a:bodyPr>
+          <a:lstStyle/>
+          <a:p>
+            <a:pPr algn="l">
+              <a:spcAft>
+                <a:spcPts val="0"/>
+              </a:spcAft>
+            </a:pPr>
+            <a:r>
+              <a:rPr sz="1050" b="1">
+                <a:solidFill>
+                  <a:srgbClr val="C88600"/>
+                </a:solidFill>
+                <a:latin typeface="Segoe UI"/>
+              </a:rPr>
+              <a:t>AMBER STEP-UP</a:t>
+            </a:r>
+          </a:p>
+        </p:txBody>
+      </p:sp>
+      <p:sp>
+        <p:nvSpPr>
+          <p:cNvPr id="32" name="Rectangle 31"/>
+          <p:cNvSpPr/>
+          <p:nvPr/>
+        </p:nvSpPr>
+        <p:spPr>
+          <a:xfrm>
+            <a:off x="640080" y="6222492"/>
+            <a:ext cx="10972800" cy="242316"/>
+          </a:xfrm>
+          <a:prstGeom prst="rect">
+            <a:avLst/>
+          </a:prstGeom>
+          <a:solidFill>
+            <a:srgbClr val="E7EEF6"/>
+          </a:solidFill>
+          <a:ln w="9525">
+            <a:solidFill>
+              <a:srgbClr val="D3DEEE"/>
+            </a:solidFill>
+          </a:ln>
+          <a:effectLst/>
+        </p:spPr>
+        <p:style>
+          <a:lnRef idx="1">
+            <a:schemeClr val="accent1"/>
+          </a:lnRef>
+          <a:fillRef idx="3">
+            <a:schemeClr val="accent1"/>
+          </a:fillRef>
+          <a:effectRef idx="2">
+            <a:schemeClr val="accent1"/>
+          </a:effectRef>
+          <a:fontRef idx="minor">
+            <a:schemeClr val="lt1"/>
+          </a:fontRef>
+        </p:style>
+        <p:txBody>
+          <a:bodyPr rtlCol="0" anchor="ctr"/>
+          <a:lstStyle/>
+          <a:p>
+            <a:pPr algn="ctr"/>
+          </a:p>
+        </p:txBody>
+      </p:sp>
+      <p:sp>
+        <p:nvSpPr>
+          <p:cNvPr id="33" name="TextBox 32"/>
+          <p:cNvSpPr txBox="1"/>
+          <p:nvPr/>
+        </p:nvSpPr>
+        <p:spPr>
+          <a:xfrm>
+            <a:off x="694944" y="6231636"/>
+            <a:ext cx="2084831" cy="251459"/>
+          </a:xfrm>
+          <a:prstGeom prst="rect">
+            <a:avLst/>
+          </a:prstGeom>
+          <a:noFill/>
+        </p:spPr>
+        <p:txBody>
+          <a:bodyPr wrap="square">
+            <a:spAutoFit/>
+          </a:bodyPr>
+          <a:lstStyle/>
+          <a:p>
+            <a:pPr>
+              <a:spcAft>
+                <a:spcPts val="0"/>
+              </a:spcAft>
+            </a:pPr>
+            <a:r>
+              <a:rPr sz="1100" b="1">
+                <a:solidFill>
+                  <a:srgbClr val="0F1B2D"/>
+                </a:solidFill>
+                <a:latin typeface="Segoe UI"/>
+              </a:rPr>
+              <a:t>D · Replay of the agent's real audio</a:t>
+            </a:r>
+          </a:p>
+        </p:txBody>
+      </p:sp>
+      <p:sp>
+        <p:nvSpPr>
+          <p:cNvPr id="34" name="TextBox 33"/>
+          <p:cNvSpPr txBox="1"/>
+          <p:nvPr/>
+        </p:nvSpPr>
+        <p:spPr>
+          <a:xfrm>
+            <a:off x="2935224" y="6231636"/>
+            <a:ext cx="3273552" cy="251459"/>
+          </a:xfrm>
+          <a:prstGeom prst="rect">
+            <a:avLst/>
+          </a:prstGeom>
+          <a:noFill/>
+        </p:spPr>
+        <p:txBody>
+          <a:bodyPr wrap="square">
+            <a:spAutoFit/>
+          </a:bodyPr>
+          <a:lstStyle/>
+          <a:p>
+            <a:pPr>
+              <a:spcAft>
+                <a:spcPts val="0"/>
+              </a:spcAft>
+            </a:pPr>
+            <a:r>
+              <a:rPr sz="1050" b="0">
+                <a:solidFill>
+                  <a:srgbClr val="33415C"/>
+                </a:solidFill>
+                <a:latin typeface="Segoe UI"/>
+              </a:rPr>
+              <a:t>Attacker plays the agent's own recording back.</a:t>
+            </a:r>
+          </a:p>
+        </p:txBody>
+      </p:sp>
+      <p:sp>
+        <p:nvSpPr>
+          <p:cNvPr id="35" name="TextBox 34"/>
+          <p:cNvSpPr txBox="1"/>
+          <p:nvPr/>
+        </p:nvSpPr>
+        <p:spPr>
+          <a:xfrm>
+            <a:off x="6318503" y="6231636"/>
+            <a:ext cx="3182112" cy="251459"/>
+          </a:xfrm>
+          <a:prstGeom prst="rect">
+            <a:avLst/>
+          </a:prstGeom>
+          <a:noFill/>
+        </p:spPr>
+        <p:txBody>
+          <a:bodyPr wrap="square">
+            <a:spAutoFit/>
+          </a:bodyPr>
+          <a:lstStyle/>
+          <a:p>
+            <a:pPr>
+              <a:spcAft>
+                <a:spcPts val="0"/>
+              </a:spcAft>
+            </a:pPr>
+            <a:r>
+              <a:rPr sz="1050" b="0">
+                <a:solidFill>
+                  <a:srgbClr val="33415C"/>
+                </a:solidFill>
+                <a:latin typeface="Segoe UI"/>
+              </a:rPr>
+              <a:t>everything else passes — content fingerprint catches identical audio re-sent</a:t>
+            </a:r>
+          </a:p>
+        </p:txBody>
+      </p:sp>
+      <p:sp>
+        <p:nvSpPr>
+          <p:cNvPr id="36" name="TextBox 35"/>
+          <p:cNvSpPr txBox="1"/>
+          <p:nvPr/>
+        </p:nvSpPr>
+        <p:spPr>
+          <a:xfrm>
+            <a:off x="9610344" y="6231636"/>
+            <a:ext cx="1993391" cy="251459"/>
+          </a:xfrm>
+          <a:prstGeom prst="rect">
+            <a:avLst/>
+          </a:prstGeom>
+          <a:noFill/>
+        </p:spPr>
+        <p:txBody>
+          <a:bodyPr wrap="square">
+            <a:spAutoFit/>
+          </a:bodyPr>
+          <a:lstStyle/>
+          <a:p>
+            <a:pPr algn="l">
+              <a:spcAft>
+                <a:spcPts val="0"/>
+              </a:spcAft>
+            </a:pPr>
+            <a:r>
+              <a:rPr sz="1050" b="1">
+                <a:solidFill>
+                  <a:srgbClr val="D6394B"/>
+                </a:solidFill>
+                <a:latin typeface="Segoe UI"/>
+              </a:rPr>
+              <a:t>RED HOLD</a:t>
             </a:r>
           </a:p>
         </p:txBody>
@@ -5114,25 +5880,7 @@
                 </a:solidFill>
                 <a:latin typeface="Segoe UI"/>
               </a:rPr>
-              <a:t>≈ </a:t>
-            </a:r>
-            <a:r>
-              <a:rPr sz="1800" b="1">
-                <a:solidFill>
-                  <a:srgbClr val="0F1B2D"/>
-                </a:solidFill>
-                <a:latin typeface="Segoe UI"/>
-              </a:rPr>
-              <a:t>$5,700</a:t>
-            </a:r>
-            <a:r>
-              <a:rPr sz="1800" b="0">
-                <a:solidFill>
-                  <a:srgbClr val="33415C"/>
-                </a:solidFill>
-                <a:latin typeface="Segoe UI"/>
-              </a:rPr>
-              <a:t> (≈ ₹4.8 lakh). (FTC 2024)</a:t>
+              <a:t>about $5,700 (about Rs 4.8 lakh, FTC 2024).</a:t>
             </a:r>
           </a:p>
           <a:p>
@@ -5157,25 +5905,7 @@
                 </a:solidFill>
                 <a:latin typeface="Segoe UI"/>
               </a:rPr>
-              <a:t>≈ </a:t>
-            </a:r>
-            <a:r>
-              <a:rPr sz="1800" b="1">
-                <a:solidFill>
-                  <a:srgbClr val="0F1B2D"/>
-                </a:solidFill>
-                <a:latin typeface="Segoe UI"/>
-              </a:rPr>
-              <a:t>50 cents.</a:t>
-            </a:r>
-            <a:r>
-              <a:rPr sz="1800" b="0">
-                <a:solidFill>
-                  <a:srgbClr val="33415C"/>
-                </a:solidFill>
-                <a:latin typeface="Segoe UI"/>
-              </a:rPr>
-              <a:t> The whole product story is this gap.</a:t>
+              <a:t>about 50 cents. The whole product story is this gap.</a:t>
             </a:r>
           </a:p>
           <a:p>
@@ -5200,25 +5930,7 @@
                 </a:solidFill>
                 <a:latin typeface="Segoe UI"/>
               </a:rPr>
-              <a:t>≈ </a:t>
-            </a:r>
-            <a:r>
-              <a:rPr sz="1700" b="1">
-                <a:solidFill>
-                  <a:srgbClr val="0F1B2D"/>
-                </a:solidFill>
-                <a:latin typeface="Segoe UI"/>
-              </a:rPr>
-              <a:t>$66 M/yr</a:t>
-            </a:r>
-            <a:r>
-              <a:rPr sz="1700" b="0">
-                <a:solidFill>
-                  <a:srgbClr val="33415C"/>
-                </a:solidFill>
-                <a:latin typeface="Segoe UI"/>
-              </a:rPr>
-              <a:t> of prevented losses. That's the five-frame model: 1.56 M risky calls × 1.33 % scams × $5,700 × 80 % caught × 70 % stopped.</a:t>
+              <a:t>about $66 M/yr of prevented losses. That's the five-frame model: 1.56 M risky calls x 1.33 % scams x $5,700 x 80 % caught x 70 % stopped.</a:t>
             </a:r>
           </a:p>
           <a:p>
@@ -5323,7 +6035,7 @@
                 </a:solidFill>
                 <a:latin typeface="Segoe UI"/>
               </a:rPr>
-              <a:t>~100×</a:t>
+              <a:t>~100x</a:t>
             </a:r>
           </a:p>
           <a:p>
@@ -5694,7 +6406,7 @@
                 </a:solidFill>
                 <a:latin typeface="Segoe UI"/>
               </a:rPr>
-              <a:t>15–60 s of that recording</a:t>
+              <a:t>15 to 60 s of that recording</a:t>
             </a:r>
             <a:r>
               <a:rPr sz="1700" b="0">

</xml_diff>

<commit_message>
deck: slide 3 = explicit attacker-block table (A/B/C/D) with real thresholds from policy.py 🤖 Generated with Codebuff Co-Authored-By: Codebuff <noreply@codebuff.com>
</commit_message>
<xml_diff>
--- a/UNCLONE-day2-deck.pptx
+++ b/UNCLONE-day2-deck.pptx
@@ -4270,7 +4270,7 @@
                 </a:solidFill>
                 <a:latin typeface="Segoe UI"/>
               </a:rPr>
-              <a:t>Four questions, asked every 6 seconds</a:t>
+              <a:t>Every attack — and which rule catches it</a:t>
             </a:r>
           </a:p>
         </p:txBody>
@@ -4361,8 +4361,8 @@
         </p:nvSpPr>
         <p:spPr>
           <a:xfrm>
-            <a:off x="640080" y="1737360"/>
-            <a:ext cx="10972800" cy="640080"/>
+            <a:off x="640080" y="1691640"/>
+            <a:ext cx="10972800" cy="548640"/>
           </a:xfrm>
           <a:prstGeom prst="rect">
             <a:avLst/>
@@ -4376,74 +4376,54 @@
           <a:lstStyle/>
           <a:p>
             <a:r>
-              <a:rPr sz="1800" b="0">
+              <a:rPr sz="1600" b="0">
                 <a:solidFill>
                   <a:srgbClr val="33415C"/>
                 </a:solidFill>
                 <a:latin typeface="Segoe UI"/>
               </a:rPr>
-              <a:t>The call is chopped into </a:t>
-            </a:r>
-            <a:r>
-              <a:rPr sz="1800" b="1">
+              <a:t>One AI engine answers </a:t>
+            </a:r>
+            <a:r>
+              <a:rPr sz="1600" b="1">
                 <a:solidFill>
                   <a:srgbClr val="0F1B2D"/>
                 </a:solidFill>
                 <a:latin typeface="Segoe UI"/>
               </a:rPr>
-              <a:t>6-second slices</a:t>
-            </a:r>
-            <a:r>
-              <a:rPr sz="1800" b="0">
+              <a:t>four different questions</a:t>
+            </a:r>
+            <a:r>
+              <a:rPr sz="1600" b="0">
                 <a:solidFill>
                   <a:srgbClr val="33415C"/>
                 </a:solidFill>
                 <a:latin typeface="Segoe UI"/>
               </a:rPr>
-              <a:t>, and each slice answers four questions. If any answer is wrong — red or amber, </a:t>
-            </a:r>
-            <a:r>
-              <a:rPr sz="1800" b="1">
-                <a:solidFill>
-                  <a:srgbClr val="0F1B2D"/>
-                </a:solidFill>
-                <a:latin typeface="Segoe UI"/>
-              </a:rPr>
-              <a:t>never auto-approve</a:t>
-            </a:r>
-            <a:r>
-              <a:rPr sz="1800" b="0">
-                <a:solidFill>
-                  <a:srgbClr val="33415C"/>
-                </a:solidFill>
-                <a:latin typeface="Segoe UI"/>
-              </a:rPr>
-              <a:t>.</a:t>
-            </a:r>
-          </a:p>
-        </p:txBody>
-      </p:sp>
-      <p:sp>
-        <p:nvSpPr>
-          <p:cNvPr id="8" name="Rounded Rectangle 7"/>
+              <a:t> about every 6-second slice. Each layer catches what the layer above it cannot see.</a:t>
+            </a:r>
+          </a:p>
+        </p:txBody>
+      </p:sp>
+      <p:sp>
+        <p:nvSpPr>
+          <p:cNvPr id="8" name="Rectangle 7"/>
           <p:cNvSpPr/>
           <p:nvPr/>
         </p:nvSpPr>
         <p:spPr>
           <a:xfrm>
-            <a:off x="640080" y="2606040"/>
-            <a:ext cx="5440680" cy="1261872"/>
-          </a:xfrm>
-          <a:prstGeom prst="roundRect">
+            <a:off x="640080" y="2395728"/>
+            <a:ext cx="11201400" cy="384048"/>
+          </a:xfrm>
+          <a:prstGeom prst="rect">
             <a:avLst/>
           </a:prstGeom>
           <a:solidFill>
-            <a:srgbClr val="F2F6FB"/>
+            <a:srgbClr val="0F1B2D"/>
           </a:solidFill>
-          <a:ln w="9525">
-            <a:solidFill>
-              <a:srgbClr val="D3DEEE"/>
-            </a:solidFill>
+          <a:ln>
+            <a:noFill/>
           </a:ln>
           <a:effectLst/>
         </p:spPr>
@@ -4477,8 +4457,8 @@
         </p:nvSpPr>
         <p:spPr>
           <a:xfrm>
-            <a:off x="804671" y="2688336"/>
-            <a:ext cx="5111496" cy="1097280"/>
+            <a:off x="713231" y="2450592"/>
+            <a:ext cx="438912" cy="292608"/>
           </a:xfrm>
           <a:prstGeom prst="rect">
             <a:avLst/>
@@ -4492,40 +4472,165 @@
           <a:lstStyle/>
           <a:p>
             <a:r>
-              <a:rPr sz="1450" b="1">
-                <a:solidFill>
-                  <a:srgbClr val="0E9F6E"/>
-                </a:solidFill>
-                <a:latin typeface="Segoe UI"/>
-              </a:rPr>
-              <a:t>1 · Is it the right voice?</a:t>
-            </a:r>
-          </a:p>
-          <a:p>
-            <a:r>
-              <a:rPr sz="1150" b="0">
-                <a:solidFill>
-                  <a:srgbClr val="33415C"/>
-                </a:solidFill>
-                <a:latin typeface="Segoe UI"/>
-              </a:rPr>
-              <a:t>Every 6-second slice is checked against the voice fingerprint enrolled from the real bank agent; a different-voice clone fails here.</a:t>
-            </a:r>
-          </a:p>
-        </p:txBody>
-      </p:sp>
-      <p:sp>
-        <p:nvSpPr>
-          <p:cNvPr id="10" name="Rounded Rectangle 9"/>
+              <a:rPr sz="1000" b="1">
+                <a:solidFill>
+                  <a:srgbClr val="FFFFFF"/>
+                </a:solidFill>
+                <a:latin typeface="Segoe UI"/>
+              </a:rPr>
+              <a:t>#</a:t>
+            </a:r>
+          </a:p>
+        </p:txBody>
+      </p:sp>
+      <p:sp>
+        <p:nvSpPr>
+          <p:cNvPr id="10" name="TextBox 9"/>
+          <p:cNvSpPr txBox="1"/>
+          <p:nvPr/>
+        </p:nvSpPr>
+        <p:spPr>
+          <a:xfrm>
+            <a:off x="1307592" y="2450592"/>
+            <a:ext cx="3364991" cy="292608"/>
+          </a:xfrm>
+          <a:prstGeom prst="rect">
+            <a:avLst/>
+          </a:prstGeom>
+          <a:noFill/>
+        </p:spPr>
+        <p:txBody>
+          <a:bodyPr wrap="square">
+            <a:spAutoFit/>
+          </a:bodyPr>
+          <a:lstStyle/>
+          <a:p>
+            <a:r>
+              <a:rPr sz="1000" b="1">
+                <a:solidFill>
+                  <a:srgbClr val="FFFFFF"/>
+                </a:solidFill>
+                <a:latin typeface="Segoe UI"/>
+              </a:rPr>
+              <a:t>WHAT THE ATTACKER DOES</a:t>
+            </a:r>
+          </a:p>
+        </p:txBody>
+      </p:sp>
+      <p:sp>
+        <p:nvSpPr>
+          <p:cNvPr id="11" name="TextBox 10"/>
+          <p:cNvSpPr txBox="1"/>
+          <p:nvPr/>
+        </p:nvSpPr>
+        <p:spPr>
+          <a:xfrm>
+            <a:off x="4782312" y="2450592"/>
+            <a:ext cx="2999232" cy="292608"/>
+          </a:xfrm>
+          <a:prstGeom prst="rect">
+            <a:avLst/>
+          </a:prstGeom>
+          <a:noFill/>
+        </p:spPr>
+        <p:txBody>
+          <a:bodyPr wrap="square">
+            <a:spAutoFit/>
+          </a:bodyPr>
+          <a:lstStyle/>
+          <a:p>
+            <a:r>
+              <a:rPr sz="1000" b="1">
+                <a:solidFill>
+                  <a:srgbClr val="FFFFFF"/>
+                </a:solidFill>
+                <a:latin typeface="Segoe UI"/>
+              </a:rPr>
+              <a:t>WHAT THE PIPELINE SEES</a:t>
+            </a:r>
+          </a:p>
+        </p:txBody>
+      </p:sp>
+      <p:sp>
+        <p:nvSpPr>
+          <p:cNvPr id="12" name="TextBox 11"/>
+          <p:cNvSpPr txBox="1"/>
+          <p:nvPr/>
+        </p:nvSpPr>
+        <p:spPr>
+          <a:xfrm>
+            <a:off x="7891272" y="2450592"/>
+            <a:ext cx="2450591" cy="292608"/>
+          </a:xfrm>
+          <a:prstGeom prst="rect">
+            <a:avLst/>
+          </a:prstGeom>
+          <a:noFill/>
+        </p:spPr>
+        <p:txBody>
+          <a:bodyPr wrap="square">
+            <a:spAutoFit/>
+          </a:bodyPr>
+          <a:lstStyle/>
+          <a:p>
+            <a:r>
+              <a:rPr sz="1000" b="1">
+                <a:solidFill>
+                  <a:srgbClr val="FFFFFF"/>
+                </a:solidFill>
+                <a:latin typeface="Segoe UI"/>
+              </a:rPr>
+              <a:t>WHICH RULE CATCHES IT</a:t>
+            </a:r>
+          </a:p>
+        </p:txBody>
+      </p:sp>
+      <p:sp>
+        <p:nvSpPr>
+          <p:cNvPr id="13" name="TextBox 12"/>
+          <p:cNvSpPr txBox="1"/>
+          <p:nvPr/>
+        </p:nvSpPr>
+        <p:spPr>
+          <a:xfrm>
+            <a:off x="10451592" y="2450592"/>
+            <a:ext cx="1307592" cy="292608"/>
+          </a:xfrm>
+          <a:prstGeom prst="rect">
+            <a:avLst/>
+          </a:prstGeom>
+          <a:noFill/>
+        </p:spPr>
+        <p:txBody>
+          <a:bodyPr wrap="square">
+            <a:spAutoFit/>
+          </a:bodyPr>
+          <a:lstStyle/>
+          <a:p>
+            <a:r>
+              <a:rPr sz="1000" b="1">
+                <a:solidFill>
+                  <a:srgbClr val="FFFFFF"/>
+                </a:solidFill>
+                <a:latin typeface="Segoe UI"/>
+              </a:rPr>
+              <a:t>RESULT</a:t>
+            </a:r>
+          </a:p>
+        </p:txBody>
+      </p:sp>
+      <p:sp>
+        <p:nvSpPr>
+          <p:cNvPr id="14" name="Rectangle 13"/>
           <p:cNvSpPr/>
           <p:nvPr/>
         </p:nvSpPr>
         <p:spPr>
           <a:xfrm>
-            <a:off x="6217920" y="2606040"/>
-            <a:ext cx="5440680" cy="1261872"/>
-          </a:xfrm>
-          <a:prstGeom prst="roundRect">
+            <a:off x="640080" y="2798064"/>
+            <a:ext cx="11201400" cy="713231"/>
+          </a:xfrm>
+          <a:prstGeom prst="rect">
             <a:avLst/>
           </a:prstGeom>
           <a:solidFill>
@@ -4562,14 +4667,14 @@
       </p:sp>
       <p:sp>
         <p:nvSpPr>
-          <p:cNvPr id="11" name="TextBox 10"/>
+          <p:cNvPr id="15" name="TextBox 14"/>
           <p:cNvSpPr txBox="1"/>
           <p:nvPr/>
         </p:nvSpPr>
         <p:spPr>
           <a:xfrm>
-            <a:off x="6382512" y="2688336"/>
-            <a:ext cx="5111496" cy="1097280"/>
+            <a:off x="768096" y="2962656"/>
+            <a:ext cx="548640" cy="365760"/>
           </a:xfrm>
           <a:prstGeom prst="rect">
             <a:avLst/>
@@ -4583,44 +4688,205 @@
           <a:lstStyle/>
           <a:p>
             <a:r>
-              <a:rPr sz="1450" b="1">
-                <a:solidFill>
-                  <a:srgbClr val="0E9F6E"/>
-                </a:solidFill>
-                <a:latin typeface="Segoe UI"/>
-              </a:rPr>
-              <a:t>2 · Does any of it sound machine-made?</a:t>
-            </a:r>
-          </a:p>
-          <a:p>
-            <a:r>
-              <a:rPr sz="1150" b="0">
+              <a:rPr sz="2000" b="1">
+                <a:solidFill>
+                  <a:srgbClr val="D6394B"/>
+                </a:solidFill>
+                <a:latin typeface="Segoe UI"/>
+              </a:rPr>
+              <a:t>A</a:t>
+            </a:r>
+          </a:p>
+        </p:txBody>
+      </p:sp>
+      <p:sp>
+        <p:nvSpPr>
+          <p:cNvPr id="16" name="TextBox 15"/>
+          <p:cNvSpPr txBox="1"/>
+          <p:nvPr/>
+        </p:nvSpPr>
+        <p:spPr>
+          <a:xfrm>
+            <a:off x="1307592" y="2843784"/>
+            <a:ext cx="3346703" cy="658368"/>
+          </a:xfrm>
+          <a:prstGeom prst="rect">
+            <a:avLst/>
+          </a:prstGeom>
+          <a:noFill/>
+        </p:spPr>
+        <p:txBody>
+          <a:bodyPr wrap="square">
+            <a:spAutoFit/>
+          </a:bodyPr>
+          <a:lstStyle/>
+          <a:p>
+            <a:pPr>
+              <a:spcAft>
+                <a:spcPts val="0"/>
+              </a:spcAft>
+            </a:pPr>
+            <a:r>
+              <a:rPr sz="1100" b="1">
+                <a:solidFill>
+                  <a:srgbClr val="0F1B2D"/>
+                </a:solidFill>
+                <a:latin typeface="Segoe UI"/>
+              </a:rPr>
+              <a:t>Clone of a DIFFERENT person's voice</a:t>
+            </a:r>
+          </a:p>
+          <a:p>
+            <a:pPr>
+              <a:spcAft>
+                <a:spcPts val="0"/>
+              </a:spcAft>
+            </a:pPr>
+            <a:r>
+              <a:rPr sz="1100" b="1">
+                <a:solidFill>
+                  <a:srgbClr val="0F1B2D"/>
+                </a:solidFill>
+                <a:latin typeface="Segoe UI"/>
+              </a:rPr>
+              <a:t>(cheap TTS, no impersonation)</a:t>
+            </a:r>
+          </a:p>
+        </p:txBody>
+      </p:sp>
+      <p:sp>
+        <p:nvSpPr>
+          <p:cNvPr id="17" name="TextBox 16"/>
+          <p:cNvSpPr txBox="1"/>
+          <p:nvPr/>
+        </p:nvSpPr>
+        <p:spPr>
+          <a:xfrm>
+            <a:off x="4782312" y="2843784"/>
+            <a:ext cx="2980944" cy="658368"/>
+          </a:xfrm>
+          <a:prstGeom prst="rect">
+            <a:avLst/>
+          </a:prstGeom>
+          <a:noFill/>
+        </p:spPr>
+        <p:txBody>
+          <a:bodyPr wrap="square">
+            <a:spAutoFit/>
+          </a:bodyPr>
+          <a:lstStyle/>
+          <a:p>
+            <a:pPr>
+              <a:spcAft>
+                <a:spcPts val="0"/>
+              </a:spcAft>
+            </a:pPr>
+            <a:r>
+              <a:rPr sz="1050" b="0">
                 <a:solidFill>
                   <a:srgbClr val="33415C"/>
                 </a:solidFill>
                 <a:latin typeface="Segoe UI"/>
               </a:rPr>
-              <a:t>Same AI scores every 4-second piece for generator artefacts — a same-voice clone can pass Q1 but not this.</a:t>
-            </a:r>
-          </a:p>
-        </p:txBody>
-      </p:sp>
-      <p:sp>
-        <p:nvSpPr>
-          <p:cNvPr id="12" name="Rounded Rectangle 11"/>
+              <a:t>similarity &lt; 0.53</a:t>
+            </a:r>
+          </a:p>
+        </p:txBody>
+      </p:sp>
+      <p:sp>
+        <p:nvSpPr>
+          <p:cNvPr id="18" name="TextBox 17"/>
+          <p:cNvSpPr txBox="1"/>
+          <p:nvPr/>
+        </p:nvSpPr>
+        <p:spPr>
+          <a:xfrm>
+            <a:off x="7891272" y="2843784"/>
+            <a:ext cx="2432303" cy="658368"/>
+          </a:xfrm>
+          <a:prstGeom prst="rect">
+            <a:avLst/>
+          </a:prstGeom>
+          <a:noFill/>
+        </p:spPr>
+        <p:txBody>
+          <a:bodyPr wrap="square">
+            <a:spAutoFit/>
+          </a:bodyPr>
+          <a:lstStyle/>
+          <a:p>
+            <a:pPr>
+              <a:spcAft>
+                <a:spcPts val="0"/>
+              </a:spcAft>
+            </a:pPr>
+            <a:r>
+              <a:rPr sz="1050" b="0">
+                <a:solidFill>
+                  <a:srgbClr val="33415C"/>
+                </a:solidFill>
+                <a:latin typeface="Segoe UI"/>
+              </a:rPr>
+              <a:t>Voice-fingerprint gate</a:t>
+            </a:r>
+          </a:p>
+        </p:txBody>
+      </p:sp>
+      <p:sp>
+        <p:nvSpPr>
+          <p:cNvPr id="19" name="TextBox 18"/>
+          <p:cNvSpPr txBox="1"/>
+          <p:nvPr/>
+        </p:nvSpPr>
+        <p:spPr>
+          <a:xfrm>
+            <a:off x="10451592" y="2843784"/>
+            <a:ext cx="1289304" cy="658368"/>
+          </a:xfrm>
+          <a:prstGeom prst="rect">
+            <a:avLst/>
+          </a:prstGeom>
+          <a:noFill/>
+        </p:spPr>
+        <p:txBody>
+          <a:bodyPr wrap="square">
+            <a:spAutoFit/>
+          </a:bodyPr>
+          <a:lstStyle/>
+          <a:p>
+            <a:pPr>
+              <a:spcAft>
+                <a:spcPts val="0"/>
+              </a:spcAft>
+            </a:pPr>
+            <a:r>
+              <a:rPr sz="1100" b="1">
+                <a:solidFill>
+                  <a:srgbClr val="D6394B"/>
+                </a:solidFill>
+                <a:latin typeface="Segoe UI"/>
+              </a:rPr>
+              <a:t>HOLD</a:t>
+            </a:r>
+          </a:p>
+        </p:txBody>
+      </p:sp>
+      <p:sp>
+        <p:nvSpPr>
+          <p:cNvPr id="20" name="Rectangle 19"/>
           <p:cNvSpPr/>
           <p:nvPr/>
         </p:nvSpPr>
         <p:spPr>
           <a:xfrm>
-            <a:off x="640080" y="3977639"/>
-            <a:ext cx="5440680" cy="1261872"/>
-          </a:xfrm>
-          <a:prstGeom prst="roundRect">
+            <a:off x="640080" y="3547872"/>
+            <a:ext cx="11201400" cy="713231"/>
+          </a:xfrm>
+          <a:prstGeom prst="rect">
             <a:avLst/>
           </a:prstGeom>
           <a:solidFill>
-            <a:srgbClr val="F2F6FB"/>
+            <a:srgbClr val="E7EEF6"/>
           </a:solidFill>
           <a:ln w="9525">
             <a:solidFill>
@@ -4653,14 +4919,14 @@
       </p:sp>
       <p:sp>
         <p:nvSpPr>
-          <p:cNvPr id="13" name="TextBox 12"/>
+          <p:cNvPr id="21" name="TextBox 20"/>
           <p:cNvSpPr txBox="1"/>
           <p:nvPr/>
         </p:nvSpPr>
         <p:spPr>
           <a:xfrm>
-            <a:off x="804671" y="4059935"/>
-            <a:ext cx="5111496" cy="1097280"/>
+            <a:off x="768096" y="3712463"/>
+            <a:ext cx="548640" cy="365760"/>
           </a:xfrm>
           <a:prstGeom prst="rect">
             <a:avLst/>
@@ -4674,40 +4940,233 @@
           <a:lstStyle/>
           <a:p>
             <a:r>
-              <a:rPr sz="1450" b="1">
-                <a:solidFill>
-                  <a:srgbClr val="C88600"/>
-                </a:solidFill>
-                <a:latin typeface="Segoe UI"/>
-              </a:rPr>
-              <a:t>3 · Does the room sound real?</a:t>
-            </a:r>
-          </a:p>
-          <a:p>
-            <a:r>
-              <a:rPr sz="1150" b="0">
+              <a:rPr sz="2000" b="1">
+                <a:solidFill>
+                  <a:srgbClr val="D6394B"/>
+                </a:solidFill>
+                <a:latin typeface="Segoe UI"/>
+              </a:rPr>
+              <a:t>B</a:t>
+            </a:r>
+          </a:p>
+        </p:txBody>
+      </p:sp>
+      <p:sp>
+        <p:nvSpPr>
+          <p:cNvPr id="22" name="TextBox 21"/>
+          <p:cNvSpPr txBox="1"/>
+          <p:nvPr/>
+        </p:nvSpPr>
+        <p:spPr>
+          <a:xfrm>
+            <a:off x="1307592" y="3593591"/>
+            <a:ext cx="3346703" cy="658368"/>
+          </a:xfrm>
+          <a:prstGeom prst="rect">
+            <a:avLst/>
+          </a:prstGeom>
+          <a:noFill/>
+        </p:spPr>
+        <p:txBody>
+          <a:bodyPr wrap="square">
+            <a:spAutoFit/>
+          </a:bodyPr>
+          <a:lstStyle/>
+          <a:p>
+            <a:pPr>
+              <a:spcAft>
+                <a:spcPts val="0"/>
+              </a:spcAft>
+            </a:pPr>
+            <a:r>
+              <a:rPr sz="1100" b="1">
+                <a:solidFill>
+                  <a:srgbClr val="0F1B2D"/>
+                </a:solidFill>
+                <a:latin typeface="Segoe UI"/>
+              </a:rPr>
+              <a:t>Same tool, same-agent-timbre clone</a:t>
+            </a:r>
+          </a:p>
+          <a:p>
+            <a:pPr>
+              <a:spcAft>
+                <a:spcPts val="0"/>
+              </a:spcAft>
+            </a:pPr>
+            <a:r>
+              <a:rPr sz="1100" b="1">
+                <a:solidFill>
+                  <a:srgbClr val="0F1B2D"/>
+                </a:solidFill>
+                <a:latin typeface="Segoe UI"/>
+              </a:rPr>
+              <a:t>(our Call 2 / 3 scenario)</a:t>
+            </a:r>
+          </a:p>
+        </p:txBody>
+      </p:sp>
+      <p:sp>
+        <p:nvSpPr>
+          <p:cNvPr id="23" name="TextBox 22"/>
+          <p:cNvSpPr txBox="1"/>
+          <p:nvPr/>
+        </p:nvSpPr>
+        <p:spPr>
+          <a:xfrm>
+            <a:off x="4782312" y="3593591"/>
+            <a:ext cx="2980944" cy="658368"/>
+          </a:xfrm>
+          <a:prstGeom prst="rect">
+            <a:avLst/>
+          </a:prstGeom>
+          <a:noFill/>
+        </p:spPr>
+        <p:txBody>
+          <a:bodyPr wrap="square">
+            <a:spAutoFit/>
+          </a:bodyPr>
+          <a:lstStyle/>
+          <a:p>
+            <a:pPr>
+              <a:spcAft>
+                <a:spcPts val="0"/>
+              </a:spcAft>
+            </a:pPr>
+            <a:r>
+              <a:rPr sz="1050" b="0">
                 <a:solidFill>
                   <a:srgbClr val="33415C"/>
                 </a:solidFill>
                 <a:latin typeface="Segoe UI"/>
               </a:rPr>
-              <a:t>Forensics checks for a real acoustic room. A pure digital render has none — that is an escalation only.</a:t>
-            </a:r>
-          </a:p>
-        </p:txBody>
-      </p:sp>
-      <p:sp>
-        <p:nvSpPr>
-          <p:cNvPr id="14" name="Rounded Rectangle 13"/>
+              <a:t>Fingerprint MAY PASS — same timbre!</a:t>
+            </a:r>
+          </a:p>
+          <a:p>
+            <a:pPr>
+              <a:spcAft>
+                <a:spcPts val="0"/>
+              </a:spcAft>
+            </a:pPr>
+            <a:r>
+              <a:rPr sz="1050" b="0">
+                <a:solidFill>
+                  <a:srgbClr val="33415C"/>
+                </a:solidFill>
+                <a:latin typeface="Segoe UI"/>
+              </a:rPr>
+              <a:t>but each 4-s segment scores 0.99 synthetic</a:t>
+            </a:r>
+          </a:p>
+        </p:txBody>
+      </p:sp>
+      <p:sp>
+        <p:nvSpPr>
+          <p:cNvPr id="24" name="TextBox 23"/>
+          <p:cNvSpPr txBox="1"/>
+          <p:nvPr/>
+        </p:nvSpPr>
+        <p:spPr>
+          <a:xfrm>
+            <a:off x="7891272" y="3593591"/>
+            <a:ext cx="2432303" cy="658368"/>
+          </a:xfrm>
+          <a:prstGeom prst="rect">
+            <a:avLst/>
+          </a:prstGeom>
+          <a:noFill/>
+        </p:spPr>
+        <p:txBody>
+          <a:bodyPr wrap="square">
+            <a:spAutoFit/>
+          </a:bodyPr>
+          <a:lstStyle/>
+          <a:p>
+            <a:pPr>
+              <a:spcAft>
+                <a:spcPts val="0"/>
+              </a:spcAft>
+            </a:pPr>
+            <a:r>
+              <a:rPr sz="1050" b="0">
+                <a:solidFill>
+                  <a:srgbClr val="33415C"/>
+                </a:solidFill>
+                <a:latin typeface="Segoe UI"/>
+              </a:rPr>
+              <a:t>Hot-segment rule (any slice ≥ 0.90)</a:t>
+            </a:r>
+          </a:p>
+        </p:txBody>
+      </p:sp>
+      <p:sp>
+        <p:nvSpPr>
+          <p:cNvPr id="25" name="TextBox 24"/>
+          <p:cNvSpPr txBox="1"/>
+          <p:nvPr/>
+        </p:nvSpPr>
+        <p:spPr>
+          <a:xfrm>
+            <a:off x="10451592" y="3593591"/>
+            <a:ext cx="1289304" cy="658368"/>
+          </a:xfrm>
+          <a:prstGeom prst="rect">
+            <a:avLst/>
+          </a:prstGeom>
+          <a:noFill/>
+        </p:spPr>
+        <p:txBody>
+          <a:bodyPr wrap="square">
+            <a:spAutoFit/>
+          </a:bodyPr>
+          <a:lstStyle/>
+          <a:p>
+            <a:pPr>
+              <a:spcAft>
+                <a:spcPts val="0"/>
+              </a:spcAft>
+            </a:pPr>
+            <a:r>
+              <a:rPr sz="1100" b="1">
+                <a:solidFill>
+                  <a:srgbClr val="D6394B"/>
+                </a:solidFill>
+                <a:latin typeface="Segoe UI"/>
+              </a:rPr>
+              <a:t>HOLD</a:t>
+            </a:r>
+          </a:p>
+          <a:p>
+            <a:pPr>
+              <a:spcAft>
+                <a:spcPts val="0"/>
+              </a:spcAft>
+            </a:pPr>
+            <a:r>
+              <a:rPr sz="1100" b="1">
+                <a:solidFill>
+                  <a:srgbClr val="D6394B"/>
+                </a:solidFill>
+                <a:latin typeface="Segoe UI"/>
+              </a:rPr>
+              <a:t>(average said "real")</a:t>
+            </a:r>
+          </a:p>
+        </p:txBody>
+      </p:sp>
+      <p:sp>
+        <p:nvSpPr>
+          <p:cNvPr id="26" name="Rectangle 25"/>
           <p:cNvSpPr/>
           <p:nvPr/>
         </p:nvSpPr>
         <p:spPr>
           <a:xfrm>
-            <a:off x="6217920" y="3977639"/>
-            <a:ext cx="5440680" cy="1261872"/>
-          </a:xfrm>
-          <a:prstGeom prst="roundRect">
+            <a:off x="640080" y="4297680"/>
+            <a:ext cx="11201400" cy="713231"/>
+          </a:xfrm>
+          <a:prstGeom prst="rect">
             <a:avLst/>
           </a:prstGeom>
           <a:solidFill>
@@ -4744,14 +5203,14 @@
       </p:sp>
       <p:sp>
         <p:nvSpPr>
-          <p:cNvPr id="15" name="TextBox 14"/>
+          <p:cNvPr id="27" name="TextBox 26"/>
           <p:cNvSpPr txBox="1"/>
           <p:nvPr/>
         </p:nvSpPr>
         <p:spPr>
           <a:xfrm>
-            <a:off x="6382512" y="4059935"/>
-            <a:ext cx="5111496" cy="1097280"/>
+            <a:off x="768096" y="4462272"/>
+            <a:ext cx="548640" cy="365760"/>
           </a:xfrm>
           <a:prstGeom prst="rect">
             <a:avLst/>
@@ -4765,38 +5224,27 @@
           <a:lstStyle/>
           <a:p>
             <a:r>
-              <a:rPr sz="1450" b="1">
-                <a:solidFill>
-                  <a:srgbClr val="D6394B"/>
-                </a:solidFill>
-                <a:latin typeface="Segoe UI"/>
-              </a:rPr>
-              <a:t>4 · Is it being replayed?</a:t>
-            </a:r>
-          </a:p>
-          <a:p>
-            <a:r>
-              <a:rPr sz="1150" b="0">
-                <a:solidFill>
-                  <a:srgbClr val="33415C"/>
-                </a:solidFill>
-                <a:latin typeface="Segoe UI"/>
-              </a:rPr>
-              <a:t>Identical audio arriving twice is a recording being re-run, not a live call — blocked on the spot.</a:t>
-            </a:r>
-          </a:p>
-        </p:txBody>
-      </p:sp>
-      <p:sp>
-        <p:nvSpPr>
-          <p:cNvPr id="16" name="TextBox 15"/>
+              <a:rPr sz="2000" b="1">
+                <a:solidFill>
+                  <a:srgbClr val="C88600"/>
+                </a:solidFill>
+                <a:latin typeface="Segoe UI"/>
+              </a:rPr>
+              <a:t>C</a:t>
+            </a:r>
+          </a:p>
+        </p:txBody>
+      </p:sp>
+      <p:sp>
+        <p:nvSpPr>
+          <p:cNvPr id="28" name="TextBox 27"/>
           <p:cNvSpPr txBox="1"/>
           <p:nvPr/>
         </p:nvSpPr>
         <p:spPr>
           <a:xfrm>
-            <a:off x="640080" y="5074920"/>
-            <a:ext cx="10972800" cy="274320"/>
+            <a:off x="1307592" y="4343400"/>
+            <a:ext cx="3346703" cy="658368"/>
           </a:xfrm>
           <a:prstGeom prst="rect">
             <a:avLst/>
@@ -4809,34 +5257,188 @@
           </a:bodyPr>
           <a:lstStyle/>
           <a:p>
-            <a:r>
-              <a:rPr sz="1200" b="1">
+            <a:pPr>
+              <a:spcAft>
+                <a:spcPts val="0"/>
+              </a:spcAft>
+            </a:pPr>
+            <a:r>
+              <a:rPr sz="1100" b="1">
                 <a:solidFill>
                   <a:srgbClr val="0F1B2D"/>
                 </a:solidFill>
                 <a:latin typeface="Segoe UI"/>
               </a:rPr>
-              <a:t>Four real attacker variants — and which layer bites each one:</a:t>
-            </a:r>
-          </a:p>
-        </p:txBody>
-      </p:sp>
-      <p:sp>
-        <p:nvSpPr>
-          <p:cNvPr id="17" name="Rectangle 16"/>
+              <a:t>Clone that also fools the deepfake</a:t>
+            </a:r>
+          </a:p>
+          <a:p>
+            <a:pPr>
+              <a:spcAft>
+                <a:spcPts val="0"/>
+              </a:spcAft>
+            </a:pPr>
+            <a:r>
+              <a:rPr sz="1100" b="1">
+                <a:solidFill>
+                  <a:srgbClr val="0F1B2D"/>
+                </a:solidFill>
+                <a:latin typeface="Segoe UI"/>
+              </a:rPr>
+              <a:t>(newer engine, unseen in training)</a:t>
+            </a:r>
+          </a:p>
+        </p:txBody>
+      </p:sp>
+      <p:sp>
+        <p:nvSpPr>
+          <p:cNvPr id="29" name="TextBox 28"/>
+          <p:cNvSpPr txBox="1"/>
+          <p:nvPr/>
+        </p:nvSpPr>
+        <p:spPr>
+          <a:xfrm>
+            <a:off x="4782312" y="4343400"/>
+            <a:ext cx="2980944" cy="658368"/>
+          </a:xfrm>
+          <a:prstGeom prst="rect">
+            <a:avLst/>
+          </a:prstGeom>
+          <a:noFill/>
+        </p:spPr>
+        <p:txBody>
+          <a:bodyPr wrap="square">
+            <a:spAutoFit/>
+          </a:bodyPr>
+          <a:lstStyle/>
+          <a:p>
+            <a:pPr>
+              <a:spcAft>
+                <a:spcPts val="0"/>
+              </a:spcAft>
+            </a:pPr>
+            <a:r>
+              <a:rPr sz="1050" b="0">
+                <a:solidFill>
+                  <a:srgbClr val="33415C"/>
+                </a:solidFill>
+                <a:latin typeface="Segoe UI"/>
+              </a:rPr>
+              <a:t>Deepfake score low, similarity high</a:t>
+            </a:r>
+          </a:p>
+        </p:txBody>
+      </p:sp>
+      <p:sp>
+        <p:nvSpPr>
+          <p:cNvPr id="30" name="TextBox 29"/>
+          <p:cNvSpPr txBox="1"/>
+          <p:nvPr/>
+        </p:nvSpPr>
+        <p:spPr>
+          <a:xfrm>
+            <a:off x="7891272" y="4343400"/>
+            <a:ext cx="2432303" cy="658368"/>
+          </a:xfrm>
+          <a:prstGeom prst="rect">
+            <a:avLst/>
+          </a:prstGeom>
+          <a:noFill/>
+        </p:spPr>
+        <p:txBody>
+          <a:bodyPr wrap="square">
+            <a:spAutoFit/>
+          </a:bodyPr>
+          <a:lstStyle/>
+          <a:p>
+            <a:pPr>
+              <a:spcAft>
+                <a:spcPts val="0"/>
+              </a:spcAft>
+            </a:pPr>
+            <a:r>
+              <a:rPr sz="1050" b="0">
+                <a:solidFill>
+                  <a:srgbClr val="33415C"/>
+                </a:solidFill>
+                <a:latin typeface="Segoe UI"/>
+              </a:rPr>
+              <a:t>Forensics: digital render → no room tone → artifact ≥ 0.85</a:t>
+            </a:r>
+          </a:p>
+        </p:txBody>
+      </p:sp>
+      <p:sp>
+        <p:nvSpPr>
+          <p:cNvPr id="31" name="TextBox 30"/>
+          <p:cNvSpPr txBox="1"/>
+          <p:nvPr/>
+        </p:nvSpPr>
+        <p:spPr>
+          <a:xfrm>
+            <a:off x="10451592" y="4343400"/>
+            <a:ext cx="1289304" cy="658368"/>
+          </a:xfrm>
+          <a:prstGeom prst="rect">
+            <a:avLst/>
+          </a:prstGeom>
+          <a:noFill/>
+        </p:spPr>
+        <p:txBody>
+          <a:bodyPr wrap="square">
+            <a:spAutoFit/>
+          </a:bodyPr>
+          <a:lstStyle/>
+          <a:p>
+            <a:pPr>
+              <a:spcAft>
+                <a:spcPts val="0"/>
+              </a:spcAft>
+            </a:pPr>
+            <a:r>
+              <a:rPr sz="1100" b="1">
+                <a:solidFill>
+                  <a:srgbClr val="C88600"/>
+                </a:solidFill>
+                <a:latin typeface="Segoe UI"/>
+              </a:rPr>
+              <a:t>STEP-UP</a:t>
+            </a:r>
+          </a:p>
+          <a:p>
+            <a:pPr>
+              <a:spcAft>
+                <a:spcPts val="0"/>
+              </a:spcAft>
+            </a:pPr>
+            <a:r>
+              <a:rPr sz="1100" b="1">
+                <a:solidFill>
+                  <a:srgbClr val="C88600"/>
+                </a:solidFill>
+                <a:latin typeface="Segoe UI"/>
+              </a:rPr>
+              <a:t>(never auto-approve)</a:t>
+            </a:r>
+          </a:p>
+        </p:txBody>
+      </p:sp>
+      <p:sp>
+        <p:nvSpPr>
+          <p:cNvPr id="32" name="Rectangle 31"/>
           <p:cNvSpPr/>
           <p:nvPr/>
         </p:nvSpPr>
         <p:spPr>
           <a:xfrm>
-            <a:off x="640080" y="5413248"/>
-            <a:ext cx="10972800" cy="242316"/>
+            <a:off x="640080" y="5047488"/>
+            <a:ext cx="11201400" cy="713231"/>
           </a:xfrm>
           <a:prstGeom prst="rect">
             <a:avLst/>
           </a:prstGeom>
           <a:solidFill>
-            <a:srgbClr val="F2F6FB"/>
+            <a:srgbClr val="E7EEF6"/>
           </a:solidFill>
           <a:ln w="9525">
             <a:solidFill>
@@ -4869,14 +5471,48 @@
       </p:sp>
       <p:sp>
         <p:nvSpPr>
-          <p:cNvPr id="18" name="TextBox 17"/>
+          <p:cNvPr id="33" name="TextBox 32"/>
           <p:cNvSpPr txBox="1"/>
           <p:nvPr/>
         </p:nvSpPr>
         <p:spPr>
           <a:xfrm>
-            <a:off x="694944" y="5422392"/>
-            <a:ext cx="2084831" cy="251459"/>
+            <a:off x="768096" y="5212079"/>
+            <a:ext cx="548640" cy="365760"/>
+          </a:xfrm>
+          <a:prstGeom prst="rect">
+            <a:avLst/>
+          </a:prstGeom>
+          <a:noFill/>
+        </p:spPr>
+        <p:txBody>
+          <a:bodyPr wrap="square">
+            <a:spAutoFit/>
+          </a:bodyPr>
+          <a:lstStyle/>
+          <a:p>
+            <a:r>
+              <a:rPr sz="2000" b="1">
+                <a:solidFill>
+                  <a:srgbClr val="D6394B"/>
+                </a:solidFill>
+                <a:latin typeface="Segoe UI"/>
+              </a:rPr>
+              <a:t>D</a:t>
+            </a:r>
+          </a:p>
+        </p:txBody>
+      </p:sp>
+      <p:sp>
+        <p:nvSpPr>
+          <p:cNvPr id="34" name="TextBox 33"/>
+          <p:cNvSpPr txBox="1"/>
+          <p:nvPr/>
+        </p:nvSpPr>
+        <p:spPr>
+          <a:xfrm>
+            <a:off x="1307592" y="5093207"/>
+            <a:ext cx="3346703" cy="658368"/>
           </a:xfrm>
           <a:prstGeom prst="rect">
             <a:avLst/>
@@ -4901,32 +5537,9 @@
                 </a:solidFill>
                 <a:latin typeface="Segoe UI"/>
               </a:rPr>
-              <a:t>A · Different voice clone</a:t>
-            </a:r>
-          </a:p>
-        </p:txBody>
-      </p:sp>
-      <p:sp>
-        <p:nvSpPr>
-          <p:cNvPr id="19" name="TextBox 18"/>
-          <p:cNvSpPr txBox="1"/>
-          <p:nvPr/>
-        </p:nvSpPr>
-        <p:spPr>
-          <a:xfrm>
-            <a:off x="2935224" y="5422392"/>
-            <a:ext cx="3273552" cy="251459"/>
-          </a:xfrm>
-          <a:prstGeom prst="rect">
-            <a:avLst/>
-          </a:prstGeom>
-          <a:noFill/>
-        </p:spPr>
-        <p:txBody>
-          <a:bodyPr wrap="square">
-            <a:spAutoFit/>
-          </a:bodyPr>
-          <a:lstStyle/>
+              <a:t>Replay of the agent's REAL</a:t>
+            </a:r>
+          </a:p>
           <a:p>
             <a:pPr>
               <a:spcAft>
@@ -4934,27 +5547,27 @@
               </a:spcAft>
             </a:pPr>
             <a:r>
-              <a:rPr sz="1050" b="0">
-                <a:solidFill>
-                  <a:srgbClr val="33415C"/>
-                </a:solidFill>
-                <a:latin typeface="Segoe UI"/>
-              </a:rPr>
-              <a:t>Downtown, cheap TTS clone of another person.</a:t>
-            </a:r>
-          </a:p>
-        </p:txBody>
-      </p:sp>
-      <p:sp>
-        <p:nvSpPr>
-          <p:cNvPr id="20" name="TextBox 19"/>
+              <a:rPr sz="1100" b="1">
+                <a:solidFill>
+                  <a:srgbClr val="0F1B2D"/>
+                </a:solidFill>
+                <a:latin typeface="Segoe UI"/>
+              </a:rPr>
+              <a:t>recorded audio</a:t>
+            </a:r>
+          </a:p>
+        </p:txBody>
+      </p:sp>
+      <p:sp>
+        <p:nvSpPr>
+          <p:cNvPr id="35" name="TextBox 34"/>
           <p:cNvSpPr txBox="1"/>
           <p:nvPr/>
         </p:nvSpPr>
         <p:spPr>
           <a:xfrm>
-            <a:off x="6318503" y="5422392"/>
-            <a:ext cx="3182112" cy="251459"/>
+            <a:off x="4782312" y="5093207"/>
+            <a:ext cx="2980944" cy="658368"/>
           </a:xfrm>
           <a:prstGeom prst="rect">
             <a:avLst/>
@@ -4979,106 +5592,21 @@
                 </a:solidFill>
                 <a:latin typeface="Segoe UI"/>
               </a:rPr>
-              <a:t>fingerprint fails (similarity &lt; 0.53)</a:t>
-            </a:r>
-          </a:p>
-        </p:txBody>
-      </p:sp>
-      <p:sp>
-        <p:nvSpPr>
-          <p:cNvPr id="21" name="TextBox 20"/>
+              <a:t>Everything passes — nothing new to detect</a:t>
+            </a:r>
+          </a:p>
+        </p:txBody>
+      </p:sp>
+      <p:sp>
+        <p:nvSpPr>
+          <p:cNvPr id="36" name="TextBox 35"/>
           <p:cNvSpPr txBox="1"/>
           <p:nvPr/>
         </p:nvSpPr>
         <p:spPr>
           <a:xfrm>
-            <a:off x="9610344" y="5422392"/>
-            <a:ext cx="1993391" cy="251459"/>
-          </a:xfrm>
-          <a:prstGeom prst="rect">
-            <a:avLst/>
-          </a:prstGeom>
-          <a:noFill/>
-        </p:spPr>
-        <p:txBody>
-          <a:bodyPr wrap="square">
-            <a:spAutoFit/>
-          </a:bodyPr>
-          <a:lstStyle/>
-          <a:p>
-            <a:pPr algn="l">
-              <a:spcAft>
-                <a:spcPts val="0"/>
-              </a:spcAft>
-            </a:pPr>
-            <a:r>
-              <a:rPr sz="1050" b="1">
-                <a:solidFill>
-                  <a:srgbClr val="D6394B"/>
-                </a:solidFill>
-                <a:latin typeface="Segoe UI"/>
-              </a:rPr>
-              <a:t>RED HOLD</a:t>
-            </a:r>
-          </a:p>
-        </p:txBody>
-      </p:sp>
-      <p:sp>
-        <p:nvSpPr>
-          <p:cNvPr id="22" name="Rectangle 21"/>
-          <p:cNvSpPr/>
-          <p:nvPr/>
-        </p:nvSpPr>
-        <p:spPr>
-          <a:xfrm>
-            <a:off x="640080" y="5682996"/>
-            <a:ext cx="10972800" cy="242316"/>
-          </a:xfrm>
-          <a:prstGeom prst="rect">
-            <a:avLst/>
-          </a:prstGeom>
-          <a:solidFill>
-            <a:srgbClr val="E7EEF6"/>
-          </a:solidFill>
-          <a:ln w="9525">
-            <a:solidFill>
-              <a:srgbClr val="D3DEEE"/>
-            </a:solidFill>
-          </a:ln>
-          <a:effectLst/>
-        </p:spPr>
-        <p:style>
-          <a:lnRef idx="1">
-            <a:schemeClr val="accent1"/>
-          </a:lnRef>
-          <a:fillRef idx="3">
-            <a:schemeClr val="accent1"/>
-          </a:fillRef>
-          <a:effectRef idx="2">
-            <a:schemeClr val="accent1"/>
-          </a:effectRef>
-          <a:fontRef idx="minor">
-            <a:schemeClr val="lt1"/>
-          </a:fontRef>
-        </p:style>
-        <p:txBody>
-          <a:bodyPr rtlCol="0" anchor="ctr"/>
-          <a:lstStyle/>
-          <a:p>
-            <a:pPr algn="ctr"/>
-          </a:p>
-        </p:txBody>
-      </p:sp>
-      <p:sp>
-        <p:nvSpPr>
-          <p:cNvPr id="23" name="TextBox 22"/>
-          <p:cNvSpPr txBox="1"/>
-          <p:nvPr/>
-        </p:nvSpPr>
-        <p:spPr>
-          <a:xfrm>
-            <a:off x="694944" y="5692140"/>
-            <a:ext cx="2084831" cy="251459"/>
+            <a:off x="7891272" y="5093207"/>
+            <a:ext cx="2432303" cy="658368"/>
           </a:xfrm>
           <a:prstGeom prst="rect">
             <a:avLst/>
@@ -5097,27 +5625,27 @@
               </a:spcAft>
             </a:pPr>
             <a:r>
-              <a:rPr sz="1100" b="1">
-                <a:solidFill>
-                  <a:srgbClr val="0F1B2D"/>
-                </a:solidFill>
-                <a:latin typeface="Segoe UI"/>
-              </a:rPr>
-              <a:t>B · Same-voice clone (our Call 2 / 3)</a:t>
-            </a:r>
-          </a:p>
-        </p:txBody>
-      </p:sp>
-      <p:sp>
-        <p:nvSpPr>
-          <p:cNvPr id="24" name="TextBox 23"/>
+              <a:rPr sz="1050" b="0">
+                <a:solidFill>
+                  <a:srgbClr val="33415C"/>
+                </a:solidFill>
+                <a:latin typeface="Segoe UI"/>
+              </a:rPr>
+              <a:t>Content fingerprint: identical audio re-sent</a:t>
+            </a:r>
+          </a:p>
+        </p:txBody>
+      </p:sp>
+      <p:sp>
+        <p:nvSpPr>
+          <p:cNvPr id="37" name="TextBox 36"/>
           <p:cNvSpPr txBox="1"/>
           <p:nvPr/>
         </p:nvSpPr>
         <p:spPr>
           <a:xfrm>
-            <a:off x="2935224" y="5692140"/>
-            <a:ext cx="3273552" cy="251459"/>
+            <a:off x="10451592" y="5093207"/>
+            <a:ext cx="1289304" cy="658368"/>
           </a:xfrm>
           <a:prstGeom prst="rect">
             <a:avLst/>
@@ -5136,27 +5664,27 @@
               </a:spcAft>
             </a:pPr>
             <a:r>
-              <a:rPr sz="1050" b="0">
-                <a:solidFill>
-                  <a:srgbClr val="33415C"/>
-                </a:solidFill>
-                <a:latin typeface="Segoe UI"/>
-              </a:rPr>
-              <a:t>Same tool, only the agent's timbre.</a:t>
-            </a:r>
-          </a:p>
-        </p:txBody>
-      </p:sp>
-      <p:sp>
-        <p:nvSpPr>
-          <p:cNvPr id="25" name="TextBox 24"/>
+              <a:rPr sz="1100" b="1">
+                <a:solidFill>
+                  <a:srgbClr val="D6394B"/>
+                </a:solidFill>
+                <a:latin typeface="Segoe UI"/>
+              </a:rPr>
+              <a:t>HOLD</a:t>
+            </a:r>
+          </a:p>
+        </p:txBody>
+      </p:sp>
+      <p:sp>
+        <p:nvSpPr>
+          <p:cNvPr id="38" name="TextBox 37"/>
           <p:cNvSpPr txBox="1"/>
           <p:nvPr/>
         </p:nvSpPr>
         <p:spPr>
           <a:xfrm>
-            <a:off x="6318503" y="5692140"/>
-            <a:ext cx="3182112" cy="251459"/>
+            <a:off x="640080" y="5843016"/>
+            <a:ext cx="11201400" cy="457200"/>
           </a:xfrm>
           <a:prstGeom prst="rect">
             <a:avLst/>
@@ -5169,462 +5697,23 @@
           </a:bodyPr>
           <a:lstStyle/>
           <a:p>
-            <a:pPr>
-              <a:spcAft>
-                <a:spcPts val="0"/>
-              </a:spcAft>
-            </a:pPr>
-            <a:r>
-              <a:rPr sz="1050" b="0">
+            <a:r>
+              <a:rPr sz="1250" b="1">
+                <a:solidFill>
+                  <a:srgbClr val="0F1B2D"/>
+                </a:solidFill>
+                <a:latin typeface="Segoe UI"/>
+              </a:rPr>
+              <a:t>Layer principle:</a:t>
+            </a:r>
+            <a:r>
+              <a:rPr sz="1250" b="0">
                 <a:solidFill>
                   <a:srgbClr val="33415C"/>
                 </a:solidFill>
                 <a:latin typeface="Segoe UI"/>
               </a:rPr>
-              <a:t>fingerprint may pass, but deepfake flags machine artefacts per 4-s slice; one hot &gt;= 0.90 holds</a:t>
-            </a:r>
-          </a:p>
-        </p:txBody>
-      </p:sp>
-      <p:sp>
-        <p:nvSpPr>
-          <p:cNvPr id="26" name="TextBox 25"/>
-          <p:cNvSpPr txBox="1"/>
-          <p:nvPr/>
-        </p:nvSpPr>
-        <p:spPr>
-          <a:xfrm>
-            <a:off x="9610344" y="5692140"/>
-            <a:ext cx="1993391" cy="251459"/>
-          </a:xfrm>
-          <a:prstGeom prst="rect">
-            <a:avLst/>
-          </a:prstGeom>
-          <a:noFill/>
-        </p:spPr>
-        <p:txBody>
-          <a:bodyPr wrap="square">
-            <a:spAutoFit/>
-          </a:bodyPr>
-          <a:lstStyle/>
-          <a:p>
-            <a:pPr algn="l">
-              <a:spcAft>
-                <a:spcPts val="0"/>
-              </a:spcAft>
-            </a:pPr>
-            <a:r>
-              <a:rPr sz="1050" b="1">
-                <a:solidFill>
-                  <a:srgbClr val="D6394B"/>
-                </a:solidFill>
-                <a:latin typeface="Segoe UI"/>
-              </a:rPr>
-              <a:t>RED HOLD</a:t>
-            </a:r>
-          </a:p>
-        </p:txBody>
-      </p:sp>
-      <p:sp>
-        <p:nvSpPr>
-          <p:cNvPr id="27" name="Rectangle 26"/>
-          <p:cNvSpPr/>
-          <p:nvPr/>
-        </p:nvSpPr>
-        <p:spPr>
-          <a:xfrm>
-            <a:off x="640080" y="5952744"/>
-            <a:ext cx="10972800" cy="242316"/>
-          </a:xfrm>
-          <a:prstGeom prst="rect">
-            <a:avLst/>
-          </a:prstGeom>
-          <a:solidFill>
-            <a:srgbClr val="F2F6FB"/>
-          </a:solidFill>
-          <a:ln w="9525">
-            <a:solidFill>
-              <a:srgbClr val="D3DEEE"/>
-            </a:solidFill>
-          </a:ln>
-          <a:effectLst/>
-        </p:spPr>
-        <p:style>
-          <a:lnRef idx="1">
-            <a:schemeClr val="accent1"/>
-          </a:lnRef>
-          <a:fillRef idx="3">
-            <a:schemeClr val="accent1"/>
-          </a:fillRef>
-          <a:effectRef idx="2">
-            <a:schemeClr val="accent1"/>
-          </a:effectRef>
-          <a:fontRef idx="minor">
-            <a:schemeClr val="lt1"/>
-          </a:fontRef>
-        </p:style>
-        <p:txBody>
-          <a:bodyPr rtlCol="0" anchor="ctr"/>
-          <a:lstStyle/>
-          <a:p>
-            <a:pPr algn="ctr"/>
-          </a:p>
-        </p:txBody>
-      </p:sp>
-      <p:sp>
-        <p:nvSpPr>
-          <p:cNvPr id="28" name="TextBox 27"/>
-          <p:cNvSpPr txBox="1"/>
-          <p:nvPr/>
-        </p:nvSpPr>
-        <p:spPr>
-          <a:xfrm>
-            <a:off x="694944" y="5961888"/>
-            <a:ext cx="2084831" cy="251459"/>
-          </a:xfrm>
-          <a:prstGeom prst="rect">
-            <a:avLst/>
-          </a:prstGeom>
-          <a:noFill/>
-        </p:spPr>
-        <p:txBody>
-          <a:bodyPr wrap="square">
-            <a:spAutoFit/>
-          </a:bodyPr>
-          <a:lstStyle/>
-          <a:p>
-            <a:pPr>
-              <a:spcAft>
-                <a:spcPts val="0"/>
-              </a:spcAft>
-            </a:pPr>
-            <a:r>
-              <a:rPr sz="1100" b="1">
-                <a:solidFill>
-                  <a:srgbClr val="0F1B2D"/>
-                </a:solidFill>
-                <a:latin typeface="Segoe UI"/>
-              </a:rPr>
-              <a:t>C · Clone that also fools deepfake</a:t>
-            </a:r>
-          </a:p>
-        </p:txBody>
-      </p:sp>
-      <p:sp>
-        <p:nvSpPr>
-          <p:cNvPr id="29" name="TextBox 28"/>
-          <p:cNvSpPr txBox="1"/>
-          <p:nvPr/>
-        </p:nvSpPr>
-        <p:spPr>
-          <a:xfrm>
-            <a:off x="2935224" y="5961888"/>
-            <a:ext cx="3273552" cy="251459"/>
-          </a:xfrm>
-          <a:prstGeom prst="rect">
-            <a:avLst/>
-          </a:prstGeom>
-          <a:noFill/>
-        </p:spPr>
-        <p:txBody>
-          <a:bodyPr wrap="square">
-            <a:spAutoFit/>
-          </a:bodyPr>
-          <a:lstStyle/>
-          <a:p>
-            <a:pPr>
-              <a:spcAft>
-                <a:spcPts val="0"/>
-              </a:spcAft>
-            </a:pPr>
-            <a:r>
-              <a:rPr sz="1050" b="0">
-                <a:solidFill>
-                  <a:srgbClr val="33415C"/>
-                </a:solidFill>
-                <a:latin typeface="Segoe UI"/>
-              </a:rPr>
-              <a:t>Newer engine unseen in training; deepfake low, similarity high.</a:t>
-            </a:r>
-          </a:p>
-        </p:txBody>
-      </p:sp>
-      <p:sp>
-        <p:nvSpPr>
-          <p:cNvPr id="30" name="TextBox 29"/>
-          <p:cNvSpPr txBox="1"/>
-          <p:nvPr/>
-        </p:nvSpPr>
-        <p:spPr>
-          <a:xfrm>
-            <a:off x="6318503" y="5961888"/>
-            <a:ext cx="3182112" cy="251459"/>
-          </a:xfrm>
-          <a:prstGeom prst="rect">
-            <a:avLst/>
-          </a:prstGeom>
-          <a:noFill/>
-        </p:spPr>
-        <p:txBody>
-          <a:bodyPr wrap="square">
-            <a:spAutoFit/>
-          </a:bodyPr>
-          <a:lstStyle/>
-          <a:p>
-            <a:pPr>
-              <a:spcAft>
-                <a:spcPts val="0"/>
-              </a:spcAft>
-            </a:pPr>
-            <a:r>
-              <a:rPr sz="1050" b="0">
-                <a:solidFill>
-                  <a:srgbClr val="33415C"/>
-                </a:solidFill>
-                <a:latin typeface="Segoe UI"/>
-              </a:rPr>
-              <a:t>forensics catches a pure digital render: no room tone</a:t>
-            </a:r>
-          </a:p>
-        </p:txBody>
-      </p:sp>
-      <p:sp>
-        <p:nvSpPr>
-          <p:cNvPr id="31" name="TextBox 30"/>
-          <p:cNvSpPr txBox="1"/>
-          <p:nvPr/>
-        </p:nvSpPr>
-        <p:spPr>
-          <a:xfrm>
-            <a:off x="9610344" y="5961888"/>
-            <a:ext cx="1993391" cy="251459"/>
-          </a:xfrm>
-          <a:prstGeom prst="rect">
-            <a:avLst/>
-          </a:prstGeom>
-          <a:noFill/>
-        </p:spPr>
-        <p:txBody>
-          <a:bodyPr wrap="square">
-            <a:spAutoFit/>
-          </a:bodyPr>
-          <a:lstStyle/>
-          <a:p>
-            <a:pPr algn="l">
-              <a:spcAft>
-                <a:spcPts val="0"/>
-              </a:spcAft>
-            </a:pPr>
-            <a:r>
-              <a:rPr sz="1050" b="1">
-                <a:solidFill>
-                  <a:srgbClr val="C88600"/>
-                </a:solidFill>
-                <a:latin typeface="Segoe UI"/>
-              </a:rPr>
-              <a:t>AMBER STEP-UP</a:t>
-            </a:r>
-          </a:p>
-        </p:txBody>
-      </p:sp>
-      <p:sp>
-        <p:nvSpPr>
-          <p:cNvPr id="32" name="Rectangle 31"/>
-          <p:cNvSpPr/>
-          <p:nvPr/>
-        </p:nvSpPr>
-        <p:spPr>
-          <a:xfrm>
-            <a:off x="640080" y="6222492"/>
-            <a:ext cx="10972800" cy="242316"/>
-          </a:xfrm>
-          <a:prstGeom prst="rect">
-            <a:avLst/>
-          </a:prstGeom>
-          <a:solidFill>
-            <a:srgbClr val="E7EEF6"/>
-          </a:solidFill>
-          <a:ln w="9525">
-            <a:solidFill>
-              <a:srgbClr val="D3DEEE"/>
-            </a:solidFill>
-          </a:ln>
-          <a:effectLst/>
-        </p:spPr>
-        <p:style>
-          <a:lnRef idx="1">
-            <a:schemeClr val="accent1"/>
-          </a:lnRef>
-          <a:fillRef idx="3">
-            <a:schemeClr val="accent1"/>
-          </a:fillRef>
-          <a:effectRef idx="2">
-            <a:schemeClr val="accent1"/>
-          </a:effectRef>
-          <a:fontRef idx="minor">
-            <a:schemeClr val="lt1"/>
-          </a:fontRef>
-        </p:style>
-        <p:txBody>
-          <a:bodyPr rtlCol="0" anchor="ctr"/>
-          <a:lstStyle/>
-          <a:p>
-            <a:pPr algn="ctr"/>
-          </a:p>
-        </p:txBody>
-      </p:sp>
-      <p:sp>
-        <p:nvSpPr>
-          <p:cNvPr id="33" name="TextBox 32"/>
-          <p:cNvSpPr txBox="1"/>
-          <p:nvPr/>
-        </p:nvSpPr>
-        <p:spPr>
-          <a:xfrm>
-            <a:off x="694944" y="6231636"/>
-            <a:ext cx="2084831" cy="251459"/>
-          </a:xfrm>
-          <a:prstGeom prst="rect">
-            <a:avLst/>
-          </a:prstGeom>
-          <a:noFill/>
-        </p:spPr>
-        <p:txBody>
-          <a:bodyPr wrap="square">
-            <a:spAutoFit/>
-          </a:bodyPr>
-          <a:lstStyle/>
-          <a:p>
-            <a:pPr>
-              <a:spcAft>
-                <a:spcPts val="0"/>
-              </a:spcAft>
-            </a:pPr>
-            <a:r>
-              <a:rPr sz="1100" b="1">
-                <a:solidFill>
-                  <a:srgbClr val="0F1B2D"/>
-                </a:solidFill>
-                <a:latin typeface="Segoe UI"/>
-              </a:rPr>
-              <a:t>D · Replay of the agent's real audio</a:t>
-            </a:r>
-          </a:p>
-        </p:txBody>
-      </p:sp>
-      <p:sp>
-        <p:nvSpPr>
-          <p:cNvPr id="34" name="TextBox 33"/>
-          <p:cNvSpPr txBox="1"/>
-          <p:nvPr/>
-        </p:nvSpPr>
-        <p:spPr>
-          <a:xfrm>
-            <a:off x="2935224" y="6231636"/>
-            <a:ext cx="3273552" cy="251459"/>
-          </a:xfrm>
-          <a:prstGeom prst="rect">
-            <a:avLst/>
-          </a:prstGeom>
-          <a:noFill/>
-        </p:spPr>
-        <p:txBody>
-          <a:bodyPr wrap="square">
-            <a:spAutoFit/>
-          </a:bodyPr>
-          <a:lstStyle/>
-          <a:p>
-            <a:pPr>
-              <a:spcAft>
-                <a:spcPts val="0"/>
-              </a:spcAft>
-            </a:pPr>
-            <a:r>
-              <a:rPr sz="1050" b="0">
-                <a:solidFill>
-                  <a:srgbClr val="33415C"/>
-                </a:solidFill>
-                <a:latin typeface="Segoe UI"/>
-              </a:rPr>
-              <a:t>Attacker plays the agent's own recording back.</a:t>
-            </a:r>
-          </a:p>
-        </p:txBody>
-      </p:sp>
-      <p:sp>
-        <p:nvSpPr>
-          <p:cNvPr id="35" name="TextBox 34"/>
-          <p:cNvSpPr txBox="1"/>
-          <p:nvPr/>
-        </p:nvSpPr>
-        <p:spPr>
-          <a:xfrm>
-            <a:off x="6318503" y="6231636"/>
-            <a:ext cx="3182112" cy="251459"/>
-          </a:xfrm>
-          <a:prstGeom prst="rect">
-            <a:avLst/>
-          </a:prstGeom>
-          <a:noFill/>
-        </p:spPr>
-        <p:txBody>
-          <a:bodyPr wrap="square">
-            <a:spAutoFit/>
-          </a:bodyPr>
-          <a:lstStyle/>
-          <a:p>
-            <a:pPr>
-              <a:spcAft>
-                <a:spcPts val="0"/>
-              </a:spcAft>
-            </a:pPr>
-            <a:r>
-              <a:rPr sz="1050" b="0">
-                <a:solidFill>
-                  <a:srgbClr val="33415C"/>
-                </a:solidFill>
-                <a:latin typeface="Segoe UI"/>
-              </a:rPr>
-              <a:t>everything else passes — content fingerprint catches identical audio re-sent</a:t>
-            </a:r>
-          </a:p>
-        </p:txBody>
-      </p:sp>
-      <p:sp>
-        <p:nvSpPr>
-          <p:cNvPr id="36" name="TextBox 35"/>
-          <p:cNvSpPr txBox="1"/>
-          <p:nvPr/>
-        </p:nvSpPr>
-        <p:spPr>
-          <a:xfrm>
-            <a:off x="9610344" y="6231636"/>
-            <a:ext cx="1993391" cy="251459"/>
-          </a:xfrm>
-          <a:prstGeom prst="rect">
-            <a:avLst/>
-          </a:prstGeom>
-          <a:noFill/>
-        </p:spPr>
-        <p:txBody>
-          <a:bodyPr wrap="square">
-            <a:spAutoFit/>
-          </a:bodyPr>
-          <a:lstStyle/>
-          <a:p>
-            <a:pPr algn="l">
-              <a:spcAft>
-                <a:spcPts val="0"/>
-              </a:spcAft>
-            </a:pPr>
-            <a:r>
-              <a:rPr sz="1050" b="1">
-                <a:solidFill>
-                  <a:srgbClr val="D6394B"/>
-                </a:solidFill>
-                <a:latin typeface="Segoe UI"/>
-              </a:rPr>
-              <a:t>RED HOLD</a:t>
+              <a:t> each layer covers another layer's blind spot — identity covers "wrong voice"; the segment check covers "right voice, machine words"; forensics covers "new unseen engine"; replay covers "it's just the recording".</a:t>
             </a:r>
           </a:p>
         </p:txBody>

</xml_diff>

<commit_message>
facts: correct impact figures against FTC 2024 Data Book and UK Finance primary sources
- FTC 2024 imposter scams: $800 median loss, $2.95B total (was $5,700 / $1.25B — unsourced)
- UK Finance full-year 2024 APP fraud: £450.7M (was £149M — not an official annual figure)
- call-volume arithmetic: 30k flagged calls per WEEK x 52 (was mislabeled per-year x 52)
- calibration: segment count 27 -> 28 (rows sum to 28)
- latency: p50 ~0.6s, p95 ~2.6s (p95 must be >= p50; earlier draft mislabeled)
- impact model recomputed: $16.6M exposure -> $9.3M prevented per bank per year
🤖 Generated with Codebuff
Co-Authored-By: Codebuff <noreply@codebuff.com>
</commit_message>
<xml_diff>
--- a/UNCLONE-day2-deck.pptx
+++ b/UNCLONE-day2-deck.pptx
@@ -5960,7 +5960,7 @@
                 </a:solidFill>
                 <a:latin typeface="Segoe UI"/>
               </a:rPr>
-              <a:t>Loss per voice scam:  </a:t>
+              <a:t>Median loss per imposter scam:  </a:t>
             </a:r>
             <a:r>
               <a:rPr sz="1800" b="0">
@@ -5969,7 +5969,7 @@
                 </a:solidFill>
                 <a:latin typeface="Segoe UI"/>
               </a:rPr>
-              <a:t>about $5,700 (about Rs 4.8 lakh, FTC 2024).</a:t>
+              <a:t>$800 (FTC 2024 Data Book). Bank-wire scams skew higher — this is the conservative anchor.</a:t>
             </a:r>
           </a:p>
           <a:p>
@@ -5994,7 +5994,7 @@
                 </a:solidFill>
                 <a:latin typeface="Segoe UI"/>
               </a:rPr>
-              <a:t>about 50 cents. The whole product story is this gap.</a:t>
+              <a:t>about 45 cents. The whole product story is this gap.</a:t>
             </a:r>
           </a:p>
           <a:p>
@@ -6019,7 +6019,7 @@
                 </a:solidFill>
                 <a:latin typeface="Segoe UI"/>
               </a:rPr>
-              <a:t>about $66 M/yr of prevented losses. That's the five-frame model: 1.56 M risky calls x 1.33 % scams x $5,700 x 80 % caught x 70 % stopped.</a:t>
+              <a:t>about $9.3 M/yr of prevented losses. That's the five-frame model: 1.56 M risky calls x 1.33 % scams x $800 x 80 % caught x 70 % stopped.</a:t>
             </a:r>
           </a:p>
           <a:p>
@@ -6124,7 +6124,7 @@
                 </a:solidFill>
                 <a:latin typeface="Segoe UI"/>
               </a:rPr>
-              <a:t>~100x</a:t>
+              <a:t>~900x</a:t>
             </a:r>
           </a:p>
           <a:p>
@@ -6135,7 +6135,7 @@
                 </a:solidFill>
                 <a:latin typeface="Segoe UI"/>
               </a:rPr>
-              <a:t>return on the checking cost: a 50-cent check that catches a $5,700 theft.</a:t>
+              <a:t>return on the checking cost: $0.87 per caught fraud (after false alarms) against an $800 median loss.</a:t>
             </a:r>
           </a:p>
         </p:txBody>
@@ -6169,7 +6169,7 @@
                 </a:solidFill>
                 <a:latin typeface="Segoe UI"/>
               </a:rPr>
-              <a:t>Latency: p50 &lt; 1 s per slice on the deployed build — inside the decision window.</a:t>
+              <a:t>Latency: p50 ~ 0.6 s per slice (p95 ~ 2.6 s) on the deployed build — inside the decision window.</a:t>
             </a:r>
           </a:p>
         </p:txBody>

</xml_diff>

<commit_message>
deck: honest forensics framing — two AI questions + two app checks, one hot segment, backstop not cover 🤖 Generated with Codebuff Co-Authored-By: Codebuff <noreply@codebuff.com>
</commit_message>
<xml_diff>
--- a/UNCLONE-day2-deck.pptx
+++ b/UNCLONE-day2-deck.pptx
@@ -4382,7 +4382,7 @@
                 </a:solidFill>
                 <a:latin typeface="Segoe UI"/>
               </a:rPr>
-              <a:t>One AI engine answers </a:t>
+              <a:t>Four checks per 6-second slice: </a:t>
             </a:r>
             <a:r>
               <a:rPr sz="1600" b="1">
@@ -4391,7 +4391,7 @@
                 </a:solidFill>
                 <a:latin typeface="Segoe UI"/>
               </a:rPr>
-              <a:t>four different questions</a:t>
+              <a:t>two AI-model questions</a:t>
             </a:r>
             <a:r>
               <a:rPr sz="1600" b="0">
@@ -4400,7 +4400,25 @@
                 </a:solidFill>
                 <a:latin typeface="Segoe UI"/>
               </a:rPr>
-              <a:t> about every 6-second slice. Each layer catches what the layer above it cannot see.</a:t>
+              <a:t> (identity, machine-voice) plus </a:t>
+            </a:r>
+            <a:r>
+              <a:rPr sz="1600" b="1">
+                <a:solidFill>
+                  <a:srgbClr val="0F1B2D"/>
+                </a:solidFill>
+                <a:latin typeface="Segoe UI"/>
+              </a:rPr>
+              <a:t>two app-side checks</a:t>
+            </a:r>
+            <a:r>
+              <a:rPr sz="1600" b="0">
+                <a:solidFill>
+                  <a:srgbClr val="33415C"/>
+                </a:solidFill>
+                <a:latin typeface="Segoe UI"/>
+              </a:rPr>
+              <a:t> (room-tone forensics, replay). Each targets a different failure mode.</a:t>
             </a:r>
           </a:p>
         </p:txBody>
@@ -5056,7 +5074,7 @@
                 </a:solidFill>
                 <a:latin typeface="Segoe UI"/>
               </a:rPr>
-              <a:t>but each 4-s segment scores 0.99 synthetic</a:t>
+              <a:t>but one 4-s segment can score 0.99 synthetic</a:t>
             </a:r>
           </a:p>
         </p:txBody>
@@ -5363,7 +5381,7 @@
                 </a:solidFill>
                 <a:latin typeface="Segoe UI"/>
               </a:rPr>
-              <a:t>Forensics: digital render → no room tone → artifact ≥ 0.85</a:t>
+              <a:t>Forensics clue (app-side): a digital render has no room tone → artifact ≥ 0.85 (PCM WAV only)</a:t>
             </a:r>
           </a:p>
         </p:txBody>
@@ -5713,7 +5731,7 @@
                 </a:solidFill>
                 <a:latin typeface="Segoe UI"/>
               </a:rPr>
-              <a:t> each layer covers another layer's blind spot — identity covers "wrong voice"; the segment check covers "right voice, machine words"; forensics covers "new unseen engine"; replay covers "it's just the recording".</a:t>
+              <a:t> each check targets a failure mode the others miss — identity catches "wrong voice"; the segment check catches "right voice, machine words"; forensics adds a best-effort room-tone backstop for new unseen engines; replay catches "it's just the recording".</a:t>
             </a:r>
           </a:p>
         </p:txBody>

</xml_diff>

<commit_message>
deck+impact: correct the ~900x/$0.87 catch-cost error to ~13x/$42, split Call 2 vs Call 3 rows, honest slide-2 audio source and slide-5 red/amber semantics
The $0.87 per caught fraud divided the per-call analysis cost by alert
precision, ignoring that the cost is paid on every analysed flagged call.
Correct denominator: ~94 analyses per catch -> ~$42 per caught fraud,
~$60 per prevented, ~13x return. Slide 3 row B described both Call 2
(identity gate) and Call 3 (hot-segment) as one case; they are now
separate rows with their real evidence. Slide 2 no longer implies live
phone-line capture (demo feeds recorded clips + live mic) and now renders
the previously-dropped chip descriptions. Slide 5 states attacks hold red
while errors fail safe amber. Slide 1 absolute softened. Same math fix
propagated to SCALE.md, REHEARSAL.md, scale.html and an erratum in the
v2 audit.

🤖 Generated with Codebuff
Co-Authored-By: Codebuff <noreply@codebuff.com>
</commit_message>
<xml_diff>
--- a/UNCLONE-day2-deck.pptx
+++ b/UNCLONE-day2-deck.pptx
@@ -3368,7 +3368,7 @@
                 </a:solidFill>
                 <a:latin typeface="Segoe UI"/>
               </a:rPr>
-              <a:t> of the bank's agent. You cannot tell. Nobody can.</a:t>
+              <a:t> of the bank's agent. You cannot tell — no amount of care on your side helps.</a:t>
             </a:r>
           </a:p>
           <a:p>
@@ -3672,7 +3672,7 @@
           <a:lstStyle/>
           <a:p>
             <a:r>
-              <a:rPr sz="1900" b="0">
+              <a:rPr sz="1550" b="0">
                 <a:solidFill>
                   <a:srgbClr val="33415C"/>
                 </a:solidFill>
@@ -3681,7 +3681,7 @@
               <a:t>An app on </a:t>
             </a:r>
             <a:r>
-              <a:rPr sz="1900" b="1">
+              <a:rPr sz="1550" b="1">
                 <a:solidFill>
                   <a:srgbClr val="0F1B2D"/>
                 </a:solidFill>
@@ -3690,22 +3690,31 @@
               <a:t>your</a:t>
             </a:r>
             <a:r>
-              <a:rPr sz="1900" b="0">
+              <a:rPr sz="1550" b="0">
                 <a:solidFill>
                   <a:srgbClr val="33415C"/>
                 </a:solidFill>
                 <a:latin typeface="Segoe UI"/>
               </a:rPr>
-              <a:t> side of the call listens and checks, every 6 seconds, </a:t>
-            </a:r>
-            <a:r>
-              <a:rPr sz="1900" b="1">
+              <a:t> side of the call checks the audio it is given — the demo runs recorded call clips and your live mic through it, every 6 seconds: </a:t>
+            </a:r>
+            <a:r>
+              <a:rPr sz="1550" b="1">
                 <a:solidFill>
                   <a:srgbClr val="0F1B2D"/>
                 </a:solidFill>
                 <a:latin typeface="Segoe UI"/>
               </a:rPr>
-              <a:t>is each slice the real enrolled agent — or a machine copying them?</a:t>
+              <a:t>is each slice the real enrolled agent, or a machine copying them?</a:t>
+            </a:r>
+            <a:r>
+              <a:rPr sz="1550" b="0">
+                <a:solidFill>
+                  <a:srgbClr val="33415C"/>
+                </a:solidFill>
+                <a:latin typeface="Segoe UI"/>
+              </a:rPr>
+              <a:t> (Capturing the phone line itself is the next version.)</a:t>
             </a:r>
           </a:p>
         </p:txBody>
@@ -3808,8 +3817,8 @@
         </p:nvSpPr>
         <p:spPr>
           <a:xfrm>
-            <a:off x="1252728" y="3081528"/>
-            <a:ext cx="2834640" cy="1051560"/>
+            <a:off x="1252728" y="3072384"/>
+            <a:ext cx="2834640" cy="1078992"/>
           </a:xfrm>
           <a:prstGeom prst="rect">
             <a:avLst/>
@@ -3823,13 +3832,29 @@
           <a:lstStyle/>
           <a:p>
             <a:r>
-              <a:rPr sz="1600" b="1">
+              <a:rPr sz="1500" b="1">
                 <a:solidFill>
                   <a:srgbClr val="0E9F6E"/>
                 </a:solidFill>
                 <a:latin typeface="Segoe UI"/>
               </a:rPr>
               <a:t>GREEN · GO</a:t>
+            </a:r>
+          </a:p>
+          <a:p>
+            <a:pPr>
+              <a:spcBef>
+                <a:spcPts val="300"/>
+              </a:spcBef>
+            </a:pPr>
+            <a:r>
+              <a:rPr sz="1050" b="0">
+                <a:solidFill>
+                  <a:srgbClr val="33415C"/>
+                </a:solidFill>
+                <a:latin typeface="Segoe UI"/>
+              </a:rPr>
+              <a:t>Real agent voice, no machine parts. Carry on with the call.</a:t>
             </a:r>
           </a:p>
         </p:txBody>
@@ -3932,8 +3957,8 @@
         </p:nvSpPr>
         <p:spPr>
           <a:xfrm>
-            <a:off x="4910328" y="3081528"/>
-            <a:ext cx="2834640" cy="1051560"/>
+            <a:off x="4910328" y="3072384"/>
+            <a:ext cx="2834640" cy="1078992"/>
           </a:xfrm>
           <a:prstGeom prst="rect">
             <a:avLst/>
@@ -3947,13 +3972,29 @@
           <a:lstStyle/>
           <a:p>
             <a:r>
-              <a:rPr sz="1600" b="1">
+              <a:rPr sz="1500" b="1">
                 <a:solidFill>
                   <a:srgbClr val="C88600"/>
                 </a:solidFill>
                 <a:latin typeface="Segoe UI"/>
               </a:rPr>
               <a:t>AMBER · DOUBLE-CHECK</a:t>
+            </a:r>
+          </a:p>
+          <a:p>
+            <a:pPr>
+              <a:spcBef>
+                <a:spcPts val="300"/>
+              </a:spcBef>
+            </a:pPr>
+            <a:r>
+              <a:rPr sz="1050" b="0">
+                <a:solidFill>
+                  <a:srgbClr val="33415C"/>
+                </a:solidFill>
+                <a:latin typeface="Segoe UI"/>
+              </a:rPr>
+              <a:t>Can't be sure. Confirm the payment in the app instead.</a:t>
             </a:r>
           </a:p>
         </p:txBody>
@@ -4056,8 +4097,8 @@
         </p:nvSpPr>
         <p:spPr>
           <a:xfrm>
-            <a:off x="8567928" y="3081528"/>
-            <a:ext cx="2880360" cy="1051560"/>
+            <a:off x="8567928" y="3072384"/>
+            <a:ext cx="2880360" cy="1078992"/>
           </a:xfrm>
           <a:prstGeom prst="rect">
             <a:avLst/>
@@ -4071,13 +4112,29 @@
           <a:lstStyle/>
           <a:p>
             <a:r>
-              <a:rPr sz="1600" b="1">
+              <a:rPr sz="1500" b="1">
                 <a:solidFill>
                   <a:srgbClr val="D6394B"/>
                 </a:solidFill>
                 <a:latin typeface="Segoe UI"/>
               </a:rPr>
               <a:t>RED · STOP</a:t>
+            </a:r>
+          </a:p>
+          <a:p>
+            <a:pPr>
+              <a:spcBef>
+                <a:spcPts val="300"/>
+              </a:spcBef>
+            </a:pPr>
+            <a:r>
+              <a:rPr sz="1050" b="0">
+                <a:solidFill>
+                  <a:srgbClr val="33415C"/>
+                </a:solidFill>
+                <a:latin typeface="Segoe UI"/>
+              </a:rPr>
+              <a:t>A fake was caught. The call is cut, the payment blocked.</a:t>
             </a:r>
           </a:p>
         </p:txBody>
@@ -4767,7 +4824,7 @@
                 </a:solidFill>
                 <a:latin typeface="Segoe UI"/>
               </a:rPr>
-              <a:t>(cheap TTS, no impersonation)</a:t>
+              <a:t>(cheap TTS — our Call 2)</a:t>
             </a:r>
           </a:p>
         </p:txBody>
@@ -4806,7 +4863,7 @@
                 </a:solidFill>
                 <a:latin typeface="Segoe UI"/>
               </a:rPr>
-              <a:t>similarity &lt; 0.53</a:t>
+              <a:t>similarity 0.13 « 0.53</a:t>
             </a:r>
           </a:p>
         </p:txBody>
@@ -5003,7 +5060,7 @@
                 </a:solidFill>
                 <a:latin typeface="Segoe UI"/>
               </a:rPr>
-              <a:t>Same tool, same-agent-timbre clone</a:t>
+              <a:t>Same-agent-timbre clone that fools identity</a:t>
             </a:r>
           </a:p>
           <a:p>
@@ -5019,7 +5076,7 @@
                 </a:solidFill>
                 <a:latin typeface="Segoe UI"/>
               </a:rPr>
-              <a:t>(our Call 2 / 3 scenario)</a:t>
+              <a:t>(0.77 — our Call 3)</a:t>
             </a:r>
           </a:p>
         </p:txBody>
@@ -5058,7 +5115,7 @@
                 </a:solidFill>
                 <a:latin typeface="Segoe UI"/>
               </a:rPr>
-              <a:t>Fingerprint MAY PASS — same timbre!</a:t>
+              <a:t>Identity PASSES, average says "real"</a:t>
             </a:r>
           </a:p>
           <a:p>
@@ -5074,7 +5131,7 @@
                 </a:solidFill>
                 <a:latin typeface="Segoe UI"/>
               </a:rPr>
-              <a:t>but one 4-s segment can score 0.99 synthetic</a:t>
+              <a:t>but one 4-s segment scores 0.99 synthetic</a:t>
             </a:r>
           </a:p>
         </p:txBody>
@@ -5168,7 +5225,7 @@
                 </a:solidFill>
                 <a:latin typeface="Segoe UI"/>
               </a:rPr>
-              <a:t>(average said "real")</a:t>
+              <a:t>(worst segment, not average)</a:t>
             </a:r>
           </a:p>
         </p:txBody>
@@ -6012,7 +6069,7 @@
                 </a:solidFill>
                 <a:latin typeface="Segoe UI"/>
               </a:rPr>
-              <a:t>about 45 cents. The whole product story is this gap.</a:t>
+              <a:t>about 45 cents — spent only on flagged calls, never on all traffic.</a:t>
             </a:r>
           </a:p>
           <a:p>
@@ -6142,18 +6199,18 @@
                 </a:solidFill>
                 <a:latin typeface="Segoe UI"/>
               </a:rPr>
-              <a:t>~900x</a:t>
-            </a:r>
-          </a:p>
-          <a:p>
-            <a:r>
-              <a:rPr sz="1400" b="0">
+              <a:t>~13x</a:t>
+            </a:r>
+          </a:p>
+          <a:p>
+            <a:r>
+              <a:rPr sz="1300" b="0">
                 <a:solidFill>
                   <a:srgbClr val="33415C"/>
                 </a:solidFill>
                 <a:latin typeface="Segoe UI"/>
               </a:rPr>
-              <a:t>return on the checking cost: $0.87 per caught fraud (after false alarms) against an $800 median loss.</a:t>
+              <a:t>return on the checking cost: about $700 K/yr of checks prevents ~$9.3 M of scams — roughly $42 per fraud caught, $60 per prevented, against an $800 median loss.</a:t>
             </a:r>
           </a:p>
         </p:txBody>
@@ -6556,7 +6613,25 @@
                 </a:solidFill>
                 <a:latin typeface="Segoe UI"/>
               </a:rPr>
-              <a:t>live now — 3 attacked calls + your own voice, every failure fails *safe* (amber, never auto-approve). Next — the phone-network version. We say which is which.</a:t>
+              <a:t>live now — 3 attacked calls + your own voice. Attacks are </a:t>
+            </a:r>
+            <a:r>
+              <a:rPr sz="1700" b="1">
+                <a:solidFill>
+                  <a:srgbClr val="0F1B2D"/>
+                </a:solidFill>
+                <a:latin typeface="Segoe UI"/>
+              </a:rPr>
+              <a:t>held</a:t>
+            </a:r>
+            <a:r>
+              <a:rPr sz="1700" b="0">
+                <a:solidFill>
+                  <a:srgbClr val="33415C"/>
+                </a:solidFill>
+                <a:latin typeface="Segoe UI"/>
+              </a:rPr>
+              <a:t> (red, call cut); errors and missing evidence fail safe (amber step-up) — neither ever auto-approves. Next — the phone-network version. We say which is which.</a:t>
             </a:r>
           </a:p>
           <a:p>

</xml_diff>